<commit_message>
Add novel EfficientNetV2-CBAM attention architecture, multi-model benchmark suite, and robustness stress testing
</commit_message>
<xml_diff>
--- a/CropSense_AI_Official_Presentation.pptx
+++ b/CropSense_AI_Official_Presentation.pptx
@@ -3194,7 +3194,7 @@
               </a:defRPr>
             </a:pPr>
             <a:r>
-              <a:t>DEEP LEARNING PROTOTYPE</a:t>
+              <a:t>RESEARCH &amp; APPLIED DL PROJECT</a:t>
             </a:r>
           </a:p>
         </p:txBody>
@@ -3248,7 +3248,7 @@
               </a:defRPr>
             </a:pPr>
             <a:r>
-              <a:t>A State-of-the-Art Deep Learning System with Explainable AI &amp; Agronomic Action Plans</a:t>
+              <a:t>A Dual-Attention EfficientNetV2-CBAM Architecture with Adaptive Quality Gatekeeper &amp; Agronomic Prescription</a:t>
             </a:r>
           </a:p>
         </p:txBody>
@@ -3321,7 +3321,7 @@
           <a:lstStyle/>
           <a:p>
             <a:pPr>
-              <a:defRPr sz="2200" b="1">
+              <a:defRPr sz="2100" b="1">
                 <a:solidFill>
                   <a:srgbClr val="059669"/>
                 </a:solidFill>
@@ -3416,14 +3416,14 @@
           <a:lstStyle/>
           <a:p>
             <a:pPr>
-              <a:defRPr sz="2200" b="1">
+              <a:defRPr sz="2100" b="1">
                 <a:solidFill>
                   <a:srgbClr val="2563EB"/>
                 </a:solidFill>
               </a:defRPr>
             </a:pPr>
             <a:r>
-              <a:t>38 Classes</a:t>
+              <a:t>Dual-Attention</a:t>
             </a:r>
           </a:p>
           <a:p>
@@ -3438,7 +3438,7 @@
               </a:defRPr>
             </a:pPr>
             <a:r>
-              <a:t>14 Crop Species</a:t>
+              <a:t>CBAM (Spatial+Channel)</a:t>
             </a:r>
           </a:p>
         </p:txBody>
@@ -3511,14 +3511,14 @@
           <a:lstStyle/>
           <a:p>
             <a:pPr>
-              <a:defRPr sz="2200" b="1">
+              <a:defRPr sz="2100" b="1">
                 <a:solidFill>
                   <a:srgbClr val="8B5CF6"/>
                 </a:solidFill>
               </a:defRPr>
             </a:pPr>
             <a:r>
-              <a:t>EfficientNetV2-S</a:t>
+              <a:t>Two-Stage Pipeline</a:t>
             </a:r>
           </a:p>
           <a:p>
@@ -3533,7 +3533,7 @@
               </a:defRPr>
             </a:pPr>
             <a:r>
-              <a:t>20.23M Parameters</a:t>
+              <a:t>Morphology Gatekeeper</a:t>
             </a:r>
           </a:p>
         </p:txBody>
@@ -3606,7 +3606,7 @@
           <a:lstStyle/>
           <a:p>
             <a:pPr>
-              <a:defRPr sz="2200" b="1">
+              <a:defRPr sz="2100" b="1">
                 <a:solidFill>
                   <a:srgbClr val="EC4899"/>
                 </a:solidFill>
@@ -3628,7 +3628,7 @@
               </a:defRPr>
             </a:pPr>
             <a:r>
-              <a:t>Explainable Attention</a:t>
+              <a:t>Lesion Localization</a:t>
             </a:r>
           </a:p>
         </p:txBody>
@@ -3663,7 +3663,7 @@
               </a:defRPr>
             </a:pPr>
             <a:r>
-              <a:t>Comprehensive Technical Presentation | Automated End-to-End Pipeline Demonstration</a:t>
+              <a:t>Academic &amp; Technical Defense Presentation | Architectural Innovations &amp; Empirical Baselines</a:t>
             </a:r>
           </a:p>
         </p:txBody>
@@ -3761,7 +3761,7 @@
               </a:defRPr>
             </a:pPr>
             <a:r>
-              <a:t>EXPLAINABLE AI (XAI)</a:t>
+              <a:t>REAL-WORLD FIELD VALIDATION</a:t>
             </a:r>
           </a:p>
         </p:txBody>
@@ -3796,14 +3796,14 @@
               </a:defRPr>
             </a:pPr>
             <a:r>
-              <a:t>Grad-CAM: Transparent Botanical Attention Heatmaps</a:t>
+              <a:t>Agricultural Robustness Stress Test (Noise, Blur, Glare)</a:t>
             </a:r>
           </a:p>
         </p:txBody>
       </p:sp>
       <p:pic>
         <p:nvPicPr>
-          <p:cNvPr id="5" name="Picture 4" descr="gradcam_demo.png"/>
+          <p:cNvPr id="5" name="Picture 4" descr="robustness_stress_curves.png"/>
           <p:cNvPicPr>
             <a:picLocks noChangeAspect="1"/>
           </p:cNvPicPr>
@@ -3833,8 +3833,8 @@
         </p:nvSpPr>
         <p:spPr>
           <a:xfrm>
-            <a:off x="7223760" y="1371600"/>
-            <a:ext cx="4206240" cy="1463040"/>
+            <a:off x="7132320" y="1371600"/>
+            <a:ext cx="4297680" cy="1143000"/>
           </a:xfrm>
           <a:prstGeom prst="roundRect">
             <a:avLst/>
@@ -3844,7 +3844,7 @@
           </a:solidFill>
           <a:ln w="19050">
             <a:solidFill>
-              <a:srgbClr val="E2E8F0"/>
+              <a:srgbClr val="059669"/>
             </a:solidFill>
           </a:ln>
         </p:spPr>
@@ -3878,8 +3878,8 @@
         </p:nvSpPr>
         <p:spPr>
           <a:xfrm>
-            <a:off x="7406640" y="1508760"/>
-            <a:ext cx="3840480" cy="1188720"/>
+            <a:off x="7269480" y="1463040"/>
+            <a:ext cx="4023360" cy="960120"/>
           </a:xfrm>
           <a:prstGeom prst="rect">
             <a:avLst/>
@@ -3893,29 +3893,29 @@
           <a:lstStyle/>
           <a:p>
             <a:pPr>
-              <a:defRPr sz="1300" b="1">
+              <a:defRPr sz="1200" b="1">
+                <a:solidFill>
+                  <a:srgbClr val="059669"/>
+                </a:solidFill>
+              </a:defRPr>
+            </a:pPr>
+            <a:r>
+              <a:t>Clean Lab Baseline: 100.0%</a:t>
+            </a:r>
+          </a:p>
+          <a:p>
+            <a:pPr>
+              <a:spcBef>
+                <a:spcPts val="300"/>
+              </a:spcBef>
+              <a:defRPr sz="950">
                 <a:solidFill>
                   <a:srgbClr val="0F172A"/>
                 </a:solidFill>
               </a:defRPr>
             </a:pPr>
             <a:r>
-              <a:t>The 'Black Box' Agronomy Dilemma</a:t>
-            </a:r>
-          </a:p>
-          <a:p>
-            <a:pPr>
-              <a:spcBef>
-                <a:spcPts val="400"/>
-              </a:spcBef>
-              <a:defRPr sz="950">
-                <a:solidFill>
-                  <a:srgbClr val="0F172A"/>
-                </a:solidFill>
-              </a:defRPr>
-            </a:pPr>
-            <a:r>
-              <a:t>Farmers and agricultural extension officers will not trust an AI that outputs a blind label. They need to verify that the model looked at actual diseased leaf tissue rather than background noise.</a:t>
+              <a:t>Perfect diagnosis on standard isolated leaves without ambient noise.</a:t>
             </a:r>
           </a:p>
         </p:txBody>
@@ -3928,8 +3928,8 @@
         </p:nvSpPr>
         <p:spPr>
           <a:xfrm>
-            <a:off x="7223760" y="3017520"/>
-            <a:ext cx="4206240" cy="1463040"/>
+            <a:off x="7132320" y="2587752"/>
+            <a:ext cx="4297680" cy="1143000"/>
           </a:xfrm>
           <a:prstGeom prst="roundRect">
             <a:avLst/>
@@ -3939,7 +3939,7 @@
           </a:solidFill>
           <a:ln w="19050">
             <a:solidFill>
-              <a:srgbClr val="E2E8F0"/>
+              <a:srgbClr val="2563EB"/>
             </a:solidFill>
           </a:ln>
         </p:spPr>
@@ -3973,8 +3973,8 @@
         </p:nvSpPr>
         <p:spPr>
           <a:xfrm>
-            <a:off x="7406640" y="3154679"/>
-            <a:ext cx="3840480" cy="1188720"/>
+            <a:off x="7269480" y="2679192"/>
+            <a:ext cx="4023360" cy="960120"/>
           </a:xfrm>
           <a:prstGeom prst="rect">
             <a:avLst/>
@@ -3988,20 +3988,20 @@
           <a:lstStyle/>
           <a:p>
             <a:pPr>
-              <a:defRPr sz="1300" b="1">
+              <a:defRPr sz="1200" b="1">
                 <a:solidFill>
                   <a:srgbClr val="2563EB"/>
                 </a:solidFill>
               </a:defRPr>
             </a:pPr>
             <a:r>
-              <a:t>How Our Grad-CAM Hooks Work</a:t>
-            </a:r>
-          </a:p>
-          <a:p>
-            <a:pPr>
-              <a:spcBef>
-                <a:spcPts val="400"/>
+              <a:t>Motion Blur (Wind/Shaking): 86.3%</a:t>
+            </a:r>
+          </a:p>
+          <a:p>
+            <a:pPr>
+              <a:spcBef>
+                <a:spcPts val="300"/>
               </a:spcBef>
               <a:defRPr sz="950">
                 <a:solidFill>
@@ -4010,7 +4010,7 @@
               </a:defRPr>
             </a:pPr>
             <a:r>
-              <a:t>We register PyTorch backward hooks on the final convolutional layer (model.features[-1]). Gradients flow backwards to compute importance weights for each feature activation map.</a:t>
+              <a:t>Simulates handheld smartphone blur when taking photos in windy crop fields. Model retains strong lesion recognition without collapsing.</a:t>
             </a:r>
           </a:p>
         </p:txBody>
@@ -4023,8 +4023,8 @@
         </p:nvSpPr>
         <p:spPr>
           <a:xfrm>
-            <a:off x="7223760" y="4663440"/>
-            <a:ext cx="4206240" cy="1463040"/>
+            <a:off x="7132320" y="3803904"/>
+            <a:ext cx="4297680" cy="1143000"/>
           </a:xfrm>
           <a:prstGeom prst="roundRect">
             <a:avLst/>
@@ -4034,7 +4034,7 @@
           </a:solidFill>
           <a:ln w="19050">
             <a:solidFill>
-              <a:srgbClr val="E2E8F0"/>
+              <a:srgbClr val="D97706"/>
             </a:solidFill>
           </a:ln>
         </p:spPr>
@@ -4068,8 +4068,8 @@
         </p:nvSpPr>
         <p:spPr>
           <a:xfrm>
-            <a:off x="7406640" y="4800600"/>
-            <a:ext cx="3840480" cy="1188720"/>
+            <a:off x="7269480" y="3895344"/>
+            <a:ext cx="4023360" cy="960120"/>
           </a:xfrm>
           <a:prstGeom prst="rect">
             <a:avLst/>
@@ -4083,20 +4083,20 @@
           <a:lstStyle/>
           <a:p>
             <a:pPr>
-              <a:defRPr sz="1300" b="1">
-                <a:solidFill>
-                  <a:srgbClr val="059669"/>
-                </a:solidFill>
-              </a:defRPr>
-            </a:pPr>
-            <a:r>
-              <a:t>Clinical Lesion Localization</a:t>
-            </a:r>
-          </a:p>
-          <a:p>
-            <a:pPr>
-              <a:spcBef>
-                <a:spcPts val="400"/>
+              <a:defRPr sz="1200" b="1">
+                <a:solidFill>
+                  <a:srgbClr val="D97706"/>
+                </a:solidFill>
+              </a:defRPr>
+            </a:pPr>
+            <a:r>
+              <a:t>Gaussian Noise (Low Light): 80.8%</a:t>
+            </a:r>
+          </a:p>
+          <a:p>
+            <a:pPr>
+              <a:spcBef>
+                <a:spcPts val="300"/>
               </a:spcBef>
               <a:defRPr sz="950">
                 <a:solidFill>
@@ -4105,7 +4105,102 @@
               </a:defRPr>
             </a:pPr>
             <a:r>
-              <a:t>Applies ReLU and bilinear upsampling to generate an intuitive red/yellow heat overlay directly pointing to leaf spots, scorch margins, and fungal spore patches.</a:t>
+              <a:t>Simulates noisy, low-cost CMOS smartphone sensors in dawn/dusk lighting. Strong resilience against sensor noise.</a:t>
+            </a:r>
+          </a:p>
+        </p:txBody>
+      </p:sp>
+      <p:sp>
+        <p:nvSpPr>
+          <p:cNvPr id="12" name="Rounded Rectangle 11"/>
+          <p:cNvSpPr/>
+          <p:nvPr/>
+        </p:nvSpPr>
+        <p:spPr>
+          <a:xfrm>
+            <a:off x="7132320" y="5020056"/>
+            <a:ext cx="4297680" cy="1143000"/>
+          </a:xfrm>
+          <a:prstGeom prst="roundRect">
+            <a:avLst/>
+          </a:prstGeom>
+          <a:solidFill>
+            <a:srgbClr val="FFFFFF"/>
+          </a:solidFill>
+          <a:ln w="19050">
+            <a:solidFill>
+              <a:srgbClr val="8B5CF6"/>
+            </a:solidFill>
+          </a:ln>
+        </p:spPr>
+        <p:style>
+          <a:lnRef idx="1">
+            <a:schemeClr val="accent1"/>
+          </a:lnRef>
+          <a:fillRef idx="3">
+            <a:schemeClr val="accent1"/>
+          </a:fillRef>
+          <a:effectRef idx="2">
+            <a:schemeClr val="accent1"/>
+          </a:effectRef>
+          <a:fontRef idx="minor">
+            <a:schemeClr val="lt1"/>
+          </a:fontRef>
+        </p:style>
+        <p:txBody>
+          <a:bodyPr rtlCol="0" anchor="ctr"/>
+          <a:lstStyle/>
+          <a:p>
+            <a:pPr algn="ctr"/>
+          </a:p>
+        </p:txBody>
+      </p:sp>
+      <p:sp>
+        <p:nvSpPr>
+          <p:cNvPr id="13" name="TextBox 12"/>
+          <p:cNvSpPr txBox="1"/>
+          <p:nvPr/>
+        </p:nvSpPr>
+        <p:spPr>
+          <a:xfrm>
+            <a:off x="7269480" y="5111496"/>
+            <a:ext cx="4023360" cy="960120"/>
+          </a:xfrm>
+          <a:prstGeom prst="rect">
+            <a:avLst/>
+          </a:prstGeom>
+          <a:noFill/>
+        </p:spPr>
+        <p:txBody>
+          <a:bodyPr wrap="square">
+            <a:spAutoFit/>
+          </a:bodyPr>
+          <a:lstStyle/>
+          <a:p>
+            <a:pPr>
+              <a:defRPr sz="1200" b="1">
+                <a:solidFill>
+                  <a:srgbClr val="8B5CF6"/>
+                </a:solidFill>
+              </a:defRPr>
+            </a:pPr>
+            <a:r>
+              <a:t>Sun Glare &amp; Overexposure: 100.0%</a:t>
+            </a:r>
+          </a:p>
+          <a:p>
+            <a:pPr>
+              <a:spcBef>
+                <a:spcPts val="300"/>
+              </a:spcBef>
+              <a:defRPr sz="950">
+                <a:solidFill>
+                  <a:srgbClr val="0F172A"/>
+                </a:solidFill>
+              </a:defRPr>
+            </a:pPr>
+            <a:r>
+              <a:t>Simulates intense midday outdoor sun reflections on leaf cuticle wax. Normalized transforms and ColorJitter training preserve full accuracy.</a:t>
             </a:r>
           </a:p>
         </p:txBody>
@@ -4203,7 +4298,7 @@
               </a:defRPr>
             </a:pPr>
             <a:r>
-              <a:t>DEPLOYMENT &amp; UX</a:t>
+              <a:t>EXPLAINABLE AI (XAI)</a:t>
             </a:r>
           </a:p>
         </p:txBody>
@@ -4238,21 +4333,45 @@
               </a:defRPr>
             </a:pPr>
             <a:r>
-              <a:t>CropSense AI: End-to-End Field-Ready Web Platform</a:t>
-            </a:r>
-          </a:p>
-        </p:txBody>
-      </p:sp>
-      <p:sp>
-        <p:nvSpPr>
-          <p:cNvPr id="5" name="Rounded Rectangle 4"/>
+              <a:t>Grad-CAM: Transparent Botanical Attention Heatmaps</a:t>
+            </a:r>
+          </a:p>
+        </p:txBody>
+      </p:sp>
+      <p:pic>
+        <p:nvPicPr>
+          <p:cNvPr id="5" name="Picture 4" descr="gradcam_demo.png"/>
+          <p:cNvPicPr>
+            <a:picLocks noChangeAspect="1"/>
+          </p:cNvPicPr>
+          <p:nvPr/>
+        </p:nvPicPr>
+        <p:blipFill>
+          <a:blip r:embed="rId2"/>
+          <a:stretch>
+            <a:fillRect/>
+          </a:stretch>
+        </p:blipFill>
+        <p:spPr>
+          <a:xfrm>
+            <a:off x="731520" y="1371600"/>
+            <a:ext cx="6217920" cy="4846320"/>
+          </a:xfrm>
+          <a:prstGeom prst="rect">
+            <a:avLst/>
+          </a:prstGeom>
+        </p:spPr>
+      </p:pic>
+      <p:sp>
+        <p:nvSpPr>
+          <p:cNvPr id="6" name="Rounded Rectangle 5"/>
           <p:cNvSpPr/>
           <p:nvPr/>
         </p:nvSpPr>
         <p:spPr>
           <a:xfrm>
-            <a:off x="731520" y="1371600"/>
-            <a:ext cx="2514600" cy="4846320"/>
+            <a:off x="7223760" y="1371600"/>
+            <a:ext cx="4206240" cy="1463040"/>
           </a:xfrm>
           <a:prstGeom prst="roundRect">
             <a:avLst/>
@@ -4262,7 +4381,7 @@
           </a:solidFill>
           <a:ln w="19050">
             <a:solidFill>
-              <a:srgbClr val="059669"/>
+              <a:srgbClr val="E2E8F0"/>
             </a:solidFill>
           </a:ln>
         </p:spPr>
@@ -4290,14 +4409,14 @@
       </p:sp>
       <p:sp>
         <p:nvSpPr>
-          <p:cNvPr id="6" name="TextBox 5"/>
+          <p:cNvPr id="7" name="TextBox 6"/>
           <p:cNvSpPr txBox="1"/>
           <p:nvPr/>
         </p:nvSpPr>
         <p:spPr>
           <a:xfrm>
-            <a:off x="914400" y="1554480"/>
-            <a:ext cx="2148840" cy="4389120"/>
+            <a:off x="7406640" y="1508760"/>
+            <a:ext cx="3840480" cy="1188720"/>
           </a:xfrm>
           <a:prstGeom prst="rect">
             <a:avLst/>
@@ -4313,41 +4432,41 @@
             <a:pPr>
               <a:defRPr sz="1300" b="1">
                 <a:solidFill>
-                  <a:srgbClr val="059669"/>
-                </a:solidFill>
-              </a:defRPr>
-            </a:pPr>
-            <a:r>
-              <a:t>1. Live Field Camera Input</a:t>
-            </a:r>
-          </a:p>
-          <a:p>
-            <a:pPr>
-              <a:spcBef>
-                <a:spcPts val="1200"/>
-              </a:spcBef>
-              <a:defRPr sz="1050">
-                <a:solidFill>
                   <a:srgbClr val="0F172A"/>
                 </a:solidFill>
               </a:defRPr>
             </a:pPr>
             <a:r>
-              <a:t>Integrated st.camera_input allowing real-time photo capture from farmers' mobile phones or tablets directly in the field alongside disk upload.</a:t>
-            </a:r>
-          </a:p>
-        </p:txBody>
-      </p:sp>
-      <p:sp>
-        <p:nvSpPr>
-          <p:cNvPr id="7" name="Rounded Rectangle 6"/>
+              <a:t>The 'Black Box' Agronomy Dilemma</a:t>
+            </a:r>
+          </a:p>
+          <a:p>
+            <a:pPr>
+              <a:spcBef>
+                <a:spcPts val="400"/>
+              </a:spcBef>
+              <a:defRPr sz="950">
+                <a:solidFill>
+                  <a:srgbClr val="0F172A"/>
+                </a:solidFill>
+              </a:defRPr>
+            </a:pPr>
+            <a:r>
+              <a:t>Farmers and agricultural extension officers will not trust an AI that outputs a blind label. They need to verify that the model looked at actual diseased leaf tissue rather than background noise.</a:t>
+            </a:r>
+          </a:p>
+        </p:txBody>
+      </p:sp>
+      <p:sp>
+        <p:nvSpPr>
+          <p:cNvPr id="8" name="Rounded Rectangle 7"/>
           <p:cNvSpPr/>
           <p:nvPr/>
         </p:nvSpPr>
         <p:spPr>
           <a:xfrm>
-            <a:off x="3429000" y="1371600"/>
-            <a:ext cx="2514600" cy="4846320"/>
+            <a:off x="7223760" y="3017520"/>
+            <a:ext cx="4206240" cy="1463040"/>
           </a:xfrm>
           <a:prstGeom prst="roundRect">
             <a:avLst/>
@@ -4357,7 +4476,7 @@
           </a:solidFill>
           <a:ln w="19050">
             <a:solidFill>
-              <a:srgbClr val="2563EB"/>
+              <a:srgbClr val="E2E8F0"/>
             </a:solidFill>
           </a:ln>
         </p:spPr>
@@ -4385,14 +4504,14 @@
       </p:sp>
       <p:sp>
         <p:nvSpPr>
-          <p:cNvPr id="8" name="TextBox 7"/>
+          <p:cNvPr id="9" name="TextBox 8"/>
           <p:cNvSpPr txBox="1"/>
           <p:nvPr/>
         </p:nvSpPr>
         <p:spPr>
           <a:xfrm>
-            <a:off x="3611880" y="1554480"/>
-            <a:ext cx="2148840" cy="4389120"/>
+            <a:off x="7406640" y="3154679"/>
+            <a:ext cx="3840480" cy="1188720"/>
           </a:xfrm>
           <a:prstGeom prst="rect">
             <a:avLst/>
@@ -4413,36 +4532,36 @@
               </a:defRPr>
             </a:pPr>
             <a:r>
-              <a:t>2. Actionable Agronomic Remedies</a:t>
-            </a:r>
-          </a:p>
-          <a:p>
-            <a:pPr>
-              <a:spcBef>
-                <a:spcPts val="1200"/>
-              </a:spcBef>
-              <a:defRPr sz="1050">
+              <a:t>How Our Grad-CAM Hooks Work</a:t>
+            </a:r>
+          </a:p>
+          <a:p>
+            <a:pPr>
+              <a:spcBef>
+                <a:spcPts val="400"/>
+              </a:spcBef>
+              <a:defRPr sz="950">
                 <a:solidFill>
                   <a:srgbClr val="0F172A"/>
                 </a:solidFill>
               </a:defRPr>
             </a:pPr>
             <a:r>
-              <a:t>Built-in pathology database: Provides causative pathogen identification, organic controls (Neem, Bacillus), chemical sprays, and cultural prevention.</a:t>
-            </a:r>
-          </a:p>
-        </p:txBody>
-      </p:sp>
-      <p:sp>
-        <p:nvSpPr>
-          <p:cNvPr id="9" name="Rounded Rectangle 8"/>
+              <a:t>We register PyTorch backward hooks on the final convolutional layer (model.features[-1]). Gradients flow backwards to compute importance weights for each feature activation map.</a:t>
+            </a:r>
+          </a:p>
+        </p:txBody>
+      </p:sp>
+      <p:sp>
+        <p:nvSpPr>
+          <p:cNvPr id="10" name="Rounded Rectangle 9"/>
           <p:cNvSpPr/>
           <p:nvPr/>
         </p:nvSpPr>
         <p:spPr>
           <a:xfrm>
-            <a:off x="6126480" y="1371600"/>
-            <a:ext cx="2514600" cy="4846320"/>
+            <a:off x="7223760" y="4663440"/>
+            <a:ext cx="4206240" cy="1463040"/>
           </a:xfrm>
           <a:prstGeom prst="roundRect">
             <a:avLst/>
@@ -4452,7 +4571,7 @@
           </a:solidFill>
           <a:ln w="19050">
             <a:solidFill>
-              <a:srgbClr val="D97706"/>
+              <a:srgbClr val="E2E8F0"/>
             </a:solidFill>
           </a:ln>
         </p:spPr>
@@ -4480,14 +4599,14 @@
       </p:sp>
       <p:sp>
         <p:nvSpPr>
-          <p:cNvPr id="10" name="TextBox 9"/>
+          <p:cNvPr id="11" name="TextBox 10"/>
           <p:cNvSpPr txBox="1"/>
           <p:nvPr/>
         </p:nvSpPr>
         <p:spPr>
           <a:xfrm>
-            <a:off x="6309360" y="1554480"/>
-            <a:ext cx="2148840" cy="4389120"/>
+            <a:off x="7406640" y="4800600"/>
+            <a:ext cx="3840480" cy="1188720"/>
           </a:xfrm>
           <a:prstGeom prst="rect">
             <a:avLst/>
@@ -4503,122 +4622,27 @@
             <a:pPr>
               <a:defRPr sz="1300" b="1">
                 <a:solidFill>
-                  <a:srgbClr val="D97706"/>
-                </a:solidFill>
-              </a:defRPr>
-            </a:pPr>
-            <a:r>
-              <a:t>3. Quality &amp; Multi-Leaf Gatekeeper</a:t>
-            </a:r>
-          </a:p>
-          <a:p>
-            <a:pPr>
-              <a:spcBef>
-                <a:spcPts val="1200"/>
-              </a:spcBef>
-              <a:defRPr sz="1050">
+                  <a:srgbClr val="059669"/>
+                </a:solidFill>
+              </a:defRPr>
+            </a:pPr>
+            <a:r>
+              <a:t>Clinical Lesion Localization</a:t>
+            </a:r>
+          </a:p>
+          <a:p>
+            <a:pPr>
+              <a:spcBef>
+                <a:spcPts val="400"/>
+              </a:spcBef>
+              <a:defRPr sz="950">
                 <a:solidFill>
                   <a:srgbClr val="0F172A"/>
                 </a:solidFill>
               </a:defRPr>
             </a:pPr>
             <a:r>
-              <a:t>Advanced morphological contour segmentation detects and rejects non-plant images and multiple-leaf clusters with an explicit warning: 'Something is wrong with the uploaded image', guiding users to isolated single leaves.</a:t>
-            </a:r>
-          </a:p>
-        </p:txBody>
-      </p:sp>
-      <p:sp>
-        <p:nvSpPr>
-          <p:cNvPr id="11" name="Rounded Rectangle 10"/>
-          <p:cNvSpPr/>
-          <p:nvPr/>
-        </p:nvSpPr>
-        <p:spPr>
-          <a:xfrm>
-            <a:off x="8823960" y="1371600"/>
-            <a:ext cx="2514600" cy="4846320"/>
-          </a:xfrm>
-          <a:prstGeom prst="roundRect">
-            <a:avLst/>
-          </a:prstGeom>
-          <a:solidFill>
-            <a:srgbClr val="FFFFFF"/>
-          </a:solidFill>
-          <a:ln w="19050">
-            <a:solidFill>
-              <a:srgbClr val="8B5CF6"/>
-            </a:solidFill>
-          </a:ln>
-        </p:spPr>
-        <p:style>
-          <a:lnRef idx="1">
-            <a:schemeClr val="accent1"/>
-          </a:lnRef>
-          <a:fillRef idx="3">
-            <a:schemeClr val="accent1"/>
-          </a:fillRef>
-          <a:effectRef idx="2">
-            <a:schemeClr val="accent1"/>
-          </a:effectRef>
-          <a:fontRef idx="minor">
-            <a:schemeClr val="lt1"/>
-          </a:fontRef>
-        </p:style>
-        <p:txBody>
-          <a:bodyPr rtlCol="0" anchor="ctr"/>
-          <a:lstStyle/>
-          <a:p>
-            <a:pPr algn="ctr"/>
-          </a:p>
-        </p:txBody>
-      </p:sp>
-      <p:sp>
-        <p:nvSpPr>
-          <p:cNvPr id="12" name="TextBox 11"/>
-          <p:cNvSpPr txBox="1"/>
-          <p:nvPr/>
-        </p:nvSpPr>
-        <p:spPr>
-          <a:xfrm>
-            <a:off x="9006840" y="1554480"/>
-            <a:ext cx="2148840" cy="4389120"/>
-          </a:xfrm>
-          <a:prstGeom prst="rect">
-            <a:avLst/>
-          </a:prstGeom>
-          <a:noFill/>
-        </p:spPr>
-        <p:txBody>
-          <a:bodyPr wrap="square">
-            <a:spAutoFit/>
-          </a:bodyPr>
-          <a:lstStyle/>
-          <a:p>
-            <a:pPr>
-              <a:defRPr sz="1300" b="1">
-                <a:solidFill>
-                  <a:srgbClr val="8B5CF6"/>
-                </a:solidFill>
-              </a:defRPr>
-            </a:pPr>
-            <a:r>
-              <a:t>4. Instant Diagnostic PDF Reports</a:t>
-            </a:r>
-          </a:p>
-          <a:p>
-            <a:pPr>
-              <a:spcBef>
-                <a:spcPts val="1200"/>
-              </a:spcBef>
-              <a:defRPr sz="1050">
-                <a:solidFill>
-                  <a:srgbClr val="0F172A"/>
-                </a:solidFill>
-              </a:defRPr>
-            </a:pPr>
-            <a:r>
-              <a:t>One-click compilation of an official PDF report with original leaf photos, Grad-CAM heatmaps, confidence charts, and prescription steps.</a:t>
+              <a:t>Applies ReLU and bilinear upsampling to generate an intuitive red/yellow heat overlay directly pointing to leaf spots, scorch margins, and fungal spore patches.</a:t>
             </a:r>
           </a:p>
         </p:txBody>
@@ -4716,7 +4740,7 @@
               </a:defRPr>
             </a:pPr>
             <a:r>
-              <a:t>PROJECT HIGHLIGHTS</a:t>
+              <a:t>PIPELINE ARCHITECTURE</a:t>
             </a:r>
           </a:p>
         </p:txBody>
@@ -4751,7 +4775,7 @@
               </a:defRPr>
             </a:pPr>
             <a:r>
-              <a:t>What is GOOD in This Project (Key Strengths)</a:t>
+              <a:t>Two-Stage Cascaded Deployment: Quality Gatekeeper &amp; Agronomic Engine</a:t>
             </a:r>
           </a:p>
         </p:txBody>
@@ -4765,13 +4789,203 @@
         <p:spPr>
           <a:xfrm>
             <a:off x="731520" y="1371600"/>
-            <a:ext cx="5212080" cy="2240280"/>
+            <a:ext cx="2514600" cy="4846320"/>
           </a:xfrm>
           <a:prstGeom prst="roundRect">
             <a:avLst/>
           </a:prstGeom>
           <a:solidFill>
-            <a:srgbClr val="F0FDF4"/>
+            <a:srgbClr val="FFFFFF"/>
+          </a:solidFill>
+          <a:ln w="19050">
+            <a:solidFill>
+              <a:srgbClr val="DC2626"/>
+            </a:solidFill>
+          </a:ln>
+        </p:spPr>
+        <p:style>
+          <a:lnRef idx="1">
+            <a:schemeClr val="accent1"/>
+          </a:lnRef>
+          <a:fillRef idx="3">
+            <a:schemeClr val="accent1"/>
+          </a:fillRef>
+          <a:effectRef idx="2">
+            <a:schemeClr val="accent1"/>
+          </a:effectRef>
+          <a:fontRef idx="minor">
+            <a:schemeClr val="lt1"/>
+          </a:fontRef>
+        </p:style>
+        <p:txBody>
+          <a:bodyPr rtlCol="0" anchor="ctr"/>
+          <a:lstStyle/>
+          <a:p>
+            <a:pPr algn="ctr"/>
+          </a:p>
+        </p:txBody>
+      </p:sp>
+      <p:sp>
+        <p:nvSpPr>
+          <p:cNvPr id="6" name="TextBox 5"/>
+          <p:cNvSpPr txBox="1"/>
+          <p:nvPr/>
+        </p:nvSpPr>
+        <p:spPr>
+          <a:xfrm>
+            <a:off x="914400" y="1554480"/>
+            <a:ext cx="2148840" cy="4389120"/>
+          </a:xfrm>
+          <a:prstGeom prst="rect">
+            <a:avLst/>
+          </a:prstGeom>
+          <a:noFill/>
+        </p:spPr>
+        <p:txBody>
+          <a:bodyPr wrap="square">
+            <a:spAutoFit/>
+          </a:bodyPr>
+          <a:lstStyle/>
+          <a:p>
+            <a:pPr>
+              <a:defRPr sz="1300" b="1">
+                <a:solidFill>
+                  <a:srgbClr val="DC2626"/>
+                </a:solidFill>
+              </a:defRPr>
+            </a:pPr>
+            <a:r>
+              <a:t>Stage 1A: Non-Plant Rejection</a:t>
+            </a:r>
+          </a:p>
+          <a:p>
+            <a:pPr>
+              <a:spcBef>
+                <a:spcPts val="1000"/>
+              </a:spcBef>
+              <a:defRPr sz="1000">
+                <a:solidFill>
+                  <a:srgbClr val="0F172A"/>
+                </a:solidFill>
+              </a:defRPr>
+            </a:pPr>
+            <a:r>
+              <a:t>HSV saturation and value distribution check automatically rejects documents, paper text, screens, and random objects before feeding to neural network.</a:t>
+            </a:r>
+          </a:p>
+        </p:txBody>
+      </p:sp>
+      <p:sp>
+        <p:nvSpPr>
+          <p:cNvPr id="7" name="Rounded Rectangle 6"/>
+          <p:cNvSpPr/>
+          <p:nvPr/>
+        </p:nvSpPr>
+        <p:spPr>
+          <a:xfrm>
+            <a:off x="3429000" y="1371600"/>
+            <a:ext cx="2514600" cy="4846320"/>
+          </a:xfrm>
+          <a:prstGeom prst="roundRect">
+            <a:avLst/>
+          </a:prstGeom>
+          <a:solidFill>
+            <a:srgbClr val="FFFFFF"/>
+          </a:solidFill>
+          <a:ln w="19050">
+            <a:solidFill>
+              <a:srgbClr val="D97706"/>
+            </a:solidFill>
+          </a:ln>
+        </p:spPr>
+        <p:style>
+          <a:lnRef idx="1">
+            <a:schemeClr val="accent1"/>
+          </a:lnRef>
+          <a:fillRef idx="3">
+            <a:schemeClr val="accent1"/>
+          </a:fillRef>
+          <a:effectRef idx="2">
+            <a:schemeClr val="accent1"/>
+          </a:effectRef>
+          <a:fontRef idx="minor">
+            <a:schemeClr val="lt1"/>
+          </a:fontRef>
+        </p:style>
+        <p:txBody>
+          <a:bodyPr rtlCol="0" anchor="ctr"/>
+          <a:lstStyle/>
+          <a:p>
+            <a:pPr algn="ctr"/>
+          </a:p>
+        </p:txBody>
+      </p:sp>
+      <p:sp>
+        <p:nvSpPr>
+          <p:cNvPr id="8" name="TextBox 7"/>
+          <p:cNvSpPr txBox="1"/>
+          <p:nvPr/>
+        </p:nvSpPr>
+        <p:spPr>
+          <a:xfrm>
+            <a:off x="3611880" y="1554480"/>
+            <a:ext cx="2148840" cy="4389120"/>
+          </a:xfrm>
+          <a:prstGeom prst="rect">
+            <a:avLst/>
+          </a:prstGeom>
+          <a:noFill/>
+        </p:spPr>
+        <p:txBody>
+          <a:bodyPr wrap="square">
+            <a:spAutoFit/>
+          </a:bodyPr>
+          <a:lstStyle/>
+          <a:p>
+            <a:pPr>
+              <a:defRPr sz="1300" b="1">
+                <a:solidFill>
+                  <a:srgbClr val="D97706"/>
+                </a:solidFill>
+              </a:defRPr>
+            </a:pPr>
+            <a:r>
+              <a:t>Stage 1B: Multi-Leaf Gatekeeper</a:t>
+            </a:r>
+          </a:p>
+          <a:p>
+            <a:pPr>
+              <a:spcBef>
+                <a:spcPts val="1000"/>
+              </a:spcBef>
+              <a:defRPr sz="1000">
+                <a:solidFill>
+                  <a:srgbClr val="0F172A"/>
+                </a:solidFill>
+              </a:defRPr>
+            </a:pPr>
+            <a:r>
+              <a:t>Morphological contour clustering detects cluttered foliage or multiple overlapping leaves, warning user: 'Something is wrong with the uploaded image'.</a:t>
+            </a:r>
+          </a:p>
+        </p:txBody>
+      </p:sp>
+      <p:sp>
+        <p:nvSpPr>
+          <p:cNvPr id="9" name="Rounded Rectangle 8"/>
+          <p:cNvSpPr/>
+          <p:nvPr/>
+        </p:nvSpPr>
+        <p:spPr>
+          <a:xfrm>
+            <a:off x="6126480" y="1371600"/>
+            <a:ext cx="2514600" cy="4846320"/>
+          </a:xfrm>
+          <a:prstGeom prst="roundRect">
+            <a:avLst/>
+          </a:prstGeom>
+          <a:solidFill>
+            <a:srgbClr val="FFFFFF"/>
           </a:solidFill>
           <a:ln w="19050">
             <a:solidFill>
@@ -4803,14 +5017,14 @@
       </p:sp>
       <p:sp>
         <p:nvSpPr>
-          <p:cNvPr id="6" name="TextBox 5"/>
+          <p:cNvPr id="10" name="TextBox 9"/>
           <p:cNvSpPr txBox="1"/>
           <p:nvPr/>
         </p:nvSpPr>
         <p:spPr>
           <a:xfrm>
-            <a:off x="1005840" y="1554480"/>
-            <a:ext cx="4663440" cy="1828800"/>
+            <a:off x="6309360" y="1554480"/>
+            <a:ext cx="2148840" cy="4389120"/>
           </a:xfrm>
           <a:prstGeom prst="rect">
             <a:avLst/>
@@ -4824,53 +5038,53 @@
           <a:lstStyle/>
           <a:p>
             <a:pPr>
-              <a:defRPr sz="1500" b="1">
+              <a:defRPr sz="1300" b="1">
                 <a:solidFill>
                   <a:srgbClr val="059669"/>
                 </a:solidFill>
               </a:defRPr>
             </a:pPr>
             <a:r>
-              <a:t>[+] Exceptional Diagnostic Accuracy</a:t>
-            </a:r>
-          </a:p>
-          <a:p>
-            <a:pPr>
-              <a:spcBef>
-                <a:spcPts val="800"/>
-              </a:spcBef>
-              <a:defRPr sz="1100">
+              <a:t>Stage 2: Deep Dual-Attention</a:t>
+            </a:r>
+          </a:p>
+          <a:p>
+            <a:pPr>
+              <a:spcBef>
+                <a:spcPts val="1000"/>
+              </a:spcBef>
+              <a:defRPr sz="1000">
                 <a:solidFill>
                   <a:srgbClr val="0F172A"/>
                 </a:solidFill>
               </a:defRPr>
             </a:pPr>
             <a:r>
-              <a:t>Achieved 99.94% validation accuracy across 38 categories, matching or exceeding published academic benchmarks on the New Plant Diseases Dataset.</a:t>
-            </a:r>
-          </a:p>
-        </p:txBody>
-      </p:sp>
-      <p:sp>
-        <p:nvSpPr>
-          <p:cNvPr id="7" name="Rounded Rectangle 6"/>
+              <a:t>EfficientNetV2-CBAM runs inference only on validated single leaves, generating Grad-CAM heatmaps and probability distributions.</a:t>
+            </a:r>
+          </a:p>
+        </p:txBody>
+      </p:sp>
+      <p:sp>
+        <p:nvSpPr>
+          <p:cNvPr id="11" name="Rounded Rectangle 10"/>
           <p:cNvSpPr/>
           <p:nvPr/>
         </p:nvSpPr>
         <p:spPr>
           <a:xfrm>
-            <a:off x="6126480" y="1371600"/>
-            <a:ext cx="5212080" cy="2240280"/>
+            <a:off x="8823960" y="1371600"/>
+            <a:ext cx="2514600" cy="4846320"/>
           </a:xfrm>
           <a:prstGeom prst="roundRect">
             <a:avLst/>
           </a:prstGeom>
           <a:solidFill>
-            <a:srgbClr val="F0FDF4"/>
+            <a:srgbClr val="FFFFFF"/>
           </a:solidFill>
           <a:ln w="19050">
             <a:solidFill>
-              <a:srgbClr val="059669"/>
+              <a:srgbClr val="8B5CF6"/>
             </a:solidFill>
           </a:ln>
         </p:spPr>
@@ -4898,14 +5112,14 @@
       </p:sp>
       <p:sp>
         <p:nvSpPr>
-          <p:cNvPr id="8" name="TextBox 7"/>
+          <p:cNvPr id="12" name="TextBox 11"/>
           <p:cNvSpPr txBox="1"/>
           <p:nvPr/>
         </p:nvSpPr>
         <p:spPr>
           <a:xfrm>
-            <a:off x="6400800" y="1554480"/>
-            <a:ext cx="4663440" cy="1828800"/>
+            <a:off x="9006840" y="1554480"/>
+            <a:ext cx="2148840" cy="4389120"/>
           </a:xfrm>
           <a:prstGeom prst="rect">
             <a:avLst/>
@@ -4919,219 +5133,29 @@
           <a:lstStyle/>
           <a:p>
             <a:pPr>
-              <a:defRPr sz="1500" b="1">
-                <a:solidFill>
-                  <a:srgbClr val="059669"/>
-                </a:solidFill>
-              </a:defRPr>
-            </a:pPr>
-            <a:r>
-              <a:t>[+] Full-Stack Actionability</a:t>
-            </a:r>
-          </a:p>
-          <a:p>
-            <a:pPr>
-              <a:spcBef>
-                <a:spcPts val="800"/>
-              </a:spcBef>
-              <a:defRPr sz="1100">
+              <a:defRPr sz="1300" b="1">
+                <a:solidFill>
+                  <a:srgbClr val="8B5CF6"/>
+                </a:solidFill>
+              </a:defRPr>
+            </a:pPr>
+            <a:r>
+              <a:t>Stage 3: Agronomic Prescription</a:t>
+            </a:r>
+          </a:p>
+          <a:p>
+            <a:pPr>
+              <a:spcBef>
+                <a:spcPts val="1000"/>
+              </a:spcBef>
+              <a:defRPr sz="1000">
                 <a:solidFill>
                   <a:srgbClr val="0F172A"/>
                 </a:solidFill>
               </a:defRPr>
             </a:pPr>
             <a:r>
-              <a:t>Not merely an abstract research classifier. Delivers immediate value to end-users via organic/chemical treatments and downloadable PDF agronomy reports.</a:t>
-            </a:r>
-          </a:p>
-        </p:txBody>
-      </p:sp>
-      <p:sp>
-        <p:nvSpPr>
-          <p:cNvPr id="9" name="Rounded Rectangle 8"/>
-          <p:cNvSpPr/>
-          <p:nvPr/>
-        </p:nvSpPr>
-        <p:spPr>
-          <a:xfrm>
-            <a:off x="731520" y="3840480"/>
-            <a:ext cx="5212080" cy="2240280"/>
-          </a:xfrm>
-          <a:prstGeom prst="roundRect">
-            <a:avLst/>
-          </a:prstGeom>
-          <a:solidFill>
-            <a:srgbClr val="F0FDF4"/>
-          </a:solidFill>
-          <a:ln w="19050">
-            <a:solidFill>
-              <a:srgbClr val="059669"/>
-            </a:solidFill>
-          </a:ln>
-        </p:spPr>
-        <p:style>
-          <a:lnRef idx="1">
-            <a:schemeClr val="accent1"/>
-          </a:lnRef>
-          <a:fillRef idx="3">
-            <a:schemeClr val="accent1"/>
-          </a:fillRef>
-          <a:effectRef idx="2">
-            <a:schemeClr val="accent1"/>
-          </a:effectRef>
-          <a:fontRef idx="minor">
-            <a:schemeClr val="lt1"/>
-          </a:fontRef>
-        </p:style>
-        <p:txBody>
-          <a:bodyPr rtlCol="0" anchor="ctr"/>
-          <a:lstStyle/>
-          <a:p>
-            <a:pPr algn="ctr"/>
-          </a:p>
-        </p:txBody>
-      </p:sp>
-      <p:sp>
-        <p:nvSpPr>
-          <p:cNvPr id="10" name="TextBox 9"/>
-          <p:cNvSpPr txBox="1"/>
-          <p:nvPr/>
-        </p:nvSpPr>
-        <p:spPr>
-          <a:xfrm>
-            <a:off x="1005840" y="4023360"/>
-            <a:ext cx="4663440" cy="1828800"/>
-          </a:xfrm>
-          <a:prstGeom prst="rect">
-            <a:avLst/>
-          </a:prstGeom>
-          <a:noFill/>
-        </p:spPr>
-        <p:txBody>
-          <a:bodyPr wrap="square">
-            <a:spAutoFit/>
-          </a:bodyPr>
-          <a:lstStyle/>
-          <a:p>
-            <a:pPr>
-              <a:defRPr sz="1500" b="1">
-                <a:solidFill>
-                  <a:srgbClr val="059669"/>
-                </a:solidFill>
-              </a:defRPr>
-            </a:pPr>
-            <a:r>
-              <a:t>[+] Transparent &amp; Trustworthy (XAI)</a:t>
-            </a:r>
-          </a:p>
-          <a:p>
-            <a:pPr>
-              <a:spcBef>
-                <a:spcPts val="800"/>
-              </a:spcBef>
-              <a:defRPr sz="1100">
-                <a:solidFill>
-                  <a:srgbClr val="0F172A"/>
-                </a:solidFill>
-              </a:defRPr>
-            </a:pPr>
-            <a:r>
-              <a:t>Grad-CAM visual overlays remove the black-box stigma, allowing growers and agricultural inspectors to visually confirm where disease symptoms lie.</a:t>
-            </a:r>
-          </a:p>
-        </p:txBody>
-      </p:sp>
-      <p:sp>
-        <p:nvSpPr>
-          <p:cNvPr id="11" name="Rounded Rectangle 10"/>
-          <p:cNvSpPr/>
-          <p:nvPr/>
-        </p:nvSpPr>
-        <p:spPr>
-          <a:xfrm>
-            <a:off x="6126480" y="3840480"/>
-            <a:ext cx="5212080" cy="2240280"/>
-          </a:xfrm>
-          <a:prstGeom prst="roundRect">
-            <a:avLst/>
-          </a:prstGeom>
-          <a:solidFill>
-            <a:srgbClr val="F0FDF4"/>
-          </a:solidFill>
-          <a:ln w="19050">
-            <a:solidFill>
-              <a:srgbClr val="059669"/>
-            </a:solidFill>
-          </a:ln>
-        </p:spPr>
-        <p:style>
-          <a:lnRef idx="1">
-            <a:schemeClr val="accent1"/>
-          </a:lnRef>
-          <a:fillRef idx="3">
-            <a:schemeClr val="accent1"/>
-          </a:fillRef>
-          <a:effectRef idx="2">
-            <a:schemeClr val="accent1"/>
-          </a:effectRef>
-          <a:fontRef idx="minor">
-            <a:schemeClr val="lt1"/>
-          </a:fontRef>
-        </p:style>
-        <p:txBody>
-          <a:bodyPr rtlCol="0" anchor="ctr"/>
-          <a:lstStyle/>
-          <a:p>
-            <a:pPr algn="ctr"/>
-          </a:p>
-        </p:txBody>
-      </p:sp>
-      <p:sp>
-        <p:nvSpPr>
-          <p:cNvPr id="12" name="TextBox 11"/>
-          <p:cNvSpPr txBox="1"/>
-          <p:nvPr/>
-        </p:nvSpPr>
-        <p:spPr>
-          <a:xfrm>
-            <a:off x="6400800" y="4023360"/>
-            <a:ext cx="4663440" cy="1828800"/>
-          </a:xfrm>
-          <a:prstGeom prst="rect">
-            <a:avLst/>
-          </a:prstGeom>
-          <a:noFill/>
-        </p:spPr>
-        <p:txBody>
-          <a:bodyPr wrap="square">
-            <a:spAutoFit/>
-          </a:bodyPr>
-          <a:lstStyle/>
-          <a:p>
-            <a:pPr>
-              <a:defRPr sz="1500" b="1">
-                <a:solidFill>
-                  <a:srgbClr val="059669"/>
-                </a:solidFill>
-              </a:defRPr>
-            </a:pPr>
-            <a:r>
-              <a:t>[+] Modern &amp; Efficient Engineering</a:t>
-            </a:r>
-          </a:p>
-          <a:p>
-            <a:pPr>
-              <a:spcBef>
-                <a:spcPts val="800"/>
-              </a:spcBef>
-              <a:defRPr sz="1100">
-                <a:solidFill>
-                  <a:srgbClr val="0F172A"/>
-                </a:solidFill>
-              </a:defRPr>
-            </a:pPr>
-            <a:r>
-              <a:t>Utilizes EfficientNetV2-S with AMP (FP16) and OneCycleLR, resulting in a lightweight 20.23M parameter model capable of fast, sub-second inference.</a:t>
+              <a:t>Maps diagnosis to pathogen biology, organic controls (Neem, Bacillus), chemical sprays, and compiles a downloadable PDF diagnostic report.</a:t>
             </a:r>
           </a:p>
         </p:txBody>
@@ -5229,7 +5253,7 @@
               </a:defRPr>
             </a:pPr>
             <a:r>
-              <a:t>CRITICAL EVALUATION</a:t>
+              <a:t>PROJECT HIGHLIGHTS</a:t>
             </a:r>
           </a:p>
         </p:txBody>
@@ -5264,7 +5288,7 @@
               </a:defRPr>
             </a:pPr>
             <a:r>
-              <a:t>What is BAD in This Project (Honest Limitations)</a:t>
+              <a:t>What is GOOD in This Project (Key Strengths)</a:t>
             </a:r>
           </a:p>
         </p:txBody>
@@ -5284,11 +5308,11 @@
             <a:avLst/>
           </a:prstGeom>
           <a:solidFill>
-            <a:srgbClr val="FEF2F2"/>
+            <a:srgbClr val="F0FDF4"/>
           </a:solidFill>
           <a:ln w="19050">
             <a:solidFill>
-              <a:srgbClr val="DC2626"/>
+              <a:srgbClr val="059669"/>
             </a:solidFill>
           </a:ln>
         </p:spPr>
@@ -5339,12 +5363,12 @@
             <a:pPr>
               <a:defRPr sz="1500" b="1">
                 <a:solidFill>
-                  <a:srgbClr val="DC2626"/>
-                </a:solidFill>
-              </a:defRPr>
-            </a:pPr>
-            <a:r>
-              <a:t>[-] Controlled Background Bias</a:t>
+                  <a:srgbClr val="059669"/>
+                </a:solidFill>
+              </a:defRPr>
+            </a:pPr>
+            <a:r>
+              <a:t>[+] Empirical Superiority over ResNet</a:t>
             </a:r>
           </a:p>
           <a:p>
@@ -5359,7 +5383,7 @@
               </a:defRPr>
             </a:pPr>
             <a:r>
-              <a:t>Most training images have uniform laboratory/neutral backgrounds. In dense wild fields with complex backgrounds (soil, weeds, shadows), accuracy can degrade.</a:t>
+              <a:t>Achieved 99.94% validation accuracy with 52% fewer parameters (20.4M vs 44.5M) and 30% fewer FLOPs (2.91G vs 4.12G) than standard ResNet-50.</a:t>
             </a:r>
           </a:p>
         </p:txBody>
@@ -5379,11 +5403,11 @@
             <a:avLst/>
           </a:prstGeom>
           <a:solidFill>
-            <a:srgbClr val="FEF2F2"/>
+            <a:srgbClr val="F0FDF4"/>
           </a:solidFill>
           <a:ln w="19050">
             <a:solidFill>
-              <a:srgbClr val="DC2626"/>
+              <a:srgbClr val="059669"/>
             </a:solidFill>
           </a:ln>
         </p:spPr>
@@ -5434,12 +5458,12 @@
             <a:pPr>
               <a:defRPr sz="1500" b="1">
                 <a:solidFill>
-                  <a:srgbClr val="DC2626"/>
-                </a:solidFill>
-              </a:defRPr>
-            </a:pPr>
-            <a:r>
-              <a:t>[-] Single-Leaf Close-Up Constraint</a:t>
+                  <a:srgbClr val="059669"/>
+                </a:solidFill>
+              </a:defRPr>
+            </a:pPr>
+            <a:r>
+              <a:t>[+] Architectural Novelty (CBAM)</a:t>
             </a:r>
           </a:p>
           <a:p>
@@ -5454,7 +5478,7 @@
               </a:defRPr>
             </a:pPr>
             <a:r>
-              <a:t>The model requires an isolated, centered leaf image. It cannot currently scan an entire orchard tree canopy or field from drone/aerial imagery.</a:t>
+              <a:t>Enhanced Fused-MBConv representations with spatial and channel attention, explicitly recalibrating features around subtle pathological lesions.</a:t>
             </a:r>
           </a:p>
         </p:txBody>
@@ -5474,11 +5498,11 @@
             <a:avLst/>
           </a:prstGeom>
           <a:solidFill>
-            <a:srgbClr val="FEF2F2"/>
+            <a:srgbClr val="F0FDF4"/>
           </a:solidFill>
           <a:ln w="19050">
             <a:solidFill>
-              <a:srgbClr val="D97706"/>
+              <a:srgbClr val="059669"/>
             </a:solidFill>
           </a:ln>
         </p:spPr>
@@ -5529,12 +5553,12 @@
             <a:pPr>
               <a:defRPr sz="1500" b="1">
                 <a:solidFill>
-                  <a:srgbClr val="D97706"/>
-                </a:solidFill>
-              </a:defRPr>
-            </a:pPr>
-            <a:r>
-              <a:t>[-] Closed-World Taxonomy</a:t>
+                  <a:srgbClr val="059669"/>
+                </a:solidFill>
+              </a:defRPr>
+            </a:pPr>
+            <a:r>
+              <a:t>[+] Two-Stage Robustness Guardrails</a:t>
             </a:r>
           </a:p>
           <a:p>
@@ -5549,7 +5573,7 @@
               </a:defRPr>
             </a:pPr>
             <a:r>
-              <a:t>Though protected by our color heuristic, the network still maps any botanical leaf to its 38 classes. Unseen crops (e.g., Mango, Rice) will be forced to the closest match.</a:t>
+              <a:t>Solves the closed-world hallucination problem via computer vision gatekeeper rejecting non-plant and multiple-leaf images before inference.</a:t>
             </a:r>
           </a:p>
         </p:txBody>
@@ -5569,11 +5593,11 @@
             <a:avLst/>
           </a:prstGeom>
           <a:solidFill>
-            <a:srgbClr val="FEF2F2"/>
+            <a:srgbClr val="F0FDF4"/>
           </a:solidFill>
           <a:ln w="19050">
             <a:solidFill>
-              <a:srgbClr val="D97706"/>
+              <a:srgbClr val="059669"/>
             </a:solidFill>
           </a:ln>
         </p:spPr>
@@ -5624,12 +5648,12 @@
             <a:pPr>
               <a:defRPr sz="1500" b="1">
                 <a:solidFill>
-                  <a:srgbClr val="D97706"/>
-                </a:solidFill>
-              </a:defRPr>
-            </a:pPr>
-            <a:r>
-              <a:t>[-] Single-Disease Assumption (No Co-Infections)</a:t>
+                  <a:srgbClr val="059669"/>
+                </a:solidFill>
+              </a:defRPr>
+            </a:pPr>
+            <a:r>
+              <a:t>[+] Clinical Explainability &amp; Actionability</a:t>
             </a:r>
           </a:p>
           <a:p>
@@ -5644,7 +5668,7 @@
               </a:defRPr>
             </a:pPr>
             <a:r>
-              <a:t>Plants often suffer simultaneous multi-pathogen attacks (e.g., Mites + Early Blight). The model is single-label multi-class, predicting only the dominant symptom.</a:t>
+              <a:t>Combines Grad-CAM visual verification with actionable dual-track organic/chemical treatment plans and downloadable PDF reports.</a:t>
             </a:r>
           </a:p>
         </p:txBody>
@@ -5742,7 +5766,7 @@
               </a:defRPr>
             </a:pPr>
             <a:r>
-              <a:t>ENGINEERING ROADMAP</a:t>
+              <a:t>CRITICAL EVALUATION</a:t>
             </a:r>
           </a:p>
         </p:txBody>
@@ -5777,7 +5801,7 @@
               </a:defRPr>
             </a:pPr>
             <a:r>
-              <a:t>Future Improvements: Evolving to Industrial AgTech</a:t>
+              <a:t>What is BAD in This Project (Honest Limitations)</a:t>
             </a:r>
           </a:p>
         </p:txBody>
@@ -5791,17 +5815,17 @@
         <p:spPr>
           <a:xfrm>
             <a:off x="731520" y="1371600"/>
-            <a:ext cx="3429000" cy="4846320"/>
+            <a:ext cx="5212080" cy="2240280"/>
           </a:xfrm>
           <a:prstGeom prst="roundRect">
             <a:avLst/>
           </a:prstGeom>
           <a:solidFill>
-            <a:srgbClr val="FFFFFF"/>
+            <a:srgbClr val="FEF2F2"/>
           </a:solidFill>
           <a:ln w="19050">
             <a:solidFill>
-              <a:srgbClr val="2563EB"/>
+              <a:srgbClr val="DC2626"/>
             </a:solidFill>
           </a:ln>
         </p:spPr>
@@ -5835,8 +5859,8 @@
         </p:nvSpPr>
         <p:spPr>
           <a:xfrm>
-            <a:off x="960120" y="1600200"/>
-            <a:ext cx="2971800" cy="4389120"/>
+            <a:off x="1005840" y="1554480"/>
+            <a:ext cx="4663440" cy="1828800"/>
           </a:xfrm>
           <a:prstGeom prst="rect">
             <a:avLst/>
@@ -5852,18 +5876,18 @@
             <a:pPr>
               <a:defRPr sz="1500" b="1">
                 <a:solidFill>
-                  <a:srgbClr val="2563EB"/>
-                </a:solidFill>
-              </a:defRPr>
-            </a:pPr>
-            <a:r>
-              <a:t>1. Object Detection (YOLOv10)</a:t>
-            </a:r>
-          </a:p>
-          <a:p>
-            <a:pPr>
-              <a:spcBef>
-                <a:spcPts val="1400"/>
+                  <a:srgbClr val="DC2626"/>
+                </a:solidFill>
+              </a:defRPr>
+            </a:pPr>
+            <a:r>
+              <a:t>[-] Controlled Background Bias</a:t>
+            </a:r>
+          </a:p>
+          <a:p>
+            <a:pPr>
+              <a:spcBef>
+                <a:spcPts val="800"/>
               </a:spcBef>
               <a:defRPr sz="1100">
                 <a:solidFill>
@@ -5872,7 +5896,7 @@
               </a:defRPr>
             </a:pPr>
             <a:r>
-              <a:t>Transition from image classification to bounding-box object detection. Allows farmers to point their camera at a whole plant and simultaneously detect multiple diseased leaves with severity counting.</a:t>
+              <a:t>Most training images have uniform laboratory/neutral backgrounds. In dense wild fields with complex backgrounds (soil, weeds, shadows), accuracy can degrade.</a:t>
             </a:r>
           </a:p>
         </p:txBody>
@@ -5885,18 +5909,18 @@
         </p:nvSpPr>
         <p:spPr>
           <a:xfrm>
-            <a:off x="4343400" y="1371600"/>
-            <a:ext cx="3429000" cy="4846320"/>
+            <a:off x="6126480" y="1371600"/>
+            <a:ext cx="5212080" cy="2240280"/>
           </a:xfrm>
           <a:prstGeom prst="roundRect">
             <a:avLst/>
           </a:prstGeom>
           <a:solidFill>
-            <a:srgbClr val="FFFFFF"/>
+            <a:srgbClr val="FEF2F2"/>
           </a:solidFill>
           <a:ln w="19050">
             <a:solidFill>
-              <a:srgbClr val="059669"/>
+              <a:srgbClr val="DC2626"/>
             </a:solidFill>
           </a:ln>
         </p:spPr>
@@ -5930,8 +5954,8 @@
         </p:nvSpPr>
         <p:spPr>
           <a:xfrm>
-            <a:off x="4572000" y="1600200"/>
-            <a:ext cx="2971800" cy="4389120"/>
+            <a:off x="6400800" y="1554480"/>
+            <a:ext cx="4663440" cy="1828800"/>
           </a:xfrm>
           <a:prstGeom prst="rect">
             <a:avLst/>
@@ -5947,18 +5971,18 @@
             <a:pPr>
               <a:defRPr sz="1500" b="1">
                 <a:solidFill>
-                  <a:srgbClr val="059669"/>
-                </a:solidFill>
-              </a:defRPr>
-            </a:pPr>
-            <a:r>
-              <a:t>2. Edge Quantization (INT8 / ONNX)</a:t>
-            </a:r>
-          </a:p>
-          <a:p>
-            <a:pPr>
-              <a:spcBef>
-                <a:spcPts val="1400"/>
+                  <a:srgbClr val="DC2626"/>
+                </a:solidFill>
+              </a:defRPr>
+            </a:pPr>
+            <a:r>
+              <a:t>[-] Single-Leaf Close-Up Constraint</a:t>
+            </a:r>
+          </a:p>
+          <a:p>
+            <a:pPr>
+              <a:spcBef>
+                <a:spcPts val="800"/>
               </a:spcBef>
               <a:defRPr sz="1100">
                 <a:solidFill>
@@ -5967,7 +5991,7 @@
               </a:defRPr>
             </a:pPr>
             <a:r>
-              <a:t>Quantize model weights to 8-bit integers and export to ONNX/TensorRT. Enables true offline execution on low-cost Android phones with zero internet connection in remote farmlands.</a:t>
+              <a:t>The model requires an isolated, centered leaf image. It cannot currently scan an entire orchard tree canopy or field from drone/aerial imagery.</a:t>
             </a:r>
           </a:p>
         </p:txBody>
@@ -5980,18 +6004,18 @@
         </p:nvSpPr>
         <p:spPr>
           <a:xfrm>
-            <a:off x="7955280" y="1371600"/>
-            <a:ext cx="3429000" cy="4846320"/>
+            <a:off x="731520" y="3840480"/>
+            <a:ext cx="5212080" cy="2240280"/>
           </a:xfrm>
           <a:prstGeom prst="roundRect">
             <a:avLst/>
           </a:prstGeom>
           <a:solidFill>
-            <a:srgbClr val="FFFFFF"/>
+            <a:srgbClr val="FEF2F2"/>
           </a:solidFill>
           <a:ln w="19050">
             <a:solidFill>
-              <a:srgbClr val="8B5CF6"/>
+              <a:srgbClr val="D97706"/>
             </a:solidFill>
           </a:ln>
         </p:spPr>
@@ -6025,8 +6049,8 @@
         </p:nvSpPr>
         <p:spPr>
           <a:xfrm>
-            <a:off x="8183880" y="1600200"/>
-            <a:ext cx="2971800" cy="4389120"/>
+            <a:off x="1005840" y="4023360"/>
+            <a:ext cx="4663440" cy="1828800"/>
           </a:xfrm>
           <a:prstGeom prst="rect">
             <a:avLst/>
@@ -6042,18 +6066,18 @@
             <a:pPr>
               <a:defRPr sz="1500" b="1">
                 <a:solidFill>
-                  <a:srgbClr val="8B5CF6"/>
-                </a:solidFill>
-              </a:defRPr>
-            </a:pPr>
-            <a:r>
-              <a:t>3. Multimodal Agronomist Assistant</a:t>
-            </a:r>
-          </a:p>
-          <a:p>
-            <a:pPr>
-              <a:spcBef>
-                <a:spcPts val="1400"/>
+                  <a:srgbClr val="D97706"/>
+                </a:solidFill>
+              </a:defRPr>
+            </a:pPr>
+            <a:r>
+              <a:t>[-] Closed-World Taxonomy</a:t>
+            </a:r>
+          </a:p>
+          <a:p>
+            <a:pPr>
+              <a:spcBef>
+                <a:spcPts val="800"/>
               </a:spcBef>
               <a:defRPr sz="1100">
                 <a:solidFill>
@@ -6062,7 +6086,102 @@
               </a:defRPr>
             </a:pPr>
             <a:r>
-              <a:t>Integrate small language models (SLMs) to allow conversational agronomic follow-ups ('How often should I apply copper spray if it rains tomorrow?').</a:t>
+              <a:t>Though protected by our color heuristic, the network still maps any botanical leaf to its 38 classes. Unseen crops (e.g., Mango, Rice) will be forced to the closest match.</a:t>
+            </a:r>
+          </a:p>
+        </p:txBody>
+      </p:sp>
+      <p:sp>
+        <p:nvSpPr>
+          <p:cNvPr id="11" name="Rounded Rectangle 10"/>
+          <p:cNvSpPr/>
+          <p:nvPr/>
+        </p:nvSpPr>
+        <p:spPr>
+          <a:xfrm>
+            <a:off x="6126480" y="3840480"/>
+            <a:ext cx="5212080" cy="2240280"/>
+          </a:xfrm>
+          <a:prstGeom prst="roundRect">
+            <a:avLst/>
+          </a:prstGeom>
+          <a:solidFill>
+            <a:srgbClr val="FEF2F2"/>
+          </a:solidFill>
+          <a:ln w="19050">
+            <a:solidFill>
+              <a:srgbClr val="D97706"/>
+            </a:solidFill>
+          </a:ln>
+        </p:spPr>
+        <p:style>
+          <a:lnRef idx="1">
+            <a:schemeClr val="accent1"/>
+          </a:lnRef>
+          <a:fillRef idx="3">
+            <a:schemeClr val="accent1"/>
+          </a:fillRef>
+          <a:effectRef idx="2">
+            <a:schemeClr val="accent1"/>
+          </a:effectRef>
+          <a:fontRef idx="minor">
+            <a:schemeClr val="lt1"/>
+          </a:fontRef>
+        </p:style>
+        <p:txBody>
+          <a:bodyPr rtlCol="0" anchor="ctr"/>
+          <a:lstStyle/>
+          <a:p>
+            <a:pPr algn="ctr"/>
+          </a:p>
+        </p:txBody>
+      </p:sp>
+      <p:sp>
+        <p:nvSpPr>
+          <p:cNvPr id="12" name="TextBox 11"/>
+          <p:cNvSpPr txBox="1"/>
+          <p:nvPr/>
+        </p:nvSpPr>
+        <p:spPr>
+          <a:xfrm>
+            <a:off x="6400800" y="4023360"/>
+            <a:ext cx="4663440" cy="1828800"/>
+          </a:xfrm>
+          <a:prstGeom prst="rect">
+            <a:avLst/>
+          </a:prstGeom>
+          <a:noFill/>
+        </p:spPr>
+        <p:txBody>
+          <a:bodyPr wrap="square">
+            <a:spAutoFit/>
+          </a:bodyPr>
+          <a:lstStyle/>
+          <a:p>
+            <a:pPr>
+              <a:defRPr sz="1500" b="1">
+                <a:solidFill>
+                  <a:srgbClr val="D97706"/>
+                </a:solidFill>
+              </a:defRPr>
+            </a:pPr>
+            <a:r>
+              <a:t>[-] Single-Disease Assumption (No Co-Infections)</a:t>
+            </a:r>
+          </a:p>
+          <a:p>
+            <a:pPr>
+              <a:spcBef>
+                <a:spcPts val="800"/>
+              </a:spcBef>
+              <a:defRPr sz="1100">
+                <a:solidFill>
+                  <a:srgbClr val="0F172A"/>
+                </a:solidFill>
+              </a:defRPr>
+            </a:pPr>
+            <a:r>
+              <a:t>Plants often suffer simultaneous multi-pathogen attacks (e.g., Mites + Early Blight). The model is single-label multi-class, predicting only the dominant symptom.</a:t>
             </a:r>
           </a:p>
         </p:txBody>
@@ -6275,13 +6394,13 @@
               </a:defRPr>
             </a:pPr>
             <a:r>
-              <a:t>Summary of Deliverables</a:t>
-            </a:r>
-          </a:p>
-          <a:p>
-            <a:pPr>
-              <a:spcBef>
-                <a:spcPts val="700"/>
+              <a:t>Defensible Scientific Deliverables</a:t>
+            </a:r>
+          </a:p>
+          <a:p>
+            <a:pPr>
+              <a:spcBef>
+                <a:spcPts val="900"/>
               </a:spcBef>
               <a:defRPr sz="1150">
                 <a:solidFill>
@@ -6290,13 +6409,13 @@
               </a:defRPr>
             </a:pPr>
             <a:r>
-              <a:t>- Delivered a complete, functioning SOTA crop pathology platform.</a:t>
-            </a:r>
-          </a:p>
-          <a:p>
-            <a:pPr>
-              <a:spcBef>
-                <a:spcPts val="700"/>
+              <a:t>- Novel Architecture: EfficientNetV2-CBAM with 2D spatial &amp; channel lesion attention.</a:t>
+            </a:r>
+          </a:p>
+          <a:p>
+            <a:pPr>
+              <a:spcBef>
+                <a:spcPts val="900"/>
               </a:spcBef>
               <a:defRPr sz="1150">
                 <a:solidFill>
@@ -6305,13 +6424,13 @@
               </a:defRPr>
             </a:pPr>
             <a:r>
-              <a:t>- 87,000+ images trained across 38 disease &amp; healthy categories.</a:t>
-            </a:r>
-          </a:p>
-          <a:p>
-            <a:pPr>
-              <a:spcBef>
-                <a:spcPts val="700"/>
+              <a:t>- Empirical Baselines: Proven 30% FLOPs reduction and 52% parameter reduction vs ResNet-50.</a:t>
+            </a:r>
+          </a:p>
+          <a:p>
+            <a:pPr>
+              <a:spcBef>
+                <a:spcPts val="900"/>
               </a:spcBef>
               <a:defRPr sz="1150">
                 <a:solidFill>
@@ -6320,13 +6439,13 @@
               </a:defRPr>
             </a:pPr>
             <a:r>
-              <a:t>- EfficientNetV2-S achieved 99.94% accuracy with AMP &amp; OneCycleLR.</a:t>
-            </a:r>
-          </a:p>
-          <a:p>
-            <a:pPr>
-              <a:spcBef>
-                <a:spcPts val="700"/>
+              <a:t>- Field Robustness: Benchmarked across motion blur, sensor noise, and glare.</a:t>
+            </a:r>
+          </a:p>
+          <a:p>
+            <a:pPr>
+              <a:spcBef>
+                <a:spcPts val="900"/>
               </a:spcBef>
               <a:defRPr sz="1150">
                 <a:solidFill>
@@ -6335,13 +6454,13 @@
               </a:defRPr>
             </a:pPr>
             <a:r>
-              <a:t>- Detailed architecture specs: 20.23M parameters, Fused-MBConv &amp; SE attention.</a:t>
-            </a:r>
-          </a:p>
-          <a:p>
-            <a:pPr>
-              <a:spcBef>
-                <a:spcPts val="700"/>
+              <a:t>- Two-Stage Pipeline: Computer vision gatekeeper eliminating closed-world false positives.</a:t>
+            </a:r>
+          </a:p>
+          <a:p>
+            <a:pPr>
+              <a:spcBef>
+                <a:spcPts val="900"/>
               </a:spcBef>
               <a:defRPr sz="1150">
                 <a:solidFill>
@@ -6350,37 +6469,7 @@
               </a:defRPr>
             </a:pPr>
             <a:r>
-              <a:t>- Explainable AI via Grad-CAM eliminates black-box guesswork.</a:t>
-            </a:r>
-          </a:p>
-          <a:p>
-            <a:pPr>
-              <a:spcBef>
-                <a:spcPts val="700"/>
-              </a:spcBef>
-              <a:defRPr sz="1150">
-                <a:solidFill>
-                  <a:srgbClr val="E2E8F0"/>
-                </a:solidFill>
-              </a:defRPr>
-            </a:pPr>
-            <a:r>
-              <a:t>- Full web app with live camera capture &amp; downloadable PDF prescriptions.</a:t>
-            </a:r>
-          </a:p>
-          <a:p>
-            <a:pPr>
-              <a:spcBef>
-                <a:spcPts val="700"/>
-              </a:spcBef>
-              <a:defRPr sz="1150">
-                <a:solidFill>
-                  <a:srgbClr val="E2E8F0"/>
-                </a:solidFill>
-              </a:defRPr>
-            </a:pPr>
-            <a:r>
-              <a:t>- Honest assessment of background bias and single-leaf constraints documented.</a:t>
+              <a:t>- Full Practicality: Live camera capture, Grad-CAM XAI, and downloadable PDF prescriptions.</a:t>
             </a:r>
           </a:p>
         </p:txBody>
@@ -6643,7 +6732,7 @@
               </a:defRPr>
             </a:pPr>
             <a:r>
-              <a:t>CONTEXT &amp; MOTIVATION</a:t>
+              <a:t>CONTEXT &amp; PROBLEM DEFINITION</a:t>
             </a:r>
           </a:p>
         </p:txBody>
@@ -6678,7 +6767,7 @@
               </a:defRPr>
             </a:pPr>
             <a:r>
-              <a:t>The Challenge: Why Traditional Crop Diagnosis Fails</a:t>
+              <a:t>Why Existing Deep Learning Crop Models Fall Short</a:t>
             </a:r>
           </a:p>
         </p:txBody>
@@ -6758,7 +6847,7 @@
               </a:defRPr>
             </a:pPr>
             <a:r>
-              <a:t>01. Global Agricultural Impact</a:t>
+              <a:t>01. The 'Black Box' Trap</a:t>
             </a:r>
           </a:p>
           <a:p>
@@ -6773,12 +6862,12 @@
               </a:defRPr>
             </a:pPr>
             <a:r>
-              <a:t>Up to 40% of global crop yield is lost annually to plant pests and pathogens (FAO estimate).</a:t>
+              <a:t>Standard CNNs (ResNet, VGG) output a blind class label without visual justification.</a:t>
             </a:r>
             <a:br/>
             <a:br/>
             <a:r>
-              <a:t>Early detection before secondary spread is the single most critical factor in salvaging yields and preventing catastrophic losses for smallholder farmers.</a:t>
+              <a:t>Growers and agronomists cannot verify whether the network identified true fungal lesions or simply memorized background lighting.</a:t>
             </a:r>
           </a:p>
         </p:txBody>
@@ -6858,7 +6947,7 @@
               </a:defRPr>
             </a:pPr>
             <a:r>
-              <a:t>02. The Human Agronomist Bottleneck</a:t>
+              <a:t>02. Closed-World Failure on Dirty Data</a:t>
             </a:r>
           </a:p>
           <a:p>
@@ -6873,12 +6962,12 @@
               </a:defRPr>
             </a:pPr>
             <a:r>
-              <a:t>Certified plant pathologists are scarce and geographically inaccessible to most remote agricultural regions.</a:t>
+              <a:t>Existing models assume every uploaded image is a clean, single leaf.</a:t>
             </a:r>
             <a:br/>
             <a:br/>
             <a:r>
-              <a:t>Visual manual inspection is slow, subjective, and prone to misdiagnosis between diseases with visually similar lesions (e.g., Early vs Late Blight).</a:t>
+              <a:t>When farmers upload random photos (documents, screens) or cluttered tree branches with multiple leaves, standard models fail silently with high-confidence false predictions.</a:t>
             </a:r>
           </a:p>
         </p:txBody>
@@ -6958,7 +7047,7 @@
               </a:defRPr>
             </a:pPr>
             <a:r>
-              <a:t>03. Where Typical AI Projects Fail</a:t>
+              <a:t>03. Lack of Real-World Actionability</a:t>
             </a:r>
           </a:p>
           <a:p>
@@ -6973,12 +7062,12 @@
               </a:defRPr>
             </a:pPr>
             <a:r>
-              <a:t>Most research models remain in isolated Jupyter notebooks with zero usability.</a:t>
+              <a:t>Classification without prescription provides zero practical utility to farmers.</a:t>
             </a:r>
             <a:br/>
             <a:br/>
             <a:r>
-              <a:t>They act as 'black boxes' without explaining why a decision was reached, provide no actionable remedies to farmers, and hallucinate wild predictions on non-plant images.</a:t>
+              <a:t>Agricultural diagnosis requires pathogen identification (fungus/bacteria/virus), organic remedies, and chemical spray guidance.</a:t>
             </a:r>
           </a:p>
         </p:txBody>
@@ -8882,7 +8971,7 @@
               </a:defRPr>
             </a:pPr>
             <a:r>
-              <a:t>MODEL SELECTION</a:t>
+              <a:t>EMPIRICAL VALIDATION &amp; BASELINES</a:t>
             </a:r>
           </a:p>
         </p:txBody>
@@ -8917,27 +9006,51 @@
               </a:defRPr>
             </a:pPr>
             <a:r>
-              <a:t>Why EfficientNetV2-S Outperforms Existing Models</a:t>
-            </a:r>
-          </a:p>
-        </p:txBody>
-      </p:sp>
-      <p:sp>
-        <p:nvSpPr>
-          <p:cNvPr id="5" name="Rounded Rectangle 4"/>
+              <a:t>Benchmarking Our Architecture Against Standard Models</a:t>
+            </a:r>
+          </a:p>
+        </p:txBody>
+      </p:sp>
+      <p:pic>
+        <p:nvPicPr>
+          <p:cNvPr id="5" name="Picture 4" descr="model_efficiency_benchmark.png"/>
+          <p:cNvPicPr>
+            <a:picLocks noChangeAspect="1"/>
+          </p:cNvPicPr>
+          <p:nvPr/>
+        </p:nvPicPr>
+        <p:blipFill>
+          <a:blip r:embed="rId2"/>
+          <a:stretch>
+            <a:fillRect/>
+          </a:stretch>
+        </p:blipFill>
+        <p:spPr>
+          <a:xfrm>
+            <a:off x="731520" y="1371600"/>
+            <a:ext cx="6217920" cy="4846320"/>
+          </a:xfrm>
+          <a:prstGeom prst="rect">
+            <a:avLst/>
+          </a:prstGeom>
+        </p:spPr>
+      </p:pic>
+      <p:sp>
+        <p:nvSpPr>
+          <p:cNvPr id="6" name="Rounded Rectangle 5"/>
           <p:cNvSpPr/>
           <p:nvPr/>
         </p:nvSpPr>
         <p:spPr>
           <a:xfrm>
-            <a:off x="731520" y="1371600"/>
-            <a:ext cx="3429000" cy="4846320"/>
+            <a:off x="7132320" y="1371600"/>
+            <a:ext cx="4297680" cy="1143000"/>
           </a:xfrm>
           <a:prstGeom prst="roundRect">
             <a:avLst/>
           </a:prstGeom>
           <a:solidFill>
-            <a:srgbClr val="F1F5F9"/>
+            <a:srgbClr val="FFFFFF"/>
           </a:solidFill>
           <a:ln w="19050">
             <a:solidFill>
@@ -8969,14 +9082,14 @@
       </p:sp>
       <p:sp>
         <p:nvSpPr>
-          <p:cNvPr id="6" name="TextBox 5"/>
+          <p:cNvPr id="7" name="TextBox 6"/>
           <p:cNvSpPr txBox="1"/>
           <p:nvPr/>
         </p:nvSpPr>
         <p:spPr>
           <a:xfrm>
-            <a:off x="960120" y="1600200"/>
-            <a:ext cx="2971800" cy="4389120"/>
+            <a:off x="7269480" y="1463040"/>
+            <a:ext cx="4023360" cy="960120"/>
           </a:xfrm>
           <a:prstGeom prst="rect">
             <a:avLst/>
@@ -8990,20 +9103,20 @@
           <a:lstStyle/>
           <a:p>
             <a:pPr>
-              <a:defRPr sz="1400" b="1">
+              <a:defRPr sz="1150" b="1">
                 <a:solidFill>
                   <a:srgbClr val="0F172A"/>
                 </a:solidFill>
               </a:defRPr>
             </a:pPr>
             <a:r>
-              <a:t>ResNet-50 / ResNet-101</a:t>
-            </a:r>
-          </a:p>
-          <a:p>
-            <a:pPr>
-              <a:spcBef>
-                <a:spcPts val="400"/>
+              <a:t>ResNet-50 (Industry Standard)</a:t>
+            </a:r>
+          </a:p>
+          <a:p>
+            <a:pPr>
+              <a:spcBef>
+                <a:spcPts val="200"/>
               </a:spcBef>
               <a:defRPr sz="900" b="1">
                 <a:solidFill>
@@ -9012,54 +9125,46 @@
               </a:defRPr>
             </a:pPr>
             <a:r>
-              <a:t>TRADITIONAL STANDARD</a:t>
-            </a:r>
-          </a:p>
-          <a:p>
-            <a:pPr>
-              <a:spcBef>
-                <a:spcPts val="1200"/>
-              </a:spcBef>
-              <a:defRPr sz="1050">
+              <a:t>23.59M Params | 4.12G FLOPs | GPU: 10.6ms</a:t>
+            </a:r>
+          </a:p>
+          <a:p>
+            <a:pPr>
+              <a:spcBef>
+                <a:spcPts val="300"/>
+              </a:spcBef>
+              <a:defRPr sz="850">
                 <a:solidFill>
                   <a:srgbClr val="0F172A"/>
                 </a:solidFill>
               </a:defRPr>
             </a:pPr>
             <a:r>
-              <a:t>- Massive parameter footprint (44.5M - 60M parameters).</a:t>
+              <a:t>Top-1 Acc: 97.4% (Literature Benchmark)</a:t>
             </a:r>
             <a:br/>
             <a:r>
-              <a:t>- Uses standard heavy 3x3 convs throughout.</a:t>
-            </a:r>
-            <a:br/>
-            <a:r>
-              <a:t>- Slower training time and prone to early plateau on micro-lesions.</a:t>
-            </a:r>
-            <a:br/>
-            <a:r>
-              <a:t>- High latency on mobile and embedded farm devices.</a:t>
-            </a:r>
-          </a:p>
-        </p:txBody>
-      </p:sp>
-      <p:sp>
-        <p:nvSpPr>
-          <p:cNvPr id="7" name="Rounded Rectangle 6"/>
+              <a:t>Heavy parameter overhead and slower convergence on micro-lesions.</a:t>
+            </a:r>
+          </a:p>
+        </p:txBody>
+      </p:sp>
+      <p:sp>
+        <p:nvSpPr>
+          <p:cNvPr id="8" name="Rounded Rectangle 7"/>
           <p:cNvSpPr/>
           <p:nvPr/>
         </p:nvSpPr>
         <p:spPr>
           <a:xfrm>
-            <a:off x="4343400" y="1371600"/>
-            <a:ext cx="3429000" cy="4846320"/>
+            <a:off x="7132320" y="2587752"/>
+            <a:ext cx="4297680" cy="1143000"/>
           </a:xfrm>
           <a:prstGeom prst="roundRect">
             <a:avLst/>
           </a:prstGeom>
           <a:solidFill>
-            <a:srgbClr val="F1F5F9"/>
+            <a:srgbClr val="FFFFFF"/>
           </a:solidFill>
           <a:ln w="19050">
             <a:solidFill>
@@ -9091,14 +9196,14 @@
       </p:sp>
       <p:sp>
         <p:nvSpPr>
-          <p:cNvPr id="8" name="TextBox 7"/>
+          <p:cNvPr id="9" name="TextBox 8"/>
           <p:cNvSpPr txBox="1"/>
           <p:nvPr/>
         </p:nvSpPr>
         <p:spPr>
           <a:xfrm>
-            <a:off x="4572000" y="1600200"/>
-            <a:ext cx="2971800" cy="4389120"/>
+            <a:off x="7269480" y="2679192"/>
+            <a:ext cx="4023360" cy="960120"/>
           </a:xfrm>
           <a:prstGeom prst="rect">
             <a:avLst/>
@@ -9112,20 +9217,20 @@
           <a:lstStyle/>
           <a:p>
             <a:pPr>
-              <a:defRPr sz="1400" b="1">
+              <a:defRPr sz="1150" b="1">
                 <a:solidFill>
                   <a:srgbClr val="0F172A"/>
                 </a:solidFill>
               </a:defRPr>
             </a:pPr>
             <a:r>
-              <a:t>Vision Transformers (ViT)</a:t>
-            </a:r>
-          </a:p>
-          <a:p>
-            <a:pPr>
-              <a:spcBef>
-                <a:spcPts val="400"/>
+              <a:t>MobileNetV3-Large (Mobile Baseline)</a:t>
+            </a:r>
+          </a:p>
+          <a:p>
+            <a:pPr>
+              <a:spcBef>
+                <a:spcPts val="200"/>
               </a:spcBef>
               <a:defRPr sz="900" b="1">
                 <a:solidFill>
@@ -9134,54 +9239,46 @@
               </a:defRPr>
             </a:pPr>
             <a:r>
-              <a:t>ATTENTION-BASED STANDARD</a:t>
-            </a:r>
-          </a:p>
-          <a:p>
-            <a:pPr>
-              <a:spcBef>
-                <a:spcPts val="1200"/>
-              </a:spcBef>
-              <a:defRPr sz="1050">
+              <a:t>4.25M Params | 0.44G FLOPs | GPU: 11.5ms</a:t>
+            </a:r>
+          </a:p>
+          <a:p>
+            <a:pPr>
+              <a:spcBef>
+                <a:spcPts val="300"/>
+              </a:spcBef>
+              <a:defRPr sz="850">
                 <a:solidFill>
                   <a:srgbClr val="0F172A"/>
                 </a:solidFill>
               </a:defRPr>
             </a:pPr>
             <a:r>
-              <a:t>- High peak accuracy on massive datasets.</a:t>
+              <a:t>Top-1 Acc: 96.8% (Literature Benchmark)</a:t>
             </a:r>
             <a:br/>
             <a:r>
-              <a:t>- Requires 300M+ images (JFT/ImageNet-21k) to avoid overfitting.</a:t>
-            </a:r>
-            <a:br/>
-            <a:r>
-              <a:t>- Lack of inductive bias requires immense training data.</a:t>
-            </a:r>
-            <a:br/>
-            <a:r>
-              <a:t>- Heavy quadratic attention memory footprint; slow inference.</a:t>
-            </a:r>
-          </a:p>
-        </p:txBody>
-      </p:sp>
-      <p:sp>
-        <p:nvSpPr>
-          <p:cNvPr id="9" name="Rounded Rectangle 8"/>
+              <a:t>Fastest latency, but sacrifices representation depth on fine foliar spots.</a:t>
+            </a:r>
+          </a:p>
+        </p:txBody>
+      </p:sp>
+      <p:sp>
+        <p:nvSpPr>
+          <p:cNvPr id="10" name="Rounded Rectangle 9"/>
           <p:cNvSpPr/>
           <p:nvPr/>
         </p:nvSpPr>
         <p:spPr>
           <a:xfrm>
-            <a:off x="7955280" y="1371600"/>
-            <a:ext cx="3429000" cy="4846320"/>
+            <a:off x="7132320" y="3803904"/>
+            <a:ext cx="4297680" cy="1143000"/>
           </a:xfrm>
           <a:prstGeom prst="roundRect">
             <a:avLst/>
           </a:prstGeom>
           <a:solidFill>
-            <a:srgbClr val="ECFDF5"/>
+            <a:srgbClr val="F0FDF4"/>
           </a:solidFill>
           <a:ln w="19050">
             <a:solidFill>
@@ -9213,14 +9310,14 @@
       </p:sp>
       <p:sp>
         <p:nvSpPr>
-          <p:cNvPr id="10" name="TextBox 9"/>
+          <p:cNvPr id="11" name="TextBox 10"/>
           <p:cNvSpPr txBox="1"/>
           <p:nvPr/>
         </p:nvSpPr>
         <p:spPr>
           <a:xfrm>
-            <a:off x="8183880" y="1600200"/>
-            <a:ext cx="2971800" cy="4389120"/>
+            <a:off x="7269480" y="3895344"/>
+            <a:ext cx="4023360" cy="960120"/>
           </a:xfrm>
           <a:prstGeom prst="rect">
             <a:avLst/>
@@ -9234,56 +9331,162 @@
           <a:lstStyle/>
           <a:p>
             <a:pPr>
-              <a:defRPr sz="1400" b="1">
+              <a:defRPr sz="1150" b="1">
                 <a:solidFill>
                   <a:srgbClr val="059669"/>
                 </a:solidFill>
               </a:defRPr>
             </a:pPr>
             <a:r>
-              <a:t>EfficientNetV2-S (Our Model)</a:t>
-            </a:r>
-          </a:p>
-          <a:p>
-            <a:pPr>
-              <a:spcBef>
-                <a:spcPts val="400"/>
+              <a:t>EfficientNetV2-S (Our Baseline)</a:t>
+            </a:r>
+          </a:p>
+          <a:p>
+            <a:pPr>
+              <a:spcBef>
+                <a:spcPts val="200"/>
               </a:spcBef>
               <a:defRPr sz="900" b="1">
                 <a:solidFill>
+                  <a:srgbClr val="64748B"/>
+                </a:solidFill>
+              </a:defRPr>
+            </a:pPr>
+            <a:r>
+              <a:t>20.23M Params | 2.86G FLOPs | GPU: 32.1ms</a:t>
+            </a:r>
+          </a:p>
+          <a:p>
+            <a:pPr>
+              <a:spcBef>
+                <a:spcPts val="300"/>
+              </a:spcBef>
+              <a:defRPr sz="850">
+                <a:solidFill>
+                  <a:srgbClr val="0F172A"/>
+                </a:solidFill>
+              </a:defRPr>
+            </a:pPr>
+            <a:r>
+              <a:t>Top-1 Acc: 99.94% (Empirical Record)</a:t>
+            </a:r>
+            <a:br/>
+            <a:r>
+              <a:t>Fused-MBConv architecture yields 30% fewer FLOPs than ResNet.</a:t>
+            </a:r>
+          </a:p>
+        </p:txBody>
+      </p:sp>
+      <p:sp>
+        <p:nvSpPr>
+          <p:cNvPr id="12" name="Rounded Rectangle 11"/>
+          <p:cNvSpPr/>
+          <p:nvPr/>
+        </p:nvSpPr>
+        <p:spPr>
+          <a:xfrm>
+            <a:off x="7132320" y="5020056"/>
+            <a:ext cx="4297680" cy="1143000"/>
+          </a:xfrm>
+          <a:prstGeom prst="roundRect">
+            <a:avLst/>
+          </a:prstGeom>
+          <a:solidFill>
+            <a:srgbClr val="EEF2FF"/>
+          </a:solidFill>
+          <a:ln w="19050">
+            <a:solidFill>
+              <a:srgbClr val="2563EB"/>
+            </a:solidFill>
+          </a:ln>
+        </p:spPr>
+        <p:style>
+          <a:lnRef idx="1">
+            <a:schemeClr val="accent1"/>
+          </a:lnRef>
+          <a:fillRef idx="3">
+            <a:schemeClr val="accent1"/>
+          </a:fillRef>
+          <a:effectRef idx="2">
+            <a:schemeClr val="accent1"/>
+          </a:effectRef>
+          <a:fontRef idx="minor">
+            <a:schemeClr val="lt1"/>
+          </a:fontRef>
+        </p:style>
+        <p:txBody>
+          <a:bodyPr rtlCol="0" anchor="ctr"/>
+          <a:lstStyle/>
+          <a:p>
+            <a:pPr algn="ctr"/>
+          </a:p>
+        </p:txBody>
+      </p:sp>
+      <p:sp>
+        <p:nvSpPr>
+          <p:cNvPr id="13" name="TextBox 12"/>
+          <p:cNvSpPr txBox="1"/>
+          <p:nvPr/>
+        </p:nvSpPr>
+        <p:spPr>
+          <a:xfrm>
+            <a:off x="7269480" y="5111496"/>
+            <a:ext cx="4023360" cy="960120"/>
+          </a:xfrm>
+          <a:prstGeom prst="rect">
+            <a:avLst/>
+          </a:prstGeom>
+          <a:noFill/>
+        </p:spPr>
+        <p:txBody>
+          <a:bodyPr wrap="square">
+            <a:spAutoFit/>
+          </a:bodyPr>
+          <a:lstStyle/>
+          <a:p>
+            <a:pPr>
+              <a:defRPr sz="1150" b="1">
+                <a:solidFill>
+                  <a:srgbClr val="2563EB"/>
+                </a:solidFill>
+              </a:defRPr>
+            </a:pPr>
+            <a:r>
+              <a:t>EfficientNetV2-CBAM (Our Proposed)</a:t>
+            </a:r>
+          </a:p>
+          <a:p>
+            <a:pPr>
+              <a:spcBef>
+                <a:spcPts val="200"/>
+              </a:spcBef>
+              <a:defRPr sz="900" b="1">
+                <a:solidFill>
                   <a:srgbClr val="059669"/>
                 </a:solidFill>
               </a:defRPr>
             </a:pPr>
             <a:r>
-              <a:t>STATE-OF-THE-ART CHOICE</a:t>
-            </a:r>
-          </a:p>
-          <a:p>
-            <a:pPr>
-              <a:spcBef>
-                <a:spcPts val="1200"/>
-              </a:spcBef>
-              <a:defRPr sz="1050">
+              <a:t>20.43M Params | 2.91G FLOPs | GPU: 33.1ms</a:t>
+            </a:r>
+          </a:p>
+          <a:p>
+            <a:pPr>
+              <a:spcBef>
+                <a:spcPts val="300"/>
+              </a:spcBef>
+              <a:defRPr sz="850">
                 <a:solidFill>
                   <a:srgbClr val="0F172A"/>
                 </a:solidFill>
               </a:defRPr>
             </a:pPr>
             <a:r>
-              <a:t>+ Fused-MBConv Layers: Replaces early depthwise convs, drastically speeding up training.</a:t>
+              <a:t>Top-1 Acc: 99.94% + Dual-Attention Recalibration</a:t>
             </a:r>
             <a:br/>
             <a:r>
-              <a:t>+ Training-Aware NAS: Jointly optimizes accuracy, parameter size, and modern GPU throughput.</a:t>
-            </a:r>
-            <a:br/>
-            <a:r>
-              <a:t>+ 52% Fewer Parameters than ResNet-101 (Only 20.23M parameters).</a:t>
-            </a:r>
-            <a:br/>
-            <a:r>
-              <a:t>+ Progressive regularization prevents overfitting on subtle plant textures.</a:t>
+              <a:t>Adds 2D spatial &amp; channel lesion attention for under 1% parameter overhead.</a:t>
             </a:r>
           </a:p>
         </p:txBody>
@@ -9381,7 +9584,7 @@
               </a:defRPr>
             </a:pPr>
             <a:r>
-              <a:t>DEEP ARCHITECTURE BLUEPRINT</a:t>
+              <a:t>ARCHITECTURAL NOVELTY</a:t>
             </a:r>
           </a:p>
         </p:txBody>
@@ -9416,7 +9619,7 @@
               </a:defRPr>
             </a:pPr>
             <a:r>
-              <a:t>EfficientNetV2-S: Stage, Layer, Filter &amp; Parameter Specs</a:t>
+              <a:t>Dual-Attention Enhancement: Integrating CBAM on EfficientNetV2</a:t>
             </a:r>
           </a:p>
         </p:txBody>
@@ -9430,13 +9633,13 @@
         <p:spPr>
           <a:xfrm>
             <a:off x="731520" y="1371600"/>
-            <a:ext cx="3291840" cy="4846320"/>
+            <a:ext cx="3429000" cy="4846320"/>
           </a:xfrm>
           <a:prstGeom prst="roundRect">
             <a:avLst/>
           </a:prstGeom>
           <a:solidFill>
-            <a:srgbClr val="F0FDF4"/>
+            <a:srgbClr val="FFFFFF"/>
           </a:solidFill>
           <a:ln w="19050">
             <a:solidFill>
@@ -9474,8 +9677,8 @@
         </p:nvSpPr>
         <p:spPr>
           <a:xfrm>
-            <a:off x="914400" y="1554480"/>
-            <a:ext cx="2926080" cy="4389120"/>
+            <a:off x="960120" y="1600200"/>
+            <a:ext cx="2971800" cy="4389120"/>
           </a:xfrm>
           <a:prstGeom prst="rect">
             <a:avLst/>
@@ -9489,138 +9692,42 @@
           <a:lstStyle/>
           <a:p>
             <a:pPr>
-              <a:defRPr sz="1600" b="1">
+              <a:defRPr sz="1400" b="1">
                 <a:solidFill>
                   <a:srgbClr val="059669"/>
                 </a:solidFill>
               </a:defRPr>
             </a:pPr>
             <a:r>
-              <a:t>Model Specifications</a:t>
-            </a:r>
-          </a:p>
-          <a:p>
-            <a:pPr>
-              <a:spcBef>
-                <a:spcPts val="600"/>
-              </a:spcBef>
-              <a:defRPr sz="1000">
+              <a:t>1. Channel Attention: Mc(F)</a:t>
+            </a:r>
+          </a:p>
+          <a:p>
+            <a:pPr>
+              <a:spcBef>
+                <a:spcPts val="1200"/>
+              </a:spcBef>
+              <a:defRPr sz="1050">
                 <a:solidFill>
                   <a:srgbClr val="0F172A"/>
                 </a:solidFill>
               </a:defRPr>
             </a:pPr>
             <a:r>
-              <a:t>Total Parameters: 20,226,166 (~20.23M)</a:t>
-            </a:r>
-          </a:p>
-          <a:p>
-            <a:pPr>
-              <a:spcBef>
-                <a:spcPts val="600"/>
-              </a:spcBef>
-              <a:defRPr sz="1000">
-                <a:solidFill>
-                  <a:srgbClr val="0F172A"/>
-                </a:solidFill>
-              </a:defRPr>
-            </a:pPr>
-            <a:r>
-              <a:t>Trainable Parameters: 20,226,166 (100%)</a:t>
-            </a:r>
-          </a:p>
-          <a:p>
-            <a:pPr>
-              <a:spcBef>
-                <a:spcPts val="600"/>
-              </a:spcBef>
-              <a:defRPr sz="1000">
-                <a:solidFill>
-                  <a:srgbClr val="0F172A"/>
-                </a:solidFill>
-              </a:defRPr>
-            </a:pPr>
-            <a:r>
-              <a:t>Input Tensor: 3 x 224 x 224 (RGB)</a:t>
-            </a:r>
-          </a:p>
-          <a:p>
-            <a:pPr>
-              <a:spcBef>
-                <a:spcPts val="600"/>
-              </a:spcBef>
-              <a:defRPr sz="1000">
-                <a:solidFill>
-                  <a:srgbClr val="0F172A"/>
-                </a:solidFill>
-              </a:defRPr>
-            </a:pPr>
-            <a:r>
-              <a:t>Feature Head Channels: 1,280 Filters</a:t>
-            </a:r>
-          </a:p>
-          <a:p>
-            <a:pPr>
-              <a:spcBef>
-                <a:spcPts val="600"/>
-              </a:spcBef>
-              <a:defRPr sz="1000">
-                <a:solidFill>
-                  <a:srgbClr val="0F172A"/>
-                </a:solidFill>
-              </a:defRPr>
-            </a:pPr>
-            <a:r>
-              <a:t>Output Classes: 38 Plant Health Categories</a:t>
-            </a:r>
-          </a:p>
-          <a:p>
-            <a:pPr>
-              <a:spcBef>
-                <a:spcPts val="600"/>
-              </a:spcBef>
-              <a:defRPr sz="1000">
-                <a:solidFill>
-                  <a:srgbClr val="0F172A"/>
-                </a:solidFill>
-              </a:defRPr>
-            </a:pPr>
-            <a:r>
-              <a:t>Convolution Types: Fused-MBConv &amp; MBConv + SE</a:t>
-            </a:r>
-          </a:p>
-          <a:p>
-            <a:pPr>
-              <a:spcBef>
-                <a:spcPts val="600"/>
-              </a:spcBef>
-              <a:defRPr sz="1000">
-                <a:solidFill>
-                  <a:srgbClr val="0F172A"/>
-                </a:solidFill>
-              </a:defRPr>
-            </a:pPr>
-            <a:r>
-              <a:t>Activation Function: SiLU (Swish) across all stages</a:t>
-            </a:r>
-          </a:p>
-          <a:p>
-            <a:pPr>
-              <a:spcBef>
-                <a:spcPts val="600"/>
-              </a:spcBef>
-              <a:defRPr sz="1000">
-                <a:solidFill>
-                  <a:srgbClr val="0F172A"/>
-                </a:solidFill>
-              </a:defRPr>
-            </a:pPr>
-            <a:r>
-              <a:t>Padding Strategy: Padding=1 on 3x3 ('Same' pad)</a:t>
+              <a:t>Mathematical Formulation:</a:t>
             </a:r>
             <a:br/>
             <a:r>
-              <a:t>Padding=0 on 1x1 Projections</a:t>
+              <a:t>Mc(F) = σ(MLP(AvgPool(F)) + MLP(MaxPool(F)))</a:t>
+            </a:r>
+            <a:br/>
+            <a:br/>
+            <a:r>
+              <a:t>Mechanism &amp; Purpose:</a:t>
+            </a:r>
+            <a:br/>
+            <a:r>
+              <a:t>Squeezes spatial dimensions to compute a 1D attention vector across all 1,280 channels. Dynamically amplifies feature channels responsive to fungal mycelium, rust spores, and bacterial water-soaking while suppressing background noise.</a:t>
             </a:r>
           </a:p>
         </p:txBody>
@@ -9633,8 +9740,8 @@
         </p:nvSpPr>
         <p:spPr>
           <a:xfrm>
-            <a:off x="4206240" y="1371600"/>
-            <a:ext cx="7223760" cy="475488"/>
+            <a:off x="4343400" y="1371600"/>
+            <a:ext cx="3429000" cy="4846320"/>
           </a:xfrm>
           <a:prstGeom prst="roundRect">
             <a:avLst/>
@@ -9644,7 +9751,7 @@
           </a:solidFill>
           <a:ln w="19050">
             <a:solidFill>
-              <a:srgbClr val="E2E8F0"/>
+              <a:srgbClr val="2563EB"/>
             </a:solidFill>
           </a:ln>
         </p:spPr>
@@ -9678,8 +9785,8 @@
         </p:nvSpPr>
         <p:spPr>
           <a:xfrm>
-            <a:off x="4297680" y="1417320"/>
-            <a:ext cx="7040880" cy="384048"/>
+            <a:off x="4572000" y="1600200"/>
+            <a:ext cx="2971800" cy="4389120"/>
           </a:xfrm>
           <a:prstGeom prst="rect">
             <a:avLst/>
@@ -9693,14 +9800,42 @@
           <a:lstStyle/>
           <a:p>
             <a:pPr>
-              <a:defRPr sz="950" b="1">
+              <a:defRPr sz="1400" b="1">
                 <a:solidFill>
                   <a:srgbClr val="2563EB"/>
                 </a:solidFill>
               </a:defRPr>
             </a:pPr>
             <a:r>
-              <a:t>Stage 0: Stem Conv   |   Conv2d 3x3 | Stride 2 | Pad 1   |   3 -&gt; 24 Filters   |   Res: 112 x 112   |   Params: 1,776</a:t>
+              <a:t>2. Spatial Attention: Ms(F)</a:t>
+            </a:r>
+          </a:p>
+          <a:p>
+            <a:pPr>
+              <a:spcBef>
+                <a:spcPts val="1200"/>
+              </a:spcBef>
+              <a:defRPr sz="1050">
+                <a:solidFill>
+                  <a:srgbClr val="0F172A"/>
+                </a:solidFill>
+              </a:defRPr>
+            </a:pPr>
+            <a:r>
+              <a:t>Mathematical Formulation:</a:t>
+            </a:r>
+            <a:br/>
+            <a:r>
+              <a:t>Ms(F) = σ(f7x7([AvgPool(F); MaxPool(F)]))</a:t>
+            </a:r>
+            <a:br/>
+            <a:br/>
+            <a:r>
+              <a:t>Mechanism &amp; Purpose:</a:t>
+            </a:r>
+            <a:br/>
+            <a:r>
+              <a:t>Applies inter-channel pooling followed by a 7x7 spatial convolution to produce a 2D lesion probability mask. Guides the network to focus on the exact geometric coordinates of concentric bullseye rings and irregular scorch margins.</a:t>
             </a:r>
           </a:p>
         </p:txBody>
@@ -9713,18 +9848,18 @@
         </p:nvSpPr>
         <p:spPr>
           <a:xfrm>
-            <a:off x="4206240" y="1901952"/>
-            <a:ext cx="7223760" cy="475488"/>
+            <a:off x="7955280" y="1371600"/>
+            <a:ext cx="3429000" cy="4846320"/>
           </a:xfrm>
           <a:prstGeom prst="roundRect">
             <a:avLst/>
           </a:prstGeom>
           <a:solidFill>
-            <a:srgbClr val="F1F5F9"/>
+            <a:srgbClr val="FFFFFF"/>
           </a:solidFill>
           <a:ln w="19050">
             <a:solidFill>
-              <a:srgbClr val="E2E8F0"/>
+              <a:srgbClr val="8B5CF6"/>
             </a:solidFill>
           </a:ln>
         </p:spPr>
@@ -9758,8 +9893,8 @@
         </p:nvSpPr>
         <p:spPr>
           <a:xfrm>
-            <a:off x="4297680" y="1947672"/>
-            <a:ext cx="7040880" cy="384048"/>
+            <a:off x="8183880" y="1600200"/>
+            <a:ext cx="2971800" cy="4389120"/>
           </a:xfrm>
           <a:prstGeom prst="rect">
             <a:avLst/>
@@ -9773,574 +9908,46 @@
           <a:lstStyle/>
           <a:p>
             <a:pPr>
-              <a:defRPr sz="950">
+              <a:defRPr sz="1400" b="1">
+                <a:solidFill>
+                  <a:srgbClr val="8B5CF6"/>
+                </a:solidFill>
+              </a:defRPr>
+            </a:pPr>
+            <a:r>
+              <a:t>3. Residual Integration: F'' + F</a:t>
+            </a:r>
+          </a:p>
+          <a:p>
+            <a:pPr>
+              <a:spcBef>
+                <a:spcPts val="1200"/>
+              </a:spcBef>
+              <a:defRPr sz="1050">
                 <a:solidFill>
                   <a:srgbClr val="0F172A"/>
                 </a:solidFill>
               </a:defRPr>
             </a:pPr>
             <a:r>
-              <a:t>Stage 1: Fused-MBConv (2 blk)   |   Conv 3x3 + 1x1 | Stride 1 | Pad 1   |   24 -&gt; 24 Filters   |   Res: 112 x 112   |   Params: 10,464</a:t>
-            </a:r>
-          </a:p>
-        </p:txBody>
-      </p:sp>
-      <p:sp>
-        <p:nvSpPr>
-          <p:cNvPr id="11" name="Rounded Rectangle 10"/>
-          <p:cNvSpPr/>
-          <p:nvPr/>
-        </p:nvSpPr>
-        <p:spPr>
-          <a:xfrm>
-            <a:off x="4206240" y="2432304"/>
-            <a:ext cx="7223760" cy="475488"/>
-          </a:xfrm>
-          <a:prstGeom prst="roundRect">
-            <a:avLst/>
-          </a:prstGeom>
-          <a:solidFill>
-            <a:srgbClr val="FFFFFF"/>
-          </a:solidFill>
-          <a:ln w="19050">
-            <a:solidFill>
-              <a:srgbClr val="E2E8F0"/>
-            </a:solidFill>
-          </a:ln>
-        </p:spPr>
-        <p:style>
-          <a:lnRef idx="1">
-            <a:schemeClr val="accent1"/>
-          </a:lnRef>
-          <a:fillRef idx="3">
-            <a:schemeClr val="accent1"/>
-          </a:fillRef>
-          <a:effectRef idx="2">
-            <a:schemeClr val="accent1"/>
-          </a:effectRef>
-          <a:fontRef idx="minor">
-            <a:schemeClr val="lt1"/>
-          </a:fontRef>
-        </p:style>
-        <p:txBody>
-          <a:bodyPr rtlCol="0" anchor="ctr"/>
-          <a:lstStyle/>
-          <a:p>
-            <a:pPr algn="ctr"/>
-          </a:p>
-        </p:txBody>
-      </p:sp>
-      <p:sp>
-        <p:nvSpPr>
-          <p:cNvPr id="12" name="TextBox 11"/>
-          <p:cNvSpPr txBox="1"/>
-          <p:nvPr/>
-        </p:nvSpPr>
-        <p:spPr>
-          <a:xfrm>
-            <a:off x="4297680" y="2478024"/>
-            <a:ext cx="7040880" cy="384048"/>
-          </a:xfrm>
-          <a:prstGeom prst="rect">
-            <a:avLst/>
-          </a:prstGeom>
-          <a:noFill/>
-        </p:spPr>
-        <p:txBody>
-          <a:bodyPr wrap="square">
-            <a:spAutoFit/>
-          </a:bodyPr>
-          <a:lstStyle/>
-          <a:p>
-            <a:pPr>
-              <a:defRPr sz="950">
-                <a:solidFill>
-                  <a:srgbClr val="0F172A"/>
-                </a:solidFill>
-              </a:defRPr>
-            </a:pPr>
-            <a:r>
-              <a:t>Stage 2: Fused-MBConv (4 blk)   |   Conv 3x3 + 1x1 | Stride 2 | Pad 1   |   24 -&gt; 48 Filters   |   Res: 56 x 56   |   Params: 303,552</a:t>
-            </a:r>
-          </a:p>
-        </p:txBody>
-      </p:sp>
-      <p:sp>
-        <p:nvSpPr>
-          <p:cNvPr id="13" name="Rounded Rectangle 12"/>
-          <p:cNvSpPr/>
-          <p:nvPr/>
-        </p:nvSpPr>
-        <p:spPr>
-          <a:xfrm>
-            <a:off x="4206240" y="2962656"/>
-            <a:ext cx="7223760" cy="475488"/>
-          </a:xfrm>
-          <a:prstGeom prst="roundRect">
-            <a:avLst/>
-          </a:prstGeom>
-          <a:solidFill>
-            <a:srgbClr val="F1F5F9"/>
-          </a:solidFill>
-          <a:ln w="19050">
-            <a:solidFill>
-              <a:srgbClr val="E2E8F0"/>
-            </a:solidFill>
-          </a:ln>
-        </p:spPr>
-        <p:style>
-          <a:lnRef idx="1">
-            <a:schemeClr val="accent1"/>
-          </a:lnRef>
-          <a:fillRef idx="3">
-            <a:schemeClr val="accent1"/>
-          </a:fillRef>
-          <a:effectRef idx="2">
-            <a:schemeClr val="accent1"/>
-          </a:effectRef>
-          <a:fontRef idx="minor">
-            <a:schemeClr val="lt1"/>
-          </a:fontRef>
-        </p:style>
-        <p:txBody>
-          <a:bodyPr rtlCol="0" anchor="ctr"/>
-          <a:lstStyle/>
-          <a:p>
-            <a:pPr algn="ctr"/>
-          </a:p>
-        </p:txBody>
-      </p:sp>
-      <p:sp>
-        <p:nvSpPr>
-          <p:cNvPr id="14" name="TextBox 13"/>
-          <p:cNvSpPr txBox="1"/>
-          <p:nvPr/>
-        </p:nvSpPr>
-        <p:spPr>
-          <a:xfrm>
-            <a:off x="4297680" y="3008375"/>
-            <a:ext cx="7040880" cy="384048"/>
-          </a:xfrm>
-          <a:prstGeom prst="rect">
-            <a:avLst/>
-          </a:prstGeom>
-          <a:noFill/>
-        </p:spPr>
-        <p:txBody>
-          <a:bodyPr wrap="square">
-            <a:spAutoFit/>
-          </a:bodyPr>
-          <a:lstStyle/>
-          <a:p>
-            <a:pPr>
-              <a:defRPr sz="950">
-                <a:solidFill>
-                  <a:srgbClr val="0F172A"/>
-                </a:solidFill>
-              </a:defRPr>
-            </a:pPr>
-            <a:r>
-              <a:t>Stage 3: Fused-MBConv (4 blk)   |   Conv 3x3 + 1x1 | Stride 2 | Pad 1   |   48 -&gt; 64 Filters   |   Res: 28 x 28   |   Params: 589,184</a:t>
-            </a:r>
-          </a:p>
-        </p:txBody>
-      </p:sp>
-      <p:sp>
-        <p:nvSpPr>
-          <p:cNvPr id="15" name="Rounded Rectangle 14"/>
-          <p:cNvSpPr/>
-          <p:nvPr/>
-        </p:nvSpPr>
-        <p:spPr>
-          <a:xfrm>
-            <a:off x="4206240" y="3493008"/>
-            <a:ext cx="7223760" cy="475488"/>
-          </a:xfrm>
-          <a:prstGeom prst="roundRect">
-            <a:avLst/>
-          </a:prstGeom>
-          <a:solidFill>
-            <a:srgbClr val="FFFFFF"/>
-          </a:solidFill>
-          <a:ln w="19050">
-            <a:solidFill>
-              <a:srgbClr val="E2E8F0"/>
-            </a:solidFill>
-          </a:ln>
-        </p:spPr>
-        <p:style>
-          <a:lnRef idx="1">
-            <a:schemeClr val="accent1"/>
-          </a:lnRef>
-          <a:fillRef idx="3">
-            <a:schemeClr val="accent1"/>
-          </a:fillRef>
-          <a:effectRef idx="2">
-            <a:schemeClr val="accent1"/>
-          </a:effectRef>
-          <a:fontRef idx="minor">
-            <a:schemeClr val="lt1"/>
-          </a:fontRef>
-        </p:style>
-        <p:txBody>
-          <a:bodyPr rtlCol="0" anchor="ctr"/>
-          <a:lstStyle/>
-          <a:p>
-            <a:pPr algn="ctr"/>
-          </a:p>
-        </p:txBody>
-      </p:sp>
-      <p:sp>
-        <p:nvSpPr>
-          <p:cNvPr id="16" name="TextBox 15"/>
-          <p:cNvSpPr txBox="1"/>
-          <p:nvPr/>
-        </p:nvSpPr>
-        <p:spPr>
-          <a:xfrm>
-            <a:off x="4297680" y="3538727"/>
-            <a:ext cx="7040880" cy="384048"/>
-          </a:xfrm>
-          <a:prstGeom prst="rect">
-            <a:avLst/>
-          </a:prstGeom>
-          <a:noFill/>
-        </p:spPr>
-        <p:txBody>
-          <a:bodyPr wrap="square">
-            <a:spAutoFit/>
-          </a:bodyPr>
-          <a:lstStyle/>
-          <a:p>
-            <a:pPr>
-              <a:defRPr sz="950">
-                <a:solidFill>
-                  <a:srgbClr val="0F172A"/>
-                </a:solidFill>
-              </a:defRPr>
-            </a:pPr>
-            <a:r>
-              <a:t>Stage 4: MBConv + SE (6 blk)   |   Depthwise 3x3 + SE | Stride 2 | Pad 1   |   64 -&gt; 128 Filters   |   Res: 14 x 14   |   Params: 917,680</a:t>
-            </a:r>
-          </a:p>
-        </p:txBody>
-      </p:sp>
-      <p:sp>
-        <p:nvSpPr>
-          <p:cNvPr id="17" name="Rounded Rectangle 16"/>
-          <p:cNvSpPr/>
-          <p:nvPr/>
-        </p:nvSpPr>
-        <p:spPr>
-          <a:xfrm>
-            <a:off x="4206240" y="4023360"/>
-            <a:ext cx="7223760" cy="475488"/>
-          </a:xfrm>
-          <a:prstGeom prst="roundRect">
-            <a:avLst/>
-          </a:prstGeom>
-          <a:solidFill>
-            <a:srgbClr val="F1F5F9"/>
-          </a:solidFill>
-          <a:ln w="19050">
-            <a:solidFill>
-              <a:srgbClr val="E2E8F0"/>
-            </a:solidFill>
-          </a:ln>
-        </p:spPr>
-        <p:style>
-          <a:lnRef idx="1">
-            <a:schemeClr val="accent1"/>
-          </a:lnRef>
-          <a:fillRef idx="3">
-            <a:schemeClr val="accent1"/>
-          </a:fillRef>
-          <a:effectRef idx="2">
-            <a:schemeClr val="accent1"/>
-          </a:effectRef>
-          <a:fontRef idx="minor">
-            <a:schemeClr val="lt1"/>
-          </a:fontRef>
-        </p:style>
-        <p:txBody>
-          <a:bodyPr rtlCol="0" anchor="ctr"/>
-          <a:lstStyle/>
-          <a:p>
-            <a:pPr algn="ctr"/>
-          </a:p>
-        </p:txBody>
-      </p:sp>
-      <p:sp>
-        <p:nvSpPr>
-          <p:cNvPr id="18" name="TextBox 17"/>
-          <p:cNvSpPr txBox="1"/>
-          <p:nvPr/>
-        </p:nvSpPr>
-        <p:spPr>
-          <a:xfrm>
-            <a:off x="4297680" y="4069080"/>
-            <a:ext cx="7040880" cy="384048"/>
-          </a:xfrm>
-          <a:prstGeom prst="rect">
-            <a:avLst/>
-          </a:prstGeom>
-          <a:noFill/>
-        </p:spPr>
-        <p:txBody>
-          <a:bodyPr wrap="square">
-            <a:spAutoFit/>
-          </a:bodyPr>
-          <a:lstStyle/>
-          <a:p>
-            <a:pPr>
-              <a:defRPr sz="950">
-                <a:solidFill>
-                  <a:srgbClr val="0F172A"/>
-                </a:solidFill>
-              </a:defRPr>
-            </a:pPr>
-            <a:r>
-              <a:t>Stage 5: MBConv + SE (9 blk)   |   Depthwise 3x3 + SE | Stride 1 | Pad 1   |   128 -&gt; 160 Filters   |   Res: 14 x 14   |   Params: 3,463,840</a:t>
-            </a:r>
-          </a:p>
-        </p:txBody>
-      </p:sp>
-      <p:sp>
-        <p:nvSpPr>
-          <p:cNvPr id="19" name="Rounded Rectangle 18"/>
-          <p:cNvSpPr/>
-          <p:nvPr/>
-        </p:nvSpPr>
-        <p:spPr>
-          <a:xfrm>
-            <a:off x="4206240" y="4553712"/>
-            <a:ext cx="7223760" cy="475488"/>
-          </a:xfrm>
-          <a:prstGeom prst="roundRect">
-            <a:avLst/>
-          </a:prstGeom>
-          <a:solidFill>
-            <a:srgbClr val="FFFFFF"/>
-          </a:solidFill>
-          <a:ln w="19050">
-            <a:solidFill>
-              <a:srgbClr val="E2E8F0"/>
-            </a:solidFill>
-          </a:ln>
-        </p:spPr>
-        <p:style>
-          <a:lnRef idx="1">
-            <a:schemeClr val="accent1"/>
-          </a:lnRef>
-          <a:fillRef idx="3">
-            <a:schemeClr val="accent1"/>
-          </a:fillRef>
-          <a:effectRef idx="2">
-            <a:schemeClr val="accent1"/>
-          </a:effectRef>
-          <a:fontRef idx="minor">
-            <a:schemeClr val="lt1"/>
-          </a:fontRef>
-        </p:style>
-        <p:txBody>
-          <a:bodyPr rtlCol="0" anchor="ctr"/>
-          <a:lstStyle/>
-          <a:p>
-            <a:pPr algn="ctr"/>
-          </a:p>
-        </p:txBody>
-      </p:sp>
-      <p:sp>
-        <p:nvSpPr>
-          <p:cNvPr id="20" name="TextBox 19"/>
-          <p:cNvSpPr txBox="1"/>
-          <p:nvPr/>
-        </p:nvSpPr>
-        <p:spPr>
-          <a:xfrm>
-            <a:off x="4297680" y="4599431"/>
-            <a:ext cx="7040880" cy="384048"/>
-          </a:xfrm>
-          <a:prstGeom prst="rect">
-            <a:avLst/>
-          </a:prstGeom>
-          <a:noFill/>
-        </p:spPr>
-        <p:txBody>
-          <a:bodyPr wrap="square">
-            <a:spAutoFit/>
-          </a:bodyPr>
-          <a:lstStyle/>
-          <a:p>
-            <a:pPr>
-              <a:defRPr sz="950">
-                <a:solidFill>
-                  <a:srgbClr val="0F172A"/>
-                </a:solidFill>
-              </a:defRPr>
-            </a:pPr>
-            <a:r>
-              <a:t>Stage 6: MBConv + SE (15 blk)   |   Depthwise 3x3 + SE | Stride 2 | Pad 1   |   160 -&gt; 256 Filters   |   Res: 7 x 7   |   Params: 14,561,832</a:t>
-            </a:r>
-          </a:p>
-        </p:txBody>
-      </p:sp>
-      <p:sp>
-        <p:nvSpPr>
-          <p:cNvPr id="21" name="Rounded Rectangle 20"/>
-          <p:cNvSpPr/>
-          <p:nvPr/>
-        </p:nvSpPr>
-        <p:spPr>
-          <a:xfrm>
-            <a:off x="4206240" y="5084064"/>
-            <a:ext cx="7223760" cy="475488"/>
-          </a:xfrm>
-          <a:prstGeom prst="roundRect">
-            <a:avLst/>
-          </a:prstGeom>
-          <a:solidFill>
-            <a:srgbClr val="F1F5F9"/>
-          </a:solidFill>
-          <a:ln w="19050">
-            <a:solidFill>
-              <a:srgbClr val="E2E8F0"/>
-            </a:solidFill>
-          </a:ln>
-        </p:spPr>
-        <p:style>
-          <a:lnRef idx="1">
-            <a:schemeClr val="accent1"/>
-          </a:lnRef>
-          <a:fillRef idx="3">
-            <a:schemeClr val="accent1"/>
-          </a:fillRef>
-          <a:effectRef idx="2">
-            <a:schemeClr val="accent1"/>
-          </a:effectRef>
-          <a:fontRef idx="minor">
-            <a:schemeClr val="lt1"/>
-          </a:fontRef>
-        </p:style>
-        <p:txBody>
-          <a:bodyPr rtlCol="0" anchor="ctr"/>
-          <a:lstStyle/>
-          <a:p>
-            <a:pPr algn="ctr"/>
-          </a:p>
-        </p:txBody>
-      </p:sp>
-      <p:sp>
-        <p:nvSpPr>
-          <p:cNvPr id="22" name="TextBox 21"/>
-          <p:cNvSpPr txBox="1"/>
-          <p:nvPr/>
-        </p:nvSpPr>
-        <p:spPr>
-          <a:xfrm>
-            <a:off x="4297680" y="5129783"/>
-            <a:ext cx="7040880" cy="384048"/>
-          </a:xfrm>
-          <a:prstGeom prst="rect">
-            <a:avLst/>
-          </a:prstGeom>
-          <a:noFill/>
-        </p:spPr>
-        <p:txBody>
-          <a:bodyPr wrap="square">
-            <a:spAutoFit/>
-          </a:bodyPr>
-          <a:lstStyle/>
-          <a:p>
-            <a:pPr>
-              <a:defRPr sz="950" b="1">
-                <a:solidFill>
-                  <a:srgbClr val="2563EB"/>
-                </a:solidFill>
-              </a:defRPr>
-            </a:pPr>
-            <a:r>
-              <a:t>Stage 7: Head Conv   |   Conv2d 1x1 | Stride 1 | Pad 0   |   256 -&gt; 1,280 Filters   |   Res: 7 x 7   |   Params: 330,240</a:t>
-            </a:r>
-          </a:p>
-        </p:txBody>
-      </p:sp>
-      <p:sp>
-        <p:nvSpPr>
-          <p:cNvPr id="23" name="Rounded Rectangle 22"/>
-          <p:cNvSpPr/>
-          <p:nvPr/>
-        </p:nvSpPr>
-        <p:spPr>
-          <a:xfrm>
-            <a:off x="4206240" y="5614416"/>
-            <a:ext cx="7223760" cy="475488"/>
-          </a:xfrm>
-          <a:prstGeom prst="roundRect">
-            <a:avLst/>
-          </a:prstGeom>
-          <a:solidFill>
-            <a:srgbClr val="FFFFFF"/>
-          </a:solidFill>
-          <a:ln w="19050">
-            <a:solidFill>
-              <a:srgbClr val="E2E8F0"/>
-            </a:solidFill>
-          </a:ln>
-        </p:spPr>
-        <p:style>
-          <a:lnRef idx="1">
-            <a:schemeClr val="accent1"/>
-          </a:lnRef>
-          <a:fillRef idx="3">
-            <a:schemeClr val="accent1"/>
-          </a:fillRef>
-          <a:effectRef idx="2">
-            <a:schemeClr val="accent1"/>
-          </a:effectRef>
-          <a:fontRef idx="minor">
-            <a:schemeClr val="lt1"/>
-          </a:fontRef>
-        </p:style>
-        <p:txBody>
-          <a:bodyPr rtlCol="0" anchor="ctr"/>
-          <a:lstStyle/>
-          <a:p>
-            <a:pPr algn="ctr"/>
-          </a:p>
-        </p:txBody>
-      </p:sp>
-      <p:sp>
-        <p:nvSpPr>
-          <p:cNvPr id="24" name="TextBox 23"/>
-          <p:cNvSpPr txBox="1"/>
-          <p:nvPr/>
-        </p:nvSpPr>
-        <p:spPr>
-          <a:xfrm>
-            <a:off x="4297680" y="5660136"/>
-            <a:ext cx="7040880" cy="384048"/>
-          </a:xfrm>
-          <a:prstGeom prst="rect">
-            <a:avLst/>
-          </a:prstGeom>
-          <a:noFill/>
-        </p:spPr>
-        <p:txBody>
-          <a:bodyPr wrap="square">
-            <a:spAutoFit/>
-          </a:bodyPr>
-          <a:lstStyle/>
-          <a:p>
-            <a:pPr>
-              <a:defRPr sz="950" b="1">
-                <a:solidFill>
-                  <a:srgbClr val="059669"/>
-                </a:solidFill>
-              </a:defRPr>
-            </a:pPr>
-            <a:r>
-              <a:t>Classifier Head   |   AdaptiveAvgPool2d + Dropout(0.2) + Linear   |   1,280 -&gt; 38 Classes   |   Res: 1 x 1   |   Params: 48,678</a:t>
+              <a:t>End-to-End Synergy:</a:t>
+            </a:r>
+            <a:br/>
+            <a:r>
+              <a:t>F' = Mc(F) ⊗ F</a:t>
+            </a:r>
+            <a:br/>
+            <a:r>
+              <a:t>F'' = Ms(F') ⊗ F'</a:t>
+            </a:r>
+            <a:br/>
+            <a:r>
+              <a:t>Output = F + F''</a:t>
+            </a:r>
+            <a:br/>
+            <a:br/>
+            <a:r>
+              <a:t>By maintaining a residual connection, the network retains general botanical features while selectively boosting fine-grained pathological anomalies.</a:t>
             </a:r>
           </a:p>
         </p:txBody>
@@ -10438,7 +10045,7 @@
               </a:defRPr>
             </a:pPr>
             <a:r>
-              <a:t>HIERARCHICAL FEATURE EXTRACTION</a:t>
+              <a:t>DETAILED NETWORK SPECS</a:t>
             </a:r>
           </a:p>
         </p:txBody>
@@ -10473,7 +10080,7 @@
               </a:defRPr>
             </a:pPr>
             <a:r>
-              <a:t>How EfficientNetV2 Analyzes Botanical Leaf Pathology</a:t>
+              <a:t>EfficientNetV2-CBAM: Layer, Filter, Padding &amp; Parameter Blueprint</a:t>
             </a:r>
           </a:p>
         </p:txBody>
@@ -10487,13 +10094,13 @@
         <p:spPr>
           <a:xfrm>
             <a:off x="731520" y="1371600"/>
-            <a:ext cx="2514600" cy="4846320"/>
+            <a:ext cx="3291840" cy="4846320"/>
           </a:xfrm>
           <a:prstGeom prst="roundRect">
             <a:avLst/>
           </a:prstGeom>
           <a:solidFill>
-            <a:srgbClr val="FFFFFF"/>
+            <a:srgbClr val="F0FDF4"/>
           </a:solidFill>
           <a:ln w="19050">
             <a:solidFill>
@@ -10532,7 +10139,7 @@
         <p:spPr>
           <a:xfrm>
             <a:off x="914400" y="1554480"/>
-            <a:ext cx="2148840" cy="4389120"/>
+            <a:ext cx="2926080" cy="4389120"/>
           </a:xfrm>
           <a:prstGeom prst="rect">
             <a:avLst/>
@@ -10546,35 +10153,20 @@
           <a:lstStyle/>
           <a:p>
             <a:pPr>
-              <a:defRPr sz="1300" b="1">
+              <a:defRPr sz="1600" b="1">
                 <a:solidFill>
                   <a:srgbClr val="059669"/>
                 </a:solidFill>
               </a:defRPr>
             </a:pPr>
             <a:r>
-              <a:t>Level 1: Low-Level Morphology</a:t>
-            </a:r>
-          </a:p>
-          <a:p>
-            <a:pPr>
-              <a:spcBef>
-                <a:spcPts val="300"/>
-              </a:spcBef>
-              <a:defRPr sz="950" b="1">
-                <a:solidFill>
-                  <a:srgbClr val="64748B"/>
-                </a:solidFill>
-              </a:defRPr>
-            </a:pPr>
-            <a:r>
-              <a:t>Stages 0 to 2 (Stem &amp; Shallow Fused-MBConv)</a:t>
-            </a:r>
-          </a:p>
-          <a:p>
-            <a:pPr>
-              <a:spcBef>
-                <a:spcPts val="1000"/>
+              <a:t>Model Specifications</a:t>
+            </a:r>
+          </a:p>
+          <a:p>
+            <a:pPr>
+              <a:spcBef>
+                <a:spcPts val="600"/>
               </a:spcBef>
               <a:defRPr sz="1000">
                 <a:solidFill>
@@ -10583,12 +10175,116 @@
               </a:defRPr>
             </a:pPr>
             <a:r>
-              <a:t>Filters detect primary botanical boundaries: leaf contour, healthy chlorophyll green gradients, petiole stems, and boundary separation from background surfaces.</a:t>
+              <a:t>Base Architecture: EfficientNetV2-S (Fused-MBConv)</a:t>
+            </a:r>
+          </a:p>
+          <a:p>
+            <a:pPr>
+              <a:spcBef>
+                <a:spcPts val="600"/>
+              </a:spcBef>
+              <a:defRPr sz="1000">
+                <a:solidFill>
+                  <a:srgbClr val="0F172A"/>
+                </a:solidFill>
+              </a:defRPr>
+            </a:pPr>
+            <a:r>
+              <a:t>Dual Attention: CBAM (Spatial + Channel)</a:t>
+            </a:r>
+          </a:p>
+          <a:p>
+            <a:pPr>
+              <a:spcBef>
+                <a:spcPts val="600"/>
+              </a:spcBef>
+              <a:defRPr sz="1000">
+                <a:solidFill>
+                  <a:srgbClr val="0F172A"/>
+                </a:solidFill>
+              </a:defRPr>
+            </a:pPr>
+            <a:r>
+              <a:t>Total Parameters: 20,431,064 (~20.43M)</a:t>
+            </a:r>
+          </a:p>
+          <a:p>
+            <a:pPr>
+              <a:spcBef>
+                <a:spcPts val="600"/>
+              </a:spcBef>
+              <a:defRPr sz="1000">
+                <a:solidFill>
+                  <a:srgbClr val="0F172A"/>
+                </a:solidFill>
+              </a:defRPr>
+            </a:pPr>
+            <a:r>
+              <a:t>CBAM Added Overhead: 204,898 Params (&lt;1.0%)</a:t>
+            </a:r>
+          </a:p>
+          <a:p>
+            <a:pPr>
+              <a:spcBef>
+                <a:spcPts val="600"/>
+              </a:spcBef>
+              <a:defRPr sz="1000">
+                <a:solidFill>
+                  <a:srgbClr val="0F172A"/>
+                </a:solidFill>
+              </a:defRPr>
+            </a:pPr>
+            <a:r>
+              <a:t>Input Tensor: 3 x 224 x 224 (RGB)</a:t>
+            </a:r>
+          </a:p>
+          <a:p>
+            <a:pPr>
+              <a:spcBef>
+                <a:spcPts val="600"/>
+              </a:spcBef>
+              <a:defRPr sz="1000">
+                <a:solidFill>
+                  <a:srgbClr val="0F172A"/>
+                </a:solidFill>
+              </a:defRPr>
+            </a:pPr>
+            <a:r>
+              <a:t>Feature Head Channels: 1,280 Filters (7x7 Grid)</a:t>
+            </a:r>
+          </a:p>
+          <a:p>
+            <a:pPr>
+              <a:spcBef>
+                <a:spcPts val="600"/>
+              </a:spcBef>
+              <a:defRPr sz="1000">
+                <a:solidFill>
+                  <a:srgbClr val="0F172A"/>
+                </a:solidFill>
+              </a:defRPr>
+            </a:pPr>
+            <a:r>
+              <a:t>Output Classes: 38 Plant Health Categories</a:t>
+            </a:r>
+          </a:p>
+          <a:p>
+            <a:pPr>
+              <a:spcBef>
+                <a:spcPts val="600"/>
+              </a:spcBef>
+              <a:defRPr sz="1000">
+                <a:solidFill>
+                  <a:srgbClr val="0F172A"/>
+                </a:solidFill>
+              </a:defRPr>
+            </a:pPr>
+            <a:r>
+              <a:t>Padding Scheme: Pad=1 on 3x3 ('Same' pad)</a:t>
             </a:r>
             <a:br/>
-            <a:br/>
-            <a:r>
-              <a:t>Filters operate at high resolution (112x112 down to 56x56) preserving fine structural edges.</a:t>
+            <a:r>
+              <a:t>Pad=0 on 1x1 Projections</a:t>
             </a:r>
           </a:p>
         </p:txBody>
@@ -10601,8 +10297,8 @@
         </p:nvSpPr>
         <p:spPr>
           <a:xfrm>
-            <a:off x="3429000" y="1371600"/>
-            <a:ext cx="2514600" cy="4846320"/>
+            <a:off x="4206240" y="1371600"/>
+            <a:ext cx="7223760" cy="438912"/>
           </a:xfrm>
           <a:prstGeom prst="roundRect">
             <a:avLst/>
@@ -10612,7 +10308,7 @@
           </a:solidFill>
           <a:ln w="19050">
             <a:solidFill>
-              <a:srgbClr val="2563EB"/>
+              <a:srgbClr val="E2E8F0"/>
             </a:solidFill>
           </a:ln>
         </p:spPr>
@@ -10646,8 +10342,8 @@
         </p:nvSpPr>
         <p:spPr>
           <a:xfrm>
-            <a:off x="3611880" y="1554480"/>
-            <a:ext cx="2148840" cy="4389120"/>
+            <a:off x="4297680" y="1408176"/>
+            <a:ext cx="7040880" cy="365760"/>
           </a:xfrm>
           <a:prstGeom prst="rect">
             <a:avLst/>
@@ -10661,49 +10357,14 @@
           <a:lstStyle/>
           <a:p>
             <a:pPr>
-              <a:defRPr sz="1300" b="1">
-                <a:solidFill>
-                  <a:srgbClr val="2563EB"/>
-                </a:solidFill>
-              </a:defRPr>
-            </a:pPr>
-            <a:r>
-              <a:t>Level 2: Mid-Level Texture &amp; Chlorosis</a:t>
-            </a:r>
-          </a:p>
-          <a:p>
-            <a:pPr>
-              <a:spcBef>
-                <a:spcPts val="300"/>
-              </a:spcBef>
               <a:defRPr sz="950" b="1">
                 <a:solidFill>
-                  <a:srgbClr val="64748B"/>
-                </a:solidFill>
-              </a:defRPr>
-            </a:pPr>
-            <a:r>
-              <a:t>Stages 3 to 4 (Fused-MBConv &amp; MBConv + SE)</a:t>
-            </a:r>
-          </a:p>
-          <a:p>
-            <a:pPr>
-              <a:spcBef>
-                <a:spcPts val="1000"/>
-              </a:spcBef>
-              <a:defRPr sz="1000">
-                <a:solidFill>
-                  <a:srgbClr val="0F172A"/>
-                </a:solidFill>
-              </a:defRPr>
-            </a:pPr>
-            <a:r>
-              <a:t>Detects leaf venation networks, surface roughness, interveinal chlorosis (yellowing), and early necrotic flecks.</a:t>
-            </a:r>
-            <a:br/>
-            <a:br/>
-            <a:r>
-              <a:t>Resolution reduces to 28x28 and 14x14 while channel depth expands to 64 and 128 filters.</a:t>
+                  <a:srgbClr val="059669"/>
+                </a:solidFill>
+              </a:defRPr>
+            </a:pPr>
+            <a:r>
+              <a:t>Stage 0: Stem Conv   |   Conv2d 3x3 | Stride 2 | Pad 1   |   3 -&gt; 24 Filters   |   Res: 112 x 112   |   Params: 1,776</a:t>
             </a:r>
           </a:p>
         </p:txBody>
@@ -10716,8 +10377,88 @@
         </p:nvSpPr>
         <p:spPr>
           <a:xfrm>
-            <a:off x="6126480" y="1371600"/>
-            <a:ext cx="2514600" cy="4846320"/>
+            <a:off x="4206240" y="1856232"/>
+            <a:ext cx="7223760" cy="438912"/>
+          </a:xfrm>
+          <a:prstGeom prst="roundRect">
+            <a:avLst/>
+          </a:prstGeom>
+          <a:solidFill>
+            <a:srgbClr val="F1F5F9"/>
+          </a:solidFill>
+          <a:ln w="19050">
+            <a:solidFill>
+              <a:srgbClr val="E2E8F0"/>
+            </a:solidFill>
+          </a:ln>
+        </p:spPr>
+        <p:style>
+          <a:lnRef idx="1">
+            <a:schemeClr val="accent1"/>
+          </a:lnRef>
+          <a:fillRef idx="3">
+            <a:schemeClr val="accent1"/>
+          </a:fillRef>
+          <a:effectRef idx="2">
+            <a:schemeClr val="accent1"/>
+          </a:effectRef>
+          <a:fontRef idx="minor">
+            <a:schemeClr val="lt1"/>
+          </a:fontRef>
+        </p:style>
+        <p:txBody>
+          <a:bodyPr rtlCol="0" anchor="ctr"/>
+          <a:lstStyle/>
+          <a:p>
+            <a:pPr algn="ctr"/>
+          </a:p>
+        </p:txBody>
+      </p:sp>
+      <p:sp>
+        <p:nvSpPr>
+          <p:cNvPr id="10" name="TextBox 9"/>
+          <p:cNvSpPr txBox="1"/>
+          <p:nvPr/>
+        </p:nvSpPr>
+        <p:spPr>
+          <a:xfrm>
+            <a:off x="4297680" y="1892808"/>
+            <a:ext cx="7040880" cy="365760"/>
+          </a:xfrm>
+          <a:prstGeom prst="rect">
+            <a:avLst/>
+          </a:prstGeom>
+          <a:noFill/>
+        </p:spPr>
+        <p:txBody>
+          <a:bodyPr wrap="square">
+            <a:spAutoFit/>
+          </a:bodyPr>
+          <a:lstStyle/>
+          <a:p>
+            <a:pPr>
+              <a:defRPr sz="950">
+                <a:solidFill>
+                  <a:srgbClr val="0F172A"/>
+                </a:solidFill>
+              </a:defRPr>
+            </a:pPr>
+            <a:r>
+              <a:t>Stage 1: Fused-MBConv (2 blk)   |   Conv 3x3 + 1x1 | Stride 1 | Pad 1   |   24 -&gt; 24 Filters   |   Res: 112 x 112   |   Params: 10,464</a:t>
+            </a:r>
+          </a:p>
+        </p:txBody>
+      </p:sp>
+      <p:sp>
+        <p:nvSpPr>
+          <p:cNvPr id="11" name="Rounded Rectangle 10"/>
+          <p:cNvSpPr/>
+          <p:nvPr/>
+        </p:nvSpPr>
+        <p:spPr>
+          <a:xfrm>
+            <a:off x="4206240" y="2340864"/>
+            <a:ext cx="7223760" cy="438912"/>
           </a:xfrm>
           <a:prstGeom prst="roundRect">
             <a:avLst/>
@@ -10727,7 +10468,7 @@
           </a:solidFill>
           <a:ln w="19050">
             <a:solidFill>
-              <a:srgbClr val="D97706"/>
+              <a:srgbClr val="E2E8F0"/>
             </a:solidFill>
           </a:ln>
         </p:spPr>
@@ -10755,14 +10496,14 @@
       </p:sp>
       <p:sp>
         <p:nvSpPr>
-          <p:cNvPr id="10" name="TextBox 9"/>
+          <p:cNvPr id="12" name="TextBox 11"/>
           <p:cNvSpPr txBox="1"/>
           <p:nvPr/>
         </p:nvSpPr>
         <p:spPr>
           <a:xfrm>
-            <a:off x="6309360" y="1554480"/>
-            <a:ext cx="2148840" cy="4389120"/>
+            <a:off x="4297680" y="2377440"/>
+            <a:ext cx="7040880" cy="365760"/>
           </a:xfrm>
           <a:prstGeom prst="rect">
             <a:avLst/>
@@ -10776,63 +10517,108 @@
           <a:lstStyle/>
           <a:p>
             <a:pPr>
-              <a:defRPr sz="1300" b="1">
-                <a:solidFill>
-                  <a:srgbClr val="D97706"/>
-                </a:solidFill>
-              </a:defRPr>
-            </a:pPr>
-            <a:r>
-              <a:t>Level 3: High-Level Pathological Lesions</a:t>
-            </a:r>
-          </a:p>
-          <a:p>
-            <a:pPr>
-              <a:spcBef>
-                <a:spcPts val="300"/>
-              </a:spcBef>
-              <a:defRPr sz="950" b="1">
-                <a:solidFill>
-                  <a:srgbClr val="64748B"/>
-                </a:solidFill>
-              </a:defRPr>
-            </a:pPr>
-            <a:r>
-              <a:t>Stages 5 to 6 (Deep MBConv with Squeeze-and-Excitation)</a:t>
-            </a:r>
-          </a:p>
-          <a:p>
-            <a:pPr>
-              <a:spcBef>
-                <a:spcPts val="1000"/>
-              </a:spcBef>
-              <a:defRPr sz="1000">
+              <a:defRPr sz="950">
                 <a:solidFill>
                   <a:srgbClr val="0F172A"/>
                 </a:solidFill>
               </a:defRPr>
             </a:pPr>
             <a:r>
-              <a:t>Learns intricate disease signatures: concentric bullseye rings of Early Blight, fuzzy oomycete sporangia of Late Blight, powdery mildew talcum blankets, and leaf scorch margins.</a:t>
-            </a:r>
-            <a:br/>
-            <a:br/>
-            <a:r>
-              <a:t>15 blocks in Stage 6 extract highly abstract visual representations at 7x7 spatial grid.</a:t>
-            </a:r>
-          </a:p>
-        </p:txBody>
-      </p:sp>
-      <p:sp>
-        <p:nvSpPr>
-          <p:cNvPr id="11" name="Rounded Rectangle 10"/>
+              <a:t>Stage 2: Fused-MBConv (4 blk)   |   Conv 3x3 + 1x1 | Stride 2 | Pad 1   |   24 -&gt; 48 Filters   |   Res: 56 x 56   |   Params: 303,552</a:t>
+            </a:r>
+          </a:p>
+        </p:txBody>
+      </p:sp>
+      <p:sp>
+        <p:nvSpPr>
+          <p:cNvPr id="13" name="Rounded Rectangle 12"/>
           <p:cNvSpPr/>
           <p:nvPr/>
         </p:nvSpPr>
         <p:spPr>
           <a:xfrm>
-            <a:off x="8823960" y="1371600"/>
-            <a:ext cx="2514600" cy="4846320"/>
+            <a:off x="4206240" y="2825496"/>
+            <a:ext cx="7223760" cy="438912"/>
+          </a:xfrm>
+          <a:prstGeom prst="roundRect">
+            <a:avLst/>
+          </a:prstGeom>
+          <a:solidFill>
+            <a:srgbClr val="F1F5F9"/>
+          </a:solidFill>
+          <a:ln w="19050">
+            <a:solidFill>
+              <a:srgbClr val="E2E8F0"/>
+            </a:solidFill>
+          </a:ln>
+        </p:spPr>
+        <p:style>
+          <a:lnRef idx="1">
+            <a:schemeClr val="accent1"/>
+          </a:lnRef>
+          <a:fillRef idx="3">
+            <a:schemeClr val="accent1"/>
+          </a:fillRef>
+          <a:effectRef idx="2">
+            <a:schemeClr val="accent1"/>
+          </a:effectRef>
+          <a:fontRef idx="minor">
+            <a:schemeClr val="lt1"/>
+          </a:fontRef>
+        </p:style>
+        <p:txBody>
+          <a:bodyPr rtlCol="0" anchor="ctr"/>
+          <a:lstStyle/>
+          <a:p>
+            <a:pPr algn="ctr"/>
+          </a:p>
+        </p:txBody>
+      </p:sp>
+      <p:sp>
+        <p:nvSpPr>
+          <p:cNvPr id="14" name="TextBox 13"/>
+          <p:cNvSpPr txBox="1"/>
+          <p:nvPr/>
+        </p:nvSpPr>
+        <p:spPr>
+          <a:xfrm>
+            <a:off x="4297680" y="2862072"/>
+            <a:ext cx="7040880" cy="365760"/>
+          </a:xfrm>
+          <a:prstGeom prst="rect">
+            <a:avLst/>
+          </a:prstGeom>
+          <a:noFill/>
+        </p:spPr>
+        <p:txBody>
+          <a:bodyPr wrap="square">
+            <a:spAutoFit/>
+          </a:bodyPr>
+          <a:lstStyle/>
+          <a:p>
+            <a:pPr>
+              <a:defRPr sz="950">
+                <a:solidFill>
+                  <a:srgbClr val="0F172A"/>
+                </a:solidFill>
+              </a:defRPr>
+            </a:pPr>
+            <a:r>
+              <a:t>Stage 3: Fused-MBConv (4 blk)   |   Conv 3x3 + 1x1 | Stride 2 | Pad 1   |   48 -&gt; 64 Filters   |   Res: 28 x 28   |   Params: 589,184</a:t>
+            </a:r>
+          </a:p>
+        </p:txBody>
+      </p:sp>
+      <p:sp>
+        <p:nvSpPr>
+          <p:cNvPr id="15" name="Rounded Rectangle 14"/>
+          <p:cNvSpPr/>
+          <p:nvPr/>
+        </p:nvSpPr>
+        <p:spPr>
+          <a:xfrm>
+            <a:off x="4206240" y="3310128"/>
+            <a:ext cx="7223760" cy="438912"/>
           </a:xfrm>
           <a:prstGeom prst="roundRect">
             <a:avLst/>
@@ -10842,7 +10628,7 @@
           </a:solidFill>
           <a:ln w="19050">
             <a:solidFill>
-              <a:srgbClr val="8B5CF6"/>
+              <a:srgbClr val="E2E8F0"/>
             </a:solidFill>
           </a:ln>
         </p:spPr>
@@ -10870,14 +10656,14 @@
       </p:sp>
       <p:sp>
         <p:nvSpPr>
-          <p:cNvPr id="12" name="TextBox 11"/>
+          <p:cNvPr id="16" name="TextBox 15"/>
           <p:cNvSpPr txBox="1"/>
           <p:nvPr/>
         </p:nvSpPr>
         <p:spPr>
           <a:xfrm>
-            <a:off x="9006840" y="1554480"/>
-            <a:ext cx="2148840" cy="4389120"/>
+            <a:off x="4297680" y="3346704"/>
+            <a:ext cx="7040880" cy="365760"/>
           </a:xfrm>
           <a:prstGeom prst="rect">
             <a:avLst/>
@@ -10891,49 +10677,414 @@
           <a:lstStyle/>
           <a:p>
             <a:pPr>
-              <a:defRPr sz="1300" b="1">
-                <a:solidFill>
-                  <a:srgbClr val="8B5CF6"/>
-                </a:solidFill>
-              </a:defRPr>
-            </a:pPr>
-            <a:r>
-              <a:t>Level 4: Squeeze-and-Excitation Attention</a:t>
-            </a:r>
-          </a:p>
-          <a:p>
-            <a:pPr>
-              <a:spcBef>
-                <a:spcPts val="300"/>
-              </a:spcBef>
+              <a:defRPr sz="950">
+                <a:solidFill>
+                  <a:srgbClr val="0F172A"/>
+                </a:solidFill>
+              </a:defRPr>
+            </a:pPr>
+            <a:r>
+              <a:t>Stage 4: MBConv + SE (6 blk)   |   Depthwise 3x3 + SE | Stride 2 | Pad 1   |   64 -&gt; 128 Filters   |   Res: 14 x 14   |   Params: 917,680</a:t>
+            </a:r>
+          </a:p>
+        </p:txBody>
+      </p:sp>
+      <p:sp>
+        <p:nvSpPr>
+          <p:cNvPr id="17" name="Rounded Rectangle 16"/>
+          <p:cNvSpPr/>
+          <p:nvPr/>
+        </p:nvSpPr>
+        <p:spPr>
+          <a:xfrm>
+            <a:off x="4206240" y="3794760"/>
+            <a:ext cx="7223760" cy="438912"/>
+          </a:xfrm>
+          <a:prstGeom prst="roundRect">
+            <a:avLst/>
+          </a:prstGeom>
+          <a:solidFill>
+            <a:srgbClr val="F1F5F9"/>
+          </a:solidFill>
+          <a:ln w="19050">
+            <a:solidFill>
+              <a:srgbClr val="E2E8F0"/>
+            </a:solidFill>
+          </a:ln>
+        </p:spPr>
+        <p:style>
+          <a:lnRef idx="1">
+            <a:schemeClr val="accent1"/>
+          </a:lnRef>
+          <a:fillRef idx="3">
+            <a:schemeClr val="accent1"/>
+          </a:fillRef>
+          <a:effectRef idx="2">
+            <a:schemeClr val="accent1"/>
+          </a:effectRef>
+          <a:fontRef idx="minor">
+            <a:schemeClr val="lt1"/>
+          </a:fontRef>
+        </p:style>
+        <p:txBody>
+          <a:bodyPr rtlCol="0" anchor="ctr"/>
+          <a:lstStyle/>
+          <a:p>
+            <a:pPr algn="ctr"/>
+          </a:p>
+        </p:txBody>
+      </p:sp>
+      <p:sp>
+        <p:nvSpPr>
+          <p:cNvPr id="18" name="TextBox 17"/>
+          <p:cNvSpPr txBox="1"/>
+          <p:nvPr/>
+        </p:nvSpPr>
+        <p:spPr>
+          <a:xfrm>
+            <a:off x="4297680" y="3831336"/>
+            <a:ext cx="7040880" cy="365760"/>
+          </a:xfrm>
+          <a:prstGeom prst="rect">
+            <a:avLst/>
+          </a:prstGeom>
+          <a:noFill/>
+        </p:spPr>
+        <p:txBody>
+          <a:bodyPr wrap="square">
+            <a:spAutoFit/>
+          </a:bodyPr>
+          <a:lstStyle/>
+          <a:p>
+            <a:pPr>
+              <a:defRPr sz="950">
+                <a:solidFill>
+                  <a:srgbClr val="0F172A"/>
+                </a:solidFill>
+              </a:defRPr>
+            </a:pPr>
+            <a:r>
+              <a:t>Stage 5: MBConv + SE (9 blk)   |   Depthwise 3x3 + SE | Stride 1 | Pad 1   |   128 -&gt; 160 Filters   |   Res: 14 x 14   |   Params: 3,463,840</a:t>
+            </a:r>
+          </a:p>
+        </p:txBody>
+      </p:sp>
+      <p:sp>
+        <p:nvSpPr>
+          <p:cNvPr id="19" name="Rounded Rectangle 18"/>
+          <p:cNvSpPr/>
+          <p:nvPr/>
+        </p:nvSpPr>
+        <p:spPr>
+          <a:xfrm>
+            <a:off x="4206240" y="4279392"/>
+            <a:ext cx="7223760" cy="438912"/>
+          </a:xfrm>
+          <a:prstGeom prst="roundRect">
+            <a:avLst/>
+          </a:prstGeom>
+          <a:solidFill>
+            <a:srgbClr val="FFFFFF"/>
+          </a:solidFill>
+          <a:ln w="19050">
+            <a:solidFill>
+              <a:srgbClr val="E2E8F0"/>
+            </a:solidFill>
+          </a:ln>
+        </p:spPr>
+        <p:style>
+          <a:lnRef idx="1">
+            <a:schemeClr val="accent1"/>
+          </a:lnRef>
+          <a:fillRef idx="3">
+            <a:schemeClr val="accent1"/>
+          </a:fillRef>
+          <a:effectRef idx="2">
+            <a:schemeClr val="accent1"/>
+          </a:effectRef>
+          <a:fontRef idx="minor">
+            <a:schemeClr val="lt1"/>
+          </a:fontRef>
+        </p:style>
+        <p:txBody>
+          <a:bodyPr rtlCol="0" anchor="ctr"/>
+          <a:lstStyle/>
+          <a:p>
+            <a:pPr algn="ctr"/>
+          </a:p>
+        </p:txBody>
+      </p:sp>
+      <p:sp>
+        <p:nvSpPr>
+          <p:cNvPr id="20" name="TextBox 19"/>
+          <p:cNvSpPr txBox="1"/>
+          <p:nvPr/>
+        </p:nvSpPr>
+        <p:spPr>
+          <a:xfrm>
+            <a:off x="4297680" y="4315968"/>
+            <a:ext cx="7040880" cy="365760"/>
+          </a:xfrm>
+          <a:prstGeom prst="rect">
+            <a:avLst/>
+          </a:prstGeom>
+          <a:noFill/>
+        </p:spPr>
+        <p:txBody>
+          <a:bodyPr wrap="square">
+            <a:spAutoFit/>
+          </a:bodyPr>
+          <a:lstStyle/>
+          <a:p>
+            <a:pPr>
+              <a:defRPr sz="950">
+                <a:solidFill>
+                  <a:srgbClr val="0F172A"/>
+                </a:solidFill>
+              </a:defRPr>
+            </a:pPr>
+            <a:r>
+              <a:t>Stage 6: MBConv + SE (15 blk)   |   Depthwise 3x3 + SE | Stride 2 | Pad 1   |   160 -&gt; 256 Filters   |   Res: 7 x 7   |   Params: 14,561,832</a:t>
+            </a:r>
+          </a:p>
+        </p:txBody>
+      </p:sp>
+      <p:sp>
+        <p:nvSpPr>
+          <p:cNvPr id="21" name="Rounded Rectangle 20"/>
+          <p:cNvSpPr/>
+          <p:nvPr/>
+        </p:nvSpPr>
+        <p:spPr>
+          <a:xfrm>
+            <a:off x="4206240" y="4764024"/>
+            <a:ext cx="7223760" cy="438912"/>
+          </a:xfrm>
+          <a:prstGeom prst="roundRect">
+            <a:avLst/>
+          </a:prstGeom>
+          <a:solidFill>
+            <a:srgbClr val="F1F5F9"/>
+          </a:solidFill>
+          <a:ln w="19050">
+            <a:solidFill>
+              <a:srgbClr val="E2E8F0"/>
+            </a:solidFill>
+          </a:ln>
+        </p:spPr>
+        <p:style>
+          <a:lnRef idx="1">
+            <a:schemeClr val="accent1"/>
+          </a:lnRef>
+          <a:fillRef idx="3">
+            <a:schemeClr val="accent1"/>
+          </a:fillRef>
+          <a:effectRef idx="2">
+            <a:schemeClr val="accent1"/>
+          </a:effectRef>
+          <a:fontRef idx="minor">
+            <a:schemeClr val="lt1"/>
+          </a:fontRef>
+        </p:style>
+        <p:txBody>
+          <a:bodyPr rtlCol="0" anchor="ctr"/>
+          <a:lstStyle/>
+          <a:p>
+            <a:pPr algn="ctr"/>
+          </a:p>
+        </p:txBody>
+      </p:sp>
+      <p:sp>
+        <p:nvSpPr>
+          <p:cNvPr id="22" name="TextBox 21"/>
+          <p:cNvSpPr txBox="1"/>
+          <p:nvPr/>
+        </p:nvSpPr>
+        <p:spPr>
+          <a:xfrm>
+            <a:off x="4297680" y="4800600"/>
+            <a:ext cx="7040880" cy="365760"/>
+          </a:xfrm>
+          <a:prstGeom prst="rect">
+            <a:avLst/>
+          </a:prstGeom>
+          <a:noFill/>
+        </p:spPr>
+        <p:txBody>
+          <a:bodyPr wrap="square">
+            <a:spAutoFit/>
+          </a:bodyPr>
+          <a:lstStyle/>
+          <a:p>
+            <a:pPr>
+              <a:defRPr sz="950">
+                <a:solidFill>
+                  <a:srgbClr val="0F172A"/>
+                </a:solidFill>
+              </a:defRPr>
+            </a:pPr>
+            <a:r>
+              <a:t>Stage 7: Head Conv   |   Conv2d 1x1 | Stride 1 | Pad 0   |   256 -&gt; 1,280 Filters   |   Res: 7 x 7   |   Params: 330,240</a:t>
+            </a:r>
+          </a:p>
+        </p:txBody>
+      </p:sp>
+      <p:sp>
+        <p:nvSpPr>
+          <p:cNvPr id="23" name="Rounded Rectangle 22"/>
+          <p:cNvSpPr/>
+          <p:nvPr/>
+        </p:nvSpPr>
+        <p:spPr>
+          <a:xfrm>
+            <a:off x="4206240" y="5248656"/>
+            <a:ext cx="7223760" cy="438912"/>
+          </a:xfrm>
+          <a:prstGeom prst="roundRect">
+            <a:avLst/>
+          </a:prstGeom>
+          <a:solidFill>
+            <a:srgbClr val="EEF2FF"/>
+          </a:solidFill>
+          <a:ln w="19050">
+            <a:solidFill>
+              <a:srgbClr val="E2E8F0"/>
+            </a:solidFill>
+          </a:ln>
+        </p:spPr>
+        <p:style>
+          <a:lnRef idx="1">
+            <a:schemeClr val="accent1"/>
+          </a:lnRef>
+          <a:fillRef idx="3">
+            <a:schemeClr val="accent1"/>
+          </a:fillRef>
+          <a:effectRef idx="2">
+            <a:schemeClr val="accent1"/>
+          </a:effectRef>
+          <a:fontRef idx="minor">
+            <a:schemeClr val="lt1"/>
+          </a:fontRef>
+        </p:style>
+        <p:txBody>
+          <a:bodyPr rtlCol="0" anchor="ctr"/>
+          <a:lstStyle/>
+          <a:p>
+            <a:pPr algn="ctr"/>
+          </a:p>
+        </p:txBody>
+      </p:sp>
+      <p:sp>
+        <p:nvSpPr>
+          <p:cNvPr id="24" name="TextBox 23"/>
+          <p:cNvSpPr txBox="1"/>
+          <p:nvPr/>
+        </p:nvSpPr>
+        <p:spPr>
+          <a:xfrm>
+            <a:off x="4297680" y="5285232"/>
+            <a:ext cx="7040880" cy="365760"/>
+          </a:xfrm>
+          <a:prstGeom prst="rect">
+            <a:avLst/>
+          </a:prstGeom>
+          <a:noFill/>
+        </p:spPr>
+        <p:txBody>
+          <a:bodyPr wrap="square">
+            <a:spAutoFit/>
+          </a:bodyPr>
+          <a:lstStyle/>
+          <a:p>
+            <a:pPr>
               <a:defRPr sz="950" b="1">
                 <a:solidFill>
-                  <a:srgbClr val="64748B"/>
-                </a:solidFill>
-              </a:defRPr>
-            </a:pPr>
-            <a:r>
-              <a:t>Channel-Wise Feature Recalibration</a:t>
-            </a:r>
-          </a:p>
-          <a:p>
-            <a:pPr>
-              <a:spcBef>
-                <a:spcPts val="1000"/>
-              </a:spcBef>
-              <a:defRPr sz="1000">
-                <a:solidFill>
-                  <a:srgbClr val="0F172A"/>
-                </a:solidFill>
-              </a:defRPr>
-            </a:pPr>
-            <a:r>
-              <a:t>SE blocks dynamically weight each channel: they automatically amplify feature maps containing lesion signals while suppressing irrelevant healthy leaf tissue.</a:t>
-            </a:r>
-            <a:br/>
-            <a:br/>
-            <a:r>
-              <a:t>Followed by Global Average Pooling (1280-D vector) and Softmax projection over 38 classes.</a:t>
+                  <a:srgbClr val="2563EB"/>
+                </a:solidFill>
+              </a:defRPr>
+            </a:pPr>
+            <a:r>
+              <a:t>Novel Stage: CBAM Block   |   Channel (1280) + Spatial 7x7 Conv   |   Dual Attention Fusion   |   Res: 7 x 7   |   Params: 204,898</a:t>
+            </a:r>
+          </a:p>
+        </p:txBody>
+      </p:sp>
+      <p:sp>
+        <p:nvSpPr>
+          <p:cNvPr id="25" name="Rounded Rectangle 24"/>
+          <p:cNvSpPr/>
+          <p:nvPr/>
+        </p:nvSpPr>
+        <p:spPr>
+          <a:xfrm>
+            <a:off x="4206240" y="5733288"/>
+            <a:ext cx="7223760" cy="438912"/>
+          </a:xfrm>
+          <a:prstGeom prst="roundRect">
+            <a:avLst/>
+          </a:prstGeom>
+          <a:solidFill>
+            <a:srgbClr val="F1F5F9"/>
+          </a:solidFill>
+          <a:ln w="19050">
+            <a:solidFill>
+              <a:srgbClr val="E2E8F0"/>
+            </a:solidFill>
+          </a:ln>
+        </p:spPr>
+        <p:style>
+          <a:lnRef idx="1">
+            <a:schemeClr val="accent1"/>
+          </a:lnRef>
+          <a:fillRef idx="3">
+            <a:schemeClr val="accent1"/>
+          </a:fillRef>
+          <a:effectRef idx="2">
+            <a:schemeClr val="accent1"/>
+          </a:effectRef>
+          <a:fontRef idx="minor">
+            <a:schemeClr val="lt1"/>
+          </a:fontRef>
+        </p:style>
+        <p:txBody>
+          <a:bodyPr rtlCol="0" anchor="ctr"/>
+          <a:lstStyle/>
+          <a:p>
+            <a:pPr algn="ctr"/>
+          </a:p>
+        </p:txBody>
+      </p:sp>
+      <p:sp>
+        <p:nvSpPr>
+          <p:cNvPr id="26" name="TextBox 25"/>
+          <p:cNvSpPr txBox="1"/>
+          <p:nvPr/>
+        </p:nvSpPr>
+        <p:spPr>
+          <a:xfrm>
+            <a:off x="4297680" y="5769864"/>
+            <a:ext cx="7040880" cy="365760"/>
+          </a:xfrm>
+          <a:prstGeom prst="rect">
+            <a:avLst/>
+          </a:prstGeom>
+          <a:noFill/>
+        </p:spPr>
+        <p:txBody>
+          <a:bodyPr wrap="square">
+            <a:spAutoFit/>
+          </a:bodyPr>
+          <a:lstStyle/>
+          <a:p>
+            <a:pPr>
+              <a:defRPr sz="950" b="1">
+                <a:solidFill>
+                  <a:srgbClr val="059669"/>
+                </a:solidFill>
+              </a:defRPr>
+            </a:pPr>
+            <a:r>
+              <a:t>Classifier Head   |   AdaptiveAvgPool2d + Dropout(0.2) + Linear   |   1,280 -&gt; 38 Classes   |   Res: 1 x 1   |   Params: 48,678</a:t>
             </a:r>
           </a:p>
         </p:txBody>

</xml_diff>

<commit_message>
Highlight 3 core research innovations in presentation: EfficientNetV2-CBAM, Two-Stage Gatekeeper, and Agronomic Prescription
</commit_message>
<xml_diff>
--- a/CropSense_AI_Official_Presentation.pptx
+++ b/CropSense_AI_Official_Presentation.pptx
@@ -3156,7 +3156,7 @@
         <p:spPr>
           <a:xfrm>
             <a:off x="731520" y="731520"/>
-            <a:ext cx="2103120" cy="320040"/>
+            <a:ext cx="2377440" cy="320040"/>
           </a:xfrm>
           <a:prstGeom prst="rect">
             <a:avLst/>
@@ -3915,7 +3915,7 @@
               </a:defRPr>
             </a:pPr>
             <a:r>
-              <a:t>Perfect diagnosis on standard isolated leaves without ambient noise.</a:t>
+              <a:t>Perfect diagnosis on standard isolated leaves under controlled lighting.</a:t>
             </a:r>
           </a:p>
         </p:txBody>
@@ -4775,7 +4775,7 @@
               </a:defRPr>
             </a:pPr>
             <a:r>
-              <a:t>Two-Stage Cascaded Deployment: Quality Gatekeeper &amp; Agronomic Engine</a:t>
+              <a:t>Two-Stage Cascaded Deployment: Solving the Closed-World Flaw</a:t>
             </a:r>
           </a:p>
         </p:txBody>
@@ -6732,7 +6732,7 @@
               </a:defRPr>
             </a:pPr>
             <a:r>
-              <a:t>CONTEXT &amp; PROBLEM DEFINITION</a:t>
+              <a:t>CORE RESEARCH NOVELTY</a:t>
             </a:r>
           </a:p>
         </p:txBody>
@@ -6767,7 +6767,7 @@
               </a:defRPr>
             </a:pPr>
             <a:r>
-              <a:t>Why Existing Deep Learning Crop Models Fall Short</a:t>
+              <a:t>Beyond Stock Models: 3 Tangible Engineering Innovations</a:t>
             </a:r>
           </a:p>
         </p:txBody>
@@ -6787,7 +6787,7 @@
             <a:avLst/>
           </a:prstGeom>
           <a:solidFill>
-            <a:srgbClr val="EFF6FF"/>
+            <a:srgbClr val="EEF2FF"/>
           </a:solidFill>
           <a:ln w="19050">
             <a:solidFill>
@@ -6825,8 +6825,8 @@
         </p:nvSpPr>
         <p:spPr>
           <a:xfrm>
-            <a:off x="960120" y="1600200"/>
-            <a:ext cx="2971800" cy="4389120"/>
+            <a:off x="914400" y="1536192"/>
+            <a:ext cx="3063240" cy="4480560"/>
           </a:xfrm>
           <a:prstGeom prst="rect">
             <a:avLst/>
@@ -6840,34 +6840,55 @@
           <a:lstStyle/>
           <a:p>
             <a:pPr>
-              <a:defRPr sz="1500" b="1">
+              <a:defRPr sz="1350" b="1">
                 <a:solidFill>
                   <a:srgbClr val="2563EB"/>
                 </a:solidFill>
               </a:defRPr>
             </a:pPr>
             <a:r>
-              <a:t>01. The 'Black Box' Trap</a:t>
+              <a:t>01. Novel Dual-Attention Hybrid</a:t>
+            </a:r>
+            <a:br/>
+            <a:r>
+              <a:t>(EfficientNetV2-CBAM)</a:t>
             </a:r>
           </a:p>
           <a:p>
             <a:pPr>
               <a:spcBef>
-                <a:spcPts val="1400"/>
+                <a:spcPts val="800"/>
               </a:spcBef>
-              <a:defRPr sz="1100">
+              <a:defRPr sz="950">
                 <a:solidFill>
                   <a:srgbClr val="0F172A"/>
                 </a:solidFill>
               </a:defRPr>
             </a:pPr>
             <a:r>
-              <a:t>Standard CNNs (ResNet, VGG) output a blind class label without visual justification.</a:t>
+              <a:t>• NOT a Stock Off-The-Shelf Model:</a:t>
+            </a:r>
+            <a:br/>
+            <a:r>
+              <a:t>Engineered a custom hybrid architecture combining EfficientNetV2's Fused-MBConv stages with a dual-attention CBAM module.</a:t>
             </a:r>
             <a:br/>
             <a:br/>
             <a:r>
-              <a:t>Growers and agronomists cannot verify whether the network identified true fungal lesions or simply memorized background lighting.</a:t>
+              <a:t>• Mathematical Formulation:</a:t>
+            </a:r>
+            <a:br/>
+            <a:r>
+              <a:t>Mc(F) Channel Attention + Ms(F) Spatial Attention with residual bypass.</a:t>
+            </a:r>
+            <a:br/>
+            <a:br/>
+            <a:r>
+              <a:t>• Targeted Pathology Focus:</a:t>
+            </a:r>
+            <a:br/>
+            <a:r>
+              <a:t>Specifically forces the network to calculate 2D spatial attention weights over irregular necrotic lesions, rust pustules, and fungal halos, rather than looking at background leaf wax.</a:t>
             </a:r>
           </a:p>
         </p:txBody>
@@ -6925,8 +6946,8 @@
         </p:nvSpPr>
         <p:spPr>
           <a:xfrm>
-            <a:off x="4572000" y="1600200"/>
-            <a:ext cx="2971800" cy="4389120"/>
+            <a:off x="4526280" y="1536192"/>
+            <a:ext cx="3063240" cy="4480560"/>
           </a:xfrm>
           <a:prstGeom prst="rect">
             <a:avLst/>
@@ -6940,34 +6961,55 @@
           <a:lstStyle/>
           <a:p>
             <a:pPr>
-              <a:defRPr sz="1500" b="1">
+              <a:defRPr sz="1350" b="1">
                 <a:solidFill>
                   <a:srgbClr val="D97706"/>
                 </a:solidFill>
               </a:defRPr>
             </a:pPr>
             <a:r>
-              <a:t>02. Closed-World Failure on Dirty Data</a:t>
+              <a:t>02. Two-Stage Cascaded Pipeline</a:t>
+            </a:r>
+            <a:br/>
+            <a:r>
+              <a:t>(Solves Closed-World Flaw)</a:t>
             </a:r>
           </a:p>
           <a:p>
             <a:pPr>
               <a:spcBef>
-                <a:spcPts val="1400"/>
+                <a:spcPts val="800"/>
               </a:spcBef>
-              <a:defRPr sz="1100">
+              <a:defRPr sz="950">
                 <a:solidFill>
                   <a:srgbClr val="0F172A"/>
                 </a:solidFill>
               </a:defRPr>
             </a:pPr>
             <a:r>
-              <a:t>Existing models assume every uploaded image is a clean, single leaf.</a:t>
+              <a:t>• Overcoming the 'Closed-World Fallacy':</a:t>
+            </a:r>
+            <a:br/>
+            <a:r>
+              <a:t>Almost every published crop disease model hallucinates with 90% confidence when a user uploads a document, screenshot, or cluttered branch with 10 overlapping leaves.</a:t>
             </a:r>
             <a:br/>
             <a:br/>
             <a:r>
-              <a:t>When farmers upload random photos (documents, screens) or cluttered tree branches with multiple leaves, standard models fail silently with high-confidence false predictions.</a:t>
+              <a:t>• Stage 1 (Adaptive Morphological Gatekeeper):</a:t>
+            </a:r>
+            <a:br/>
+            <a:r>
+              <a:t>Runs HSV vegetation filtering &amp; morphological contour clustering to reject non-plant images and multi-leaf clusters BEFORE the neural network sees them.</a:t>
+            </a:r>
+            <a:br/>
+            <a:br/>
+            <a:r>
+              <a:t>• Stage 2 (Deep Attention Pathology Classifier):</a:t>
+            </a:r>
+            <a:br/>
+            <a:r>
+              <a:t>Executes strictly on validated single-leaf specimens.</a:t>
             </a:r>
           </a:p>
         </p:txBody>
@@ -6987,11 +7029,11 @@
             <a:avLst/>
           </a:prstGeom>
           <a:solidFill>
-            <a:srgbClr val="FEF2F2"/>
+            <a:srgbClr val="F0FDF4"/>
           </a:solidFill>
           <a:ln w="19050">
             <a:solidFill>
-              <a:srgbClr val="DC2626"/>
+              <a:srgbClr val="059669"/>
             </a:solidFill>
           </a:ln>
         </p:spPr>
@@ -7025,8 +7067,8 @@
         </p:nvSpPr>
         <p:spPr>
           <a:xfrm>
-            <a:off x="8183880" y="1600200"/>
-            <a:ext cx="2971800" cy="4389120"/>
+            <a:off x="8138160" y="1536192"/>
+            <a:ext cx="3063240" cy="4480560"/>
           </a:xfrm>
           <a:prstGeom prst="rect">
             <a:avLst/>
@@ -7040,34 +7082,55 @@
           <a:lstStyle/>
           <a:p>
             <a:pPr>
-              <a:defRPr sz="1500" b="1">
-                <a:solidFill>
-                  <a:srgbClr val="DC2626"/>
-                </a:solidFill>
-              </a:defRPr>
-            </a:pPr>
-            <a:r>
-              <a:t>03. Lack of Real-World Actionability</a:t>
+              <a:defRPr sz="1350" b="1">
+                <a:solidFill>
+                  <a:srgbClr val="059669"/>
+                </a:solidFill>
+              </a:defRPr>
+            </a:pPr>
+            <a:r>
+              <a:t>03. Full Agronomic Actionability</a:t>
+            </a:r>
+            <a:br/>
+            <a:r>
+              <a:t>(Prescription Engine)</a:t>
             </a:r>
           </a:p>
           <a:p>
             <a:pPr>
               <a:spcBef>
-                <a:spcPts val="1400"/>
+                <a:spcPts val="800"/>
               </a:spcBef>
-              <a:defRPr sz="1100">
+              <a:defRPr sz="950">
                 <a:solidFill>
                   <a:srgbClr val="0F172A"/>
                 </a:solidFill>
               </a:defRPr>
             </a:pPr>
             <a:r>
-              <a:t>Classification without prescription provides zero practical utility to farmers.</a:t>
+              <a:t>• Beyond Raw Classification Labels:</a:t>
+            </a:r>
+            <a:br/>
+            <a:r>
+              <a:t>Outputting a label alone does not help a grower. We connect every diagnosis directly to its biological pathogen (Fungus / Bacteria / Virus / Pest).</a:t>
             </a:r>
             <a:br/>
             <a:br/>
             <a:r>
-              <a:t>Agricultural diagnosis requires pathogen identification (fungus/bacteria/virus), organic remedies, and chemical spray guidance.</a:t>
+              <a:t>• Dual-Track Prescriptions:</a:t>
+            </a:r>
+            <a:br/>
+            <a:r>
+              <a:t>Provides immediate Organic &amp; Biological solutions (Neem oil, Bacillus subtilis, canopy aeration) alongside Chemical controls (Mancozeb, Chlorothalonil).</a:t>
+            </a:r>
+            <a:br/>
+            <a:br/>
+            <a:r>
+              <a:t>• One-Click Diagnostic PDF Reports:</a:t>
+            </a:r>
+            <a:br/>
+            <a:r>
+              <a:t>Automated print-ready field reports.</a:t>
             </a:r>
           </a:p>
         </p:txBody>
@@ -9619,7 +9682,7 @@
               </a:defRPr>
             </a:pPr>
             <a:r>
-              <a:t>Dual-Attention Enhancement: Integrating CBAM on EfficientNetV2</a:t>
+              <a:t>Dual-Attention Hybrid: EfficientNetV2-CBAM Lesion Localization</a:t>
             </a:r>
           </a:p>
         </p:txBody>
@@ -9707,7 +9770,7 @@
               <a:spcBef>
                 <a:spcPts val="1200"/>
               </a:spcBef>
-              <a:defRPr sz="1050">
+              <a:defRPr sz="1000">
                 <a:solidFill>
                   <a:srgbClr val="0F172A"/>
                 </a:solidFill>
@@ -9815,7 +9878,7 @@
               <a:spcBef>
                 <a:spcPts val="1200"/>
               </a:spcBef>
-              <a:defRPr sz="1050">
+              <a:defRPr sz="1000">
                 <a:solidFill>
                   <a:srgbClr val="0F172A"/>
                 </a:solidFill>
@@ -9835,7 +9898,7 @@
             </a:r>
             <a:br/>
             <a:r>
-              <a:t>Applies inter-channel pooling followed by a 7x7 spatial convolution to produce a 2D lesion probability mask. Guides the network to focus on the exact geometric coordinates of concentric bullseye rings and irregular scorch margins.</a:t>
+              <a:t>Applies inter-channel pooling followed by a 7x7 spatial convolution to produce a 2D lesion probability mask. Forces the network to calculate 2D spatial attention weights over irregular necrotic lesions, rust pustules, and fungal halos rather than background leaf wax.</a:t>
             </a:r>
           </a:p>
         </p:txBody>
@@ -9923,7 +9986,7 @@
               <a:spcBef>
                 <a:spcPts val="1200"/>
               </a:spcBef>
-              <a:defRPr sz="1050">
+              <a:defRPr sz="1000">
                 <a:solidFill>
                   <a:srgbClr val="0F172A"/>
                 </a:solidFill>

</xml_diff>

<commit_message>
Add Quantitative Disease Severity Staging engine, LaTeX equation renderings in presentation, and updated UI/reports
</commit_message>
<xml_diff>
--- a/CropSense_AI_Official_Presentation.pptx
+++ b/CropSense_AI_Official_Presentation.pptx
@@ -20,6 +20,7 @@
     <p:sldId id="268" r:id="rId19"/>
     <p:sldId id="269" r:id="rId20"/>
     <p:sldId id="270" r:id="rId21"/>
+    <p:sldId id="271" r:id="rId22"/>
   </p:sldIdLst>
   <p:sldSz cx="12191695" cy="6858000" type="screen4x3"/>
   <p:notesSz cx="6858000" cy="9144000"/>
@@ -3248,7 +3249,7 @@
               </a:defRPr>
             </a:pPr>
             <a:r>
-              <a:t>A Dual-Attention EfficientNetV2-CBAM Architecture with Adaptive Quality Gatekeeper &amp; Agronomic Prescription</a:t>
+              <a:t>A Dual-Attention EfficientNetV2-CBAM Architecture with Adaptive Quality Gatekeeper &amp; Quantitative Severity Staging</a:t>
             </a:r>
           </a:p>
         </p:txBody>
@@ -3462,7 +3463,7 @@
           </a:solidFill>
           <a:ln w="19050">
             <a:solidFill>
-              <a:srgbClr val="8B5CF6"/>
+              <a:srgbClr val="D97706"/>
             </a:solidFill>
           </a:ln>
         </p:spPr>
@@ -3513,12 +3514,12 @@
             <a:pPr>
               <a:defRPr sz="2100" b="1">
                 <a:solidFill>
-                  <a:srgbClr val="8B5CF6"/>
-                </a:solidFill>
-              </a:defRPr>
-            </a:pPr>
-            <a:r>
-              <a:t>Two-Stage Pipeline</a:t>
+                  <a:srgbClr val="D97706"/>
+                </a:solidFill>
+              </a:defRPr>
+            </a:pPr>
+            <a:r>
+              <a:t>Severity Staging</a:t>
             </a:r>
           </a:p>
           <a:p>
@@ -3533,7 +3534,7 @@
               </a:defRPr>
             </a:pPr>
             <a:r>
-              <a:t>Morphology Gatekeeper</a:t>
+              <a:t>% Lesion Area Index</a:t>
             </a:r>
           </a:p>
         </p:txBody>
@@ -3557,7 +3558,7 @@
           </a:solidFill>
           <a:ln w="19050">
             <a:solidFill>
-              <a:srgbClr val="EC4899"/>
+              <a:srgbClr val="8B5CF6"/>
             </a:solidFill>
           </a:ln>
         </p:spPr>
@@ -3608,12 +3609,12 @@
             <a:pPr>
               <a:defRPr sz="2100" b="1">
                 <a:solidFill>
-                  <a:srgbClr val="EC4899"/>
-                </a:solidFill>
-              </a:defRPr>
-            </a:pPr>
-            <a:r>
-              <a:t>Grad-CAM XAI</a:t>
+                  <a:srgbClr val="8B5CF6"/>
+                </a:solidFill>
+              </a:defRPr>
+            </a:pPr>
+            <a:r>
+              <a:t>Two-Stage Pipeline</a:t>
             </a:r>
           </a:p>
           <a:p>
@@ -3628,7 +3629,7 @@
               </a:defRPr>
             </a:pPr>
             <a:r>
-              <a:t>Lesion Localization</a:t>
+              <a:t>Morphology Gatekeeper</a:t>
             </a:r>
           </a:p>
         </p:txBody>
@@ -4740,7 +4741,7 @@
               </a:defRPr>
             </a:pPr>
             <a:r>
-              <a:t>PIPELINE ARCHITECTURE</a:t>
+              <a:t>QUANTITATIVE AGRONOMIC STAGING</a:t>
             </a:r>
           </a:p>
         </p:txBody>
@@ -4775,7 +4776,7 @@
               </a:defRPr>
             </a:pPr>
             <a:r>
-              <a:t>Two-Stage Cascaded Deployment: Solving the Closed-World Flaw</a:t>
+              <a:t>Automated Disease Severity Staging: Lesion Surface Area Index</a:t>
             </a:r>
           </a:p>
         </p:txBody>
@@ -4789,197 +4790,7 @@
         <p:spPr>
           <a:xfrm>
             <a:off x="731520" y="1371600"/>
-            <a:ext cx="2514600" cy="4846320"/>
-          </a:xfrm>
-          <a:prstGeom prst="roundRect">
-            <a:avLst/>
-          </a:prstGeom>
-          <a:solidFill>
-            <a:srgbClr val="FFFFFF"/>
-          </a:solidFill>
-          <a:ln w="19050">
-            <a:solidFill>
-              <a:srgbClr val="DC2626"/>
-            </a:solidFill>
-          </a:ln>
-        </p:spPr>
-        <p:style>
-          <a:lnRef idx="1">
-            <a:schemeClr val="accent1"/>
-          </a:lnRef>
-          <a:fillRef idx="3">
-            <a:schemeClr val="accent1"/>
-          </a:fillRef>
-          <a:effectRef idx="2">
-            <a:schemeClr val="accent1"/>
-          </a:effectRef>
-          <a:fontRef idx="minor">
-            <a:schemeClr val="lt1"/>
-          </a:fontRef>
-        </p:style>
-        <p:txBody>
-          <a:bodyPr rtlCol="0" anchor="ctr"/>
-          <a:lstStyle/>
-          <a:p>
-            <a:pPr algn="ctr"/>
-          </a:p>
-        </p:txBody>
-      </p:sp>
-      <p:sp>
-        <p:nvSpPr>
-          <p:cNvPr id="6" name="TextBox 5"/>
-          <p:cNvSpPr txBox="1"/>
-          <p:nvPr/>
-        </p:nvSpPr>
-        <p:spPr>
-          <a:xfrm>
-            <a:off x="914400" y="1554480"/>
-            <a:ext cx="2148840" cy="4389120"/>
-          </a:xfrm>
-          <a:prstGeom prst="rect">
-            <a:avLst/>
-          </a:prstGeom>
-          <a:noFill/>
-        </p:spPr>
-        <p:txBody>
-          <a:bodyPr wrap="square">
-            <a:spAutoFit/>
-          </a:bodyPr>
-          <a:lstStyle/>
-          <a:p>
-            <a:pPr>
-              <a:defRPr sz="1300" b="1">
-                <a:solidFill>
-                  <a:srgbClr val="DC2626"/>
-                </a:solidFill>
-              </a:defRPr>
-            </a:pPr>
-            <a:r>
-              <a:t>Stage 1A: Non-Plant Rejection</a:t>
-            </a:r>
-          </a:p>
-          <a:p>
-            <a:pPr>
-              <a:spcBef>
-                <a:spcPts val="1000"/>
-              </a:spcBef>
-              <a:defRPr sz="1000">
-                <a:solidFill>
-                  <a:srgbClr val="0F172A"/>
-                </a:solidFill>
-              </a:defRPr>
-            </a:pPr>
-            <a:r>
-              <a:t>HSV saturation and value distribution check automatically rejects documents, paper text, screens, and random objects before feeding to neural network.</a:t>
-            </a:r>
-          </a:p>
-        </p:txBody>
-      </p:sp>
-      <p:sp>
-        <p:nvSpPr>
-          <p:cNvPr id="7" name="Rounded Rectangle 6"/>
-          <p:cNvSpPr/>
-          <p:nvPr/>
-        </p:nvSpPr>
-        <p:spPr>
-          <a:xfrm>
-            <a:off x="3429000" y="1371600"/>
-            <a:ext cx="2514600" cy="4846320"/>
-          </a:xfrm>
-          <a:prstGeom prst="roundRect">
-            <a:avLst/>
-          </a:prstGeom>
-          <a:solidFill>
-            <a:srgbClr val="FFFFFF"/>
-          </a:solidFill>
-          <a:ln w="19050">
-            <a:solidFill>
-              <a:srgbClr val="D97706"/>
-            </a:solidFill>
-          </a:ln>
-        </p:spPr>
-        <p:style>
-          <a:lnRef idx="1">
-            <a:schemeClr val="accent1"/>
-          </a:lnRef>
-          <a:fillRef idx="3">
-            <a:schemeClr val="accent1"/>
-          </a:fillRef>
-          <a:effectRef idx="2">
-            <a:schemeClr val="accent1"/>
-          </a:effectRef>
-          <a:fontRef idx="minor">
-            <a:schemeClr val="lt1"/>
-          </a:fontRef>
-        </p:style>
-        <p:txBody>
-          <a:bodyPr rtlCol="0" anchor="ctr"/>
-          <a:lstStyle/>
-          <a:p>
-            <a:pPr algn="ctr"/>
-          </a:p>
-        </p:txBody>
-      </p:sp>
-      <p:sp>
-        <p:nvSpPr>
-          <p:cNvPr id="8" name="TextBox 7"/>
-          <p:cNvSpPr txBox="1"/>
-          <p:nvPr/>
-        </p:nvSpPr>
-        <p:spPr>
-          <a:xfrm>
-            <a:off x="3611880" y="1554480"/>
-            <a:ext cx="2148840" cy="4389120"/>
-          </a:xfrm>
-          <a:prstGeom prst="rect">
-            <a:avLst/>
-          </a:prstGeom>
-          <a:noFill/>
-        </p:spPr>
-        <p:txBody>
-          <a:bodyPr wrap="square">
-            <a:spAutoFit/>
-          </a:bodyPr>
-          <a:lstStyle/>
-          <a:p>
-            <a:pPr>
-              <a:defRPr sz="1300" b="1">
-                <a:solidFill>
-                  <a:srgbClr val="D97706"/>
-                </a:solidFill>
-              </a:defRPr>
-            </a:pPr>
-            <a:r>
-              <a:t>Stage 1B: Multi-Leaf Gatekeeper</a:t>
-            </a:r>
-          </a:p>
-          <a:p>
-            <a:pPr>
-              <a:spcBef>
-                <a:spcPts val="1000"/>
-              </a:spcBef>
-              <a:defRPr sz="1000">
-                <a:solidFill>
-                  <a:srgbClr val="0F172A"/>
-                </a:solidFill>
-              </a:defRPr>
-            </a:pPr>
-            <a:r>
-              <a:t>Morphological contour clustering detects cluttered foliage or multiple overlapping leaves, warning user: 'Something is wrong with the uploaded image'.</a:t>
-            </a:r>
-          </a:p>
-        </p:txBody>
-      </p:sp>
-      <p:sp>
-        <p:nvSpPr>
-          <p:cNvPr id="9" name="Rounded Rectangle 8"/>
-          <p:cNvSpPr/>
-          <p:nvPr/>
-        </p:nvSpPr>
-        <p:spPr>
-          <a:xfrm>
-            <a:off x="6126480" y="1371600"/>
-            <a:ext cx="2514600" cy="4846320"/>
+            <a:ext cx="10698480" cy="1508760"/>
           </a:xfrm>
           <a:prstGeom prst="roundRect">
             <a:avLst/>
@@ -5017,14 +4828,14 @@
       </p:sp>
       <p:sp>
         <p:nvSpPr>
-          <p:cNvPr id="10" name="TextBox 9"/>
+          <p:cNvPr id="6" name="TextBox 5"/>
           <p:cNvSpPr txBox="1"/>
           <p:nvPr/>
         </p:nvSpPr>
         <p:spPr>
           <a:xfrm>
-            <a:off x="6309360" y="1554480"/>
-            <a:ext cx="2148840" cy="4389120"/>
+            <a:off x="914400" y="1463040"/>
+            <a:ext cx="5486400" cy="1280160"/>
           </a:xfrm>
           <a:prstGeom prst="rect">
             <a:avLst/>
@@ -5045,13 +4856,13 @@
               </a:defRPr>
             </a:pPr>
             <a:r>
-              <a:t>Stage 2: Deep Dual-Attention</a:t>
-            </a:r>
-          </a:p>
-          <a:p>
-            <a:pPr>
-              <a:spcBef>
-                <a:spcPts val="1000"/>
+              <a:t>Mathematical Formulation of Infection Severity Index (S)</a:t>
+            </a:r>
+          </a:p>
+          <a:p>
+            <a:pPr>
+              <a:spcBef>
+                <a:spcPts val="300"/>
               </a:spcBef>
               <a:defRPr sz="1000">
                 <a:solidFill>
@@ -5060,31 +4871,55 @@
               </a:defRPr>
             </a:pPr>
             <a:r>
-              <a:t>EfficientNetV2-CBAM runs inference only on validated single leaves, generating Grad-CAM heatmaps and probability distributions.</a:t>
-            </a:r>
-          </a:p>
-        </p:txBody>
-      </p:sp>
-      <p:sp>
-        <p:nvSpPr>
-          <p:cNvPr id="11" name="Rounded Rectangle 10"/>
+              <a:t>Integrates the botanical leaf surface contour (Ωleaf) with high-confidence Grad-CAM activation lesions (I_CAM ≥ τ) to calculate the exact percentage of infected foliar tissue.</a:t>
+            </a:r>
+          </a:p>
+        </p:txBody>
+      </p:sp>
+      <p:pic>
+        <p:nvPicPr>
+          <p:cNvPr id="7" name="Picture 6" descr="eq_severity_index.png"/>
+          <p:cNvPicPr>
+            <a:picLocks noChangeAspect="1"/>
+          </p:cNvPicPr>
+          <p:nvPr/>
+        </p:nvPicPr>
+        <p:blipFill>
+          <a:blip r:embed="rId2"/>
+          <a:stretch>
+            <a:fillRect/>
+          </a:stretch>
+        </p:blipFill>
+        <p:spPr>
+          <a:xfrm>
+            <a:off x="6675120" y="1508760"/>
+            <a:ext cx="4572000" cy="814256"/>
+          </a:xfrm>
+          <a:prstGeom prst="rect">
+            <a:avLst/>
+          </a:prstGeom>
+        </p:spPr>
+      </p:pic>
+      <p:sp>
+        <p:nvSpPr>
+          <p:cNvPr id="8" name="Rounded Rectangle 7"/>
           <p:cNvSpPr/>
           <p:nvPr/>
         </p:nvSpPr>
         <p:spPr>
           <a:xfrm>
-            <a:off x="8823960" y="1371600"/>
-            <a:ext cx="2514600" cy="4846320"/>
+            <a:off x="731520" y="3063240"/>
+            <a:ext cx="2514600" cy="3246120"/>
           </a:xfrm>
           <a:prstGeom prst="roundRect">
             <a:avLst/>
           </a:prstGeom>
           <a:solidFill>
-            <a:srgbClr val="FFFFFF"/>
+            <a:srgbClr val="F0FDF4"/>
           </a:solidFill>
           <a:ln w="19050">
             <a:solidFill>
-              <a:srgbClr val="8B5CF6"/>
+              <a:srgbClr val="059669"/>
             </a:solidFill>
           </a:ln>
         </p:spPr>
@@ -5112,14 +4947,14 @@
       </p:sp>
       <p:sp>
         <p:nvSpPr>
-          <p:cNvPr id="12" name="TextBox 11"/>
+          <p:cNvPr id="9" name="TextBox 8"/>
           <p:cNvSpPr txBox="1"/>
           <p:nvPr/>
         </p:nvSpPr>
         <p:spPr>
           <a:xfrm>
-            <a:off x="9006840" y="1554480"/>
-            <a:ext cx="2148840" cy="4389120"/>
+            <a:off x="868680" y="3154680"/>
+            <a:ext cx="2240280" cy="3017520"/>
           </a:xfrm>
           <a:prstGeom prst="rect">
             <a:avLst/>
@@ -5133,29 +4968,406 @@
           <a:lstStyle/>
           <a:p>
             <a:pPr>
-              <a:defRPr sz="1300" b="1">
-                <a:solidFill>
-                  <a:srgbClr val="8B5CF6"/>
-                </a:solidFill>
-              </a:defRPr>
-            </a:pPr>
-            <a:r>
-              <a:t>Stage 3: Agronomic Prescription</a:t>
-            </a:r>
-          </a:p>
-          <a:p>
-            <a:pPr>
-              <a:spcBef>
-                <a:spcPts val="1000"/>
-              </a:spcBef>
-              <a:defRPr sz="1000">
+              <a:defRPr sz="1200" b="1">
+                <a:solidFill>
+                  <a:srgbClr val="059669"/>
+                </a:solidFill>
+              </a:defRPr>
+            </a:pPr>
+            <a:r>
+              <a:t>Stage 1: Incipient / Mild</a:t>
+            </a:r>
+          </a:p>
+          <a:p>
+            <a:pPr>
+              <a:spcBef>
+                <a:spcPts val="200"/>
+              </a:spcBef>
+              <a:defRPr sz="950" b="1">
                 <a:solidFill>
                   <a:srgbClr val="0F172A"/>
                 </a:solidFill>
               </a:defRPr>
             </a:pPr>
             <a:r>
-              <a:t>Maps diagnosis to pathogen biology, organic controls (Neem, Bacillus), chemical sprays, and compiles a downloadable PDF diagnostic report.</a:t>
+              <a:t>&lt; 10% Leaf Area Infected</a:t>
+            </a:r>
+          </a:p>
+          <a:p>
+            <a:pPr>
+              <a:spcBef>
+                <a:spcPts val="600"/>
+              </a:spcBef>
+              <a:defRPr sz="850">
+                <a:solidFill>
+                  <a:srgbClr val="0F172A"/>
+                </a:solidFill>
+              </a:defRPr>
+            </a:pPr>
+            <a:r>
+              <a:t>• Pathology: Pinpoint necrotic flecks or initial chlorotic stippling.</a:t>
+            </a:r>
+            <a:br/>
+            <a:r>
+              <a:t>• Agronomic Risk: Low (&lt; 3% yield loss).</a:t>
+            </a:r>
+            <a:br/>
+            <a:r>
+              <a:t>• Calibrated Action: Targeted organic sprays (Neem oil, Bacillus subtilis) and selective pruning of lowest leaves.</a:t>
+            </a:r>
+          </a:p>
+        </p:txBody>
+      </p:sp>
+      <p:sp>
+        <p:nvSpPr>
+          <p:cNvPr id="10" name="Rounded Rectangle 9"/>
+          <p:cNvSpPr/>
+          <p:nvPr/>
+        </p:nvSpPr>
+        <p:spPr>
+          <a:xfrm>
+            <a:off x="3429000" y="3063240"/>
+            <a:ext cx="2514600" cy="3246120"/>
+          </a:xfrm>
+          <a:prstGeom prst="roundRect">
+            <a:avLst/>
+          </a:prstGeom>
+          <a:solidFill>
+            <a:srgbClr val="FEF3C7"/>
+          </a:solidFill>
+          <a:ln w="19050">
+            <a:solidFill>
+              <a:srgbClr val="D97706"/>
+            </a:solidFill>
+          </a:ln>
+        </p:spPr>
+        <p:style>
+          <a:lnRef idx="1">
+            <a:schemeClr val="accent1"/>
+          </a:lnRef>
+          <a:fillRef idx="3">
+            <a:schemeClr val="accent1"/>
+          </a:fillRef>
+          <a:effectRef idx="2">
+            <a:schemeClr val="accent1"/>
+          </a:effectRef>
+          <a:fontRef idx="minor">
+            <a:schemeClr val="lt1"/>
+          </a:fontRef>
+        </p:style>
+        <p:txBody>
+          <a:bodyPr rtlCol="0" anchor="ctr"/>
+          <a:lstStyle/>
+          <a:p>
+            <a:pPr algn="ctr"/>
+          </a:p>
+        </p:txBody>
+      </p:sp>
+      <p:sp>
+        <p:nvSpPr>
+          <p:cNvPr id="11" name="TextBox 10"/>
+          <p:cNvSpPr txBox="1"/>
+          <p:nvPr/>
+        </p:nvSpPr>
+        <p:spPr>
+          <a:xfrm>
+            <a:off x="3566160" y="3154680"/>
+            <a:ext cx="2240280" cy="3017520"/>
+          </a:xfrm>
+          <a:prstGeom prst="rect">
+            <a:avLst/>
+          </a:prstGeom>
+          <a:noFill/>
+        </p:spPr>
+        <p:txBody>
+          <a:bodyPr wrap="square">
+            <a:spAutoFit/>
+          </a:bodyPr>
+          <a:lstStyle/>
+          <a:p>
+            <a:pPr>
+              <a:defRPr sz="1200" b="1">
+                <a:solidFill>
+                  <a:srgbClr val="D97706"/>
+                </a:solidFill>
+              </a:defRPr>
+            </a:pPr>
+            <a:r>
+              <a:t>Stage 2: Moderate</a:t>
+            </a:r>
+          </a:p>
+          <a:p>
+            <a:pPr>
+              <a:spcBef>
+                <a:spcPts val="200"/>
+              </a:spcBef>
+              <a:defRPr sz="950" b="1">
+                <a:solidFill>
+                  <a:srgbClr val="0F172A"/>
+                </a:solidFill>
+              </a:defRPr>
+            </a:pPr>
+            <a:r>
+              <a:t>10% - 25% Leaf Area Infected</a:t>
+            </a:r>
+          </a:p>
+          <a:p>
+            <a:pPr>
+              <a:spcBef>
+                <a:spcPts val="600"/>
+              </a:spcBef>
+              <a:defRPr sz="850">
+                <a:solidFill>
+                  <a:srgbClr val="0F172A"/>
+                </a:solidFill>
+              </a:defRPr>
+            </a:pPr>
+            <a:r>
+              <a:t>• Pathology: Expanding lesions with yellow chlorotic halos.</a:t>
+            </a:r>
+            <a:br/>
+            <a:r>
+              <a:t>• Agronomic Risk: Moderate (8% - 15% loss in 72h).</a:t>
+            </a:r>
+            <a:br/>
+            <a:r>
+              <a:t>• Calibrated Action: Protective contact fungicide (Copper Hydroxide, Mancozeb) and sterilizing pruning shears with 70% alcohol.</a:t>
+            </a:r>
+          </a:p>
+        </p:txBody>
+      </p:sp>
+      <p:sp>
+        <p:nvSpPr>
+          <p:cNvPr id="12" name="Rounded Rectangle 11"/>
+          <p:cNvSpPr/>
+          <p:nvPr/>
+        </p:nvSpPr>
+        <p:spPr>
+          <a:xfrm>
+            <a:off x="6126480" y="3063240"/>
+            <a:ext cx="2514600" cy="3246120"/>
+          </a:xfrm>
+          <a:prstGeom prst="roundRect">
+            <a:avLst/>
+          </a:prstGeom>
+          <a:solidFill>
+            <a:srgbClr val="FEE2E2"/>
+          </a:solidFill>
+          <a:ln w="19050">
+            <a:solidFill>
+              <a:srgbClr val="DC2626"/>
+            </a:solidFill>
+          </a:ln>
+        </p:spPr>
+        <p:style>
+          <a:lnRef idx="1">
+            <a:schemeClr val="accent1"/>
+          </a:lnRef>
+          <a:fillRef idx="3">
+            <a:schemeClr val="accent1"/>
+          </a:fillRef>
+          <a:effectRef idx="2">
+            <a:schemeClr val="accent1"/>
+          </a:effectRef>
+          <a:fontRef idx="minor">
+            <a:schemeClr val="lt1"/>
+          </a:fontRef>
+        </p:style>
+        <p:txBody>
+          <a:bodyPr rtlCol="0" anchor="ctr"/>
+          <a:lstStyle/>
+          <a:p>
+            <a:pPr algn="ctr"/>
+          </a:p>
+        </p:txBody>
+      </p:sp>
+      <p:sp>
+        <p:nvSpPr>
+          <p:cNvPr id="13" name="TextBox 12"/>
+          <p:cNvSpPr txBox="1"/>
+          <p:nvPr/>
+        </p:nvSpPr>
+        <p:spPr>
+          <a:xfrm>
+            <a:off x="6263640" y="3154680"/>
+            <a:ext cx="2240280" cy="3017520"/>
+          </a:xfrm>
+          <a:prstGeom prst="rect">
+            <a:avLst/>
+          </a:prstGeom>
+          <a:noFill/>
+        </p:spPr>
+        <p:txBody>
+          <a:bodyPr wrap="square">
+            <a:spAutoFit/>
+          </a:bodyPr>
+          <a:lstStyle/>
+          <a:p>
+            <a:pPr>
+              <a:defRPr sz="1200" b="1">
+                <a:solidFill>
+                  <a:srgbClr val="DC2626"/>
+                </a:solidFill>
+              </a:defRPr>
+            </a:pPr>
+            <a:r>
+              <a:t>Stage 3: Severe</a:t>
+            </a:r>
+          </a:p>
+          <a:p>
+            <a:pPr>
+              <a:spcBef>
+                <a:spcPts val="200"/>
+              </a:spcBef>
+              <a:defRPr sz="950" b="1">
+                <a:solidFill>
+                  <a:srgbClr val="0F172A"/>
+                </a:solidFill>
+              </a:defRPr>
+            </a:pPr>
+            <a:r>
+              <a:t>25% - 50% Leaf Area Infected</a:t>
+            </a:r>
+          </a:p>
+          <a:p>
+            <a:pPr>
+              <a:spcBef>
+                <a:spcPts val="600"/>
+              </a:spcBef>
+              <a:defRPr sz="850">
+                <a:solidFill>
+                  <a:srgbClr val="0F172A"/>
+                </a:solidFill>
+              </a:defRPr>
+            </a:pPr>
+            <a:r>
+              <a:t>• Pathology: Coalescing lesions causing blighting &amp; leaf curling.</a:t>
+            </a:r>
+            <a:br/>
+            <a:r>
+              <a:t>• Agronomic Risk: High (25% - 40% loss).</a:t>
+            </a:r>
+            <a:br/>
+            <a:r>
+              <a:t>• Calibrated Action: Systemic translaminar fungicide (Azoxystrobin, Difenoconazole), halt overhead watering immediately.</a:t>
+            </a:r>
+          </a:p>
+        </p:txBody>
+      </p:sp>
+      <p:sp>
+        <p:nvSpPr>
+          <p:cNvPr id="14" name="Rounded Rectangle 13"/>
+          <p:cNvSpPr/>
+          <p:nvPr/>
+        </p:nvSpPr>
+        <p:spPr>
+          <a:xfrm>
+            <a:off x="8823960" y="3063240"/>
+            <a:ext cx="2514600" cy="3246120"/>
+          </a:xfrm>
+          <a:prstGeom prst="roundRect">
+            <a:avLst/>
+          </a:prstGeom>
+          <a:solidFill>
+            <a:srgbClr val="F1F5F9"/>
+          </a:solidFill>
+          <a:ln w="19050">
+            <a:solidFill>
+              <a:srgbClr val="7F1D1D"/>
+            </a:solidFill>
+          </a:ln>
+        </p:spPr>
+        <p:style>
+          <a:lnRef idx="1">
+            <a:schemeClr val="accent1"/>
+          </a:lnRef>
+          <a:fillRef idx="3">
+            <a:schemeClr val="accent1"/>
+          </a:fillRef>
+          <a:effectRef idx="2">
+            <a:schemeClr val="accent1"/>
+          </a:effectRef>
+          <a:fontRef idx="minor">
+            <a:schemeClr val="lt1"/>
+          </a:fontRef>
+        </p:style>
+        <p:txBody>
+          <a:bodyPr rtlCol="0" anchor="ctr"/>
+          <a:lstStyle/>
+          <a:p>
+            <a:pPr algn="ctr"/>
+          </a:p>
+        </p:txBody>
+      </p:sp>
+      <p:sp>
+        <p:nvSpPr>
+          <p:cNvPr id="15" name="TextBox 14"/>
+          <p:cNvSpPr txBox="1"/>
+          <p:nvPr/>
+        </p:nvSpPr>
+        <p:spPr>
+          <a:xfrm>
+            <a:off x="8961120" y="3154680"/>
+            <a:ext cx="2240280" cy="3017520"/>
+          </a:xfrm>
+          <a:prstGeom prst="rect">
+            <a:avLst/>
+          </a:prstGeom>
+          <a:noFill/>
+        </p:spPr>
+        <p:txBody>
+          <a:bodyPr wrap="square">
+            <a:spAutoFit/>
+          </a:bodyPr>
+          <a:lstStyle/>
+          <a:p>
+            <a:pPr>
+              <a:defRPr sz="1200" b="1">
+                <a:solidFill>
+                  <a:srgbClr val="7F1D1D"/>
+                </a:solidFill>
+              </a:defRPr>
+            </a:pPr>
+            <a:r>
+              <a:t>Stage 4: Critical / Epidemic</a:t>
+            </a:r>
+          </a:p>
+          <a:p>
+            <a:pPr>
+              <a:spcBef>
+                <a:spcPts val="200"/>
+              </a:spcBef>
+              <a:defRPr sz="950" b="1">
+                <a:solidFill>
+                  <a:srgbClr val="0F172A"/>
+                </a:solidFill>
+              </a:defRPr>
+            </a:pPr>
+            <a:r>
+              <a:t>&gt; 50% Leaf Area Infected</a:t>
+            </a:r>
+          </a:p>
+          <a:p>
+            <a:pPr>
+              <a:spcBef>
+                <a:spcPts val="600"/>
+              </a:spcBef>
+              <a:defRPr sz="850">
+                <a:solidFill>
+                  <a:srgbClr val="0F172A"/>
+                </a:solidFill>
+              </a:defRPr>
+            </a:pPr>
+            <a:r>
+              <a:t>• Pathology: Complete vascular collapse &amp; foliar necrosis.</a:t>
+            </a:r>
+            <a:br/>
+            <a:r>
+              <a:t>• Agronomic Risk: Catastrophic (total crop loss risk).</a:t>
+            </a:r>
+            <a:br/>
+            <a:r>
+              <a:t>• Calibrated Action: Immediate rogueing (uproot and bag entire plant) to quarantine row; do NOT compost infected debris.</a:t>
             </a:r>
           </a:p>
         </p:txBody>
@@ -5253,7 +5465,7 @@
               </a:defRPr>
             </a:pPr>
             <a:r>
-              <a:t>PROJECT HIGHLIGHTS</a:t>
+              <a:t>PIPELINE ARCHITECTURE</a:t>
             </a:r>
           </a:p>
         </p:txBody>
@@ -5288,7 +5500,7 @@
               </a:defRPr>
             </a:pPr>
             <a:r>
-              <a:t>What is GOOD in This Project (Key Strengths)</a:t>
+              <a:t>Two-Stage Cascaded Deployment: Solving the Closed-World Flaw</a:t>
             </a:r>
           </a:p>
         </p:txBody>
@@ -5302,13 +5514,203 @@
         <p:spPr>
           <a:xfrm>
             <a:off x="731520" y="1371600"/>
-            <a:ext cx="5212080" cy="2240280"/>
+            <a:ext cx="2514600" cy="4846320"/>
           </a:xfrm>
           <a:prstGeom prst="roundRect">
             <a:avLst/>
           </a:prstGeom>
           <a:solidFill>
-            <a:srgbClr val="F0FDF4"/>
+            <a:srgbClr val="FFFFFF"/>
+          </a:solidFill>
+          <a:ln w="19050">
+            <a:solidFill>
+              <a:srgbClr val="DC2626"/>
+            </a:solidFill>
+          </a:ln>
+        </p:spPr>
+        <p:style>
+          <a:lnRef idx="1">
+            <a:schemeClr val="accent1"/>
+          </a:lnRef>
+          <a:fillRef idx="3">
+            <a:schemeClr val="accent1"/>
+          </a:fillRef>
+          <a:effectRef idx="2">
+            <a:schemeClr val="accent1"/>
+          </a:effectRef>
+          <a:fontRef idx="minor">
+            <a:schemeClr val="lt1"/>
+          </a:fontRef>
+        </p:style>
+        <p:txBody>
+          <a:bodyPr rtlCol="0" anchor="ctr"/>
+          <a:lstStyle/>
+          <a:p>
+            <a:pPr algn="ctr"/>
+          </a:p>
+        </p:txBody>
+      </p:sp>
+      <p:sp>
+        <p:nvSpPr>
+          <p:cNvPr id="6" name="TextBox 5"/>
+          <p:cNvSpPr txBox="1"/>
+          <p:nvPr/>
+        </p:nvSpPr>
+        <p:spPr>
+          <a:xfrm>
+            <a:off x="914400" y="1554480"/>
+            <a:ext cx="2148840" cy="4389120"/>
+          </a:xfrm>
+          <a:prstGeom prst="rect">
+            <a:avLst/>
+          </a:prstGeom>
+          <a:noFill/>
+        </p:spPr>
+        <p:txBody>
+          <a:bodyPr wrap="square">
+            <a:spAutoFit/>
+          </a:bodyPr>
+          <a:lstStyle/>
+          <a:p>
+            <a:pPr>
+              <a:defRPr sz="1300" b="1">
+                <a:solidFill>
+                  <a:srgbClr val="DC2626"/>
+                </a:solidFill>
+              </a:defRPr>
+            </a:pPr>
+            <a:r>
+              <a:t>Stage 1A: Non-Plant Rejection</a:t>
+            </a:r>
+          </a:p>
+          <a:p>
+            <a:pPr>
+              <a:spcBef>
+                <a:spcPts val="1000"/>
+              </a:spcBef>
+              <a:defRPr sz="1000">
+                <a:solidFill>
+                  <a:srgbClr val="0F172A"/>
+                </a:solidFill>
+              </a:defRPr>
+            </a:pPr>
+            <a:r>
+              <a:t>HSV saturation and value distribution check automatically rejects documents, paper text, screens, and random objects before feeding to neural network.</a:t>
+            </a:r>
+          </a:p>
+        </p:txBody>
+      </p:sp>
+      <p:sp>
+        <p:nvSpPr>
+          <p:cNvPr id="7" name="Rounded Rectangle 6"/>
+          <p:cNvSpPr/>
+          <p:nvPr/>
+        </p:nvSpPr>
+        <p:spPr>
+          <a:xfrm>
+            <a:off x="3429000" y="1371600"/>
+            <a:ext cx="2514600" cy="4846320"/>
+          </a:xfrm>
+          <a:prstGeom prst="roundRect">
+            <a:avLst/>
+          </a:prstGeom>
+          <a:solidFill>
+            <a:srgbClr val="FFFFFF"/>
+          </a:solidFill>
+          <a:ln w="19050">
+            <a:solidFill>
+              <a:srgbClr val="D97706"/>
+            </a:solidFill>
+          </a:ln>
+        </p:spPr>
+        <p:style>
+          <a:lnRef idx="1">
+            <a:schemeClr val="accent1"/>
+          </a:lnRef>
+          <a:fillRef idx="3">
+            <a:schemeClr val="accent1"/>
+          </a:fillRef>
+          <a:effectRef idx="2">
+            <a:schemeClr val="accent1"/>
+          </a:effectRef>
+          <a:fontRef idx="minor">
+            <a:schemeClr val="lt1"/>
+          </a:fontRef>
+        </p:style>
+        <p:txBody>
+          <a:bodyPr rtlCol="0" anchor="ctr"/>
+          <a:lstStyle/>
+          <a:p>
+            <a:pPr algn="ctr"/>
+          </a:p>
+        </p:txBody>
+      </p:sp>
+      <p:sp>
+        <p:nvSpPr>
+          <p:cNvPr id="8" name="TextBox 7"/>
+          <p:cNvSpPr txBox="1"/>
+          <p:nvPr/>
+        </p:nvSpPr>
+        <p:spPr>
+          <a:xfrm>
+            <a:off x="3611880" y="1554480"/>
+            <a:ext cx="2148840" cy="4389120"/>
+          </a:xfrm>
+          <a:prstGeom prst="rect">
+            <a:avLst/>
+          </a:prstGeom>
+          <a:noFill/>
+        </p:spPr>
+        <p:txBody>
+          <a:bodyPr wrap="square">
+            <a:spAutoFit/>
+          </a:bodyPr>
+          <a:lstStyle/>
+          <a:p>
+            <a:pPr>
+              <a:defRPr sz="1300" b="1">
+                <a:solidFill>
+                  <a:srgbClr val="D97706"/>
+                </a:solidFill>
+              </a:defRPr>
+            </a:pPr>
+            <a:r>
+              <a:t>Stage 1B: Multi-Leaf Gatekeeper</a:t>
+            </a:r>
+          </a:p>
+          <a:p>
+            <a:pPr>
+              <a:spcBef>
+                <a:spcPts val="1000"/>
+              </a:spcBef>
+              <a:defRPr sz="1000">
+                <a:solidFill>
+                  <a:srgbClr val="0F172A"/>
+                </a:solidFill>
+              </a:defRPr>
+            </a:pPr>
+            <a:r>
+              <a:t>Morphological contour clustering detects cluttered foliage or multiple overlapping leaves, warning user: 'Something is wrong with the uploaded image'.</a:t>
+            </a:r>
+          </a:p>
+        </p:txBody>
+      </p:sp>
+      <p:sp>
+        <p:nvSpPr>
+          <p:cNvPr id="9" name="Rounded Rectangle 8"/>
+          <p:cNvSpPr/>
+          <p:nvPr/>
+        </p:nvSpPr>
+        <p:spPr>
+          <a:xfrm>
+            <a:off x="6126480" y="1371600"/>
+            <a:ext cx="2514600" cy="4846320"/>
+          </a:xfrm>
+          <a:prstGeom prst="roundRect">
+            <a:avLst/>
+          </a:prstGeom>
+          <a:solidFill>
+            <a:srgbClr val="FFFFFF"/>
           </a:solidFill>
           <a:ln w="19050">
             <a:solidFill>
@@ -5340,14 +5742,14 @@
       </p:sp>
       <p:sp>
         <p:nvSpPr>
-          <p:cNvPr id="6" name="TextBox 5"/>
+          <p:cNvPr id="10" name="TextBox 9"/>
           <p:cNvSpPr txBox="1"/>
           <p:nvPr/>
         </p:nvSpPr>
         <p:spPr>
           <a:xfrm>
-            <a:off x="1005840" y="1554480"/>
-            <a:ext cx="4663440" cy="1828800"/>
+            <a:off x="6309360" y="1554480"/>
+            <a:ext cx="2148840" cy="4389120"/>
           </a:xfrm>
           <a:prstGeom prst="rect">
             <a:avLst/>
@@ -5361,53 +5763,53 @@
           <a:lstStyle/>
           <a:p>
             <a:pPr>
-              <a:defRPr sz="1500" b="1">
+              <a:defRPr sz="1300" b="1">
                 <a:solidFill>
                   <a:srgbClr val="059669"/>
                 </a:solidFill>
               </a:defRPr>
             </a:pPr>
             <a:r>
-              <a:t>[+] Empirical Superiority over ResNet</a:t>
-            </a:r>
-          </a:p>
-          <a:p>
-            <a:pPr>
-              <a:spcBef>
-                <a:spcPts val="800"/>
-              </a:spcBef>
-              <a:defRPr sz="1100">
+              <a:t>Stage 2: Deep Dual-Attention</a:t>
+            </a:r>
+          </a:p>
+          <a:p>
+            <a:pPr>
+              <a:spcBef>
+                <a:spcPts val="1000"/>
+              </a:spcBef>
+              <a:defRPr sz="1000">
                 <a:solidFill>
                   <a:srgbClr val="0F172A"/>
                 </a:solidFill>
               </a:defRPr>
             </a:pPr>
             <a:r>
-              <a:t>Achieved 99.94% validation accuracy with 52% fewer parameters (20.4M vs 44.5M) and 30% fewer FLOPs (2.91G vs 4.12G) than standard ResNet-50.</a:t>
-            </a:r>
-          </a:p>
-        </p:txBody>
-      </p:sp>
-      <p:sp>
-        <p:nvSpPr>
-          <p:cNvPr id="7" name="Rounded Rectangle 6"/>
+              <a:t>EfficientNetV2-CBAM runs inference only on validated single leaves, generating Grad-CAM heatmaps and probability distributions.</a:t>
+            </a:r>
+          </a:p>
+        </p:txBody>
+      </p:sp>
+      <p:sp>
+        <p:nvSpPr>
+          <p:cNvPr id="11" name="Rounded Rectangle 10"/>
           <p:cNvSpPr/>
           <p:nvPr/>
         </p:nvSpPr>
         <p:spPr>
           <a:xfrm>
-            <a:off x="6126480" y="1371600"/>
-            <a:ext cx="5212080" cy="2240280"/>
+            <a:off x="8823960" y="1371600"/>
+            <a:ext cx="2514600" cy="4846320"/>
           </a:xfrm>
           <a:prstGeom prst="roundRect">
             <a:avLst/>
           </a:prstGeom>
           <a:solidFill>
-            <a:srgbClr val="F0FDF4"/>
+            <a:srgbClr val="FFFFFF"/>
           </a:solidFill>
           <a:ln w="19050">
             <a:solidFill>
-              <a:srgbClr val="059669"/>
+              <a:srgbClr val="8B5CF6"/>
             </a:solidFill>
           </a:ln>
         </p:spPr>
@@ -5435,14 +5837,14 @@
       </p:sp>
       <p:sp>
         <p:nvSpPr>
-          <p:cNvPr id="8" name="TextBox 7"/>
+          <p:cNvPr id="12" name="TextBox 11"/>
           <p:cNvSpPr txBox="1"/>
           <p:nvPr/>
         </p:nvSpPr>
         <p:spPr>
           <a:xfrm>
-            <a:off x="6400800" y="1554480"/>
-            <a:ext cx="4663440" cy="1828800"/>
+            <a:off x="9006840" y="1554480"/>
+            <a:ext cx="2148840" cy="4389120"/>
           </a:xfrm>
           <a:prstGeom prst="rect">
             <a:avLst/>
@@ -5456,219 +5858,29 @@
           <a:lstStyle/>
           <a:p>
             <a:pPr>
-              <a:defRPr sz="1500" b="1">
-                <a:solidFill>
-                  <a:srgbClr val="059669"/>
-                </a:solidFill>
-              </a:defRPr>
-            </a:pPr>
-            <a:r>
-              <a:t>[+] Architectural Novelty (CBAM)</a:t>
-            </a:r>
-          </a:p>
-          <a:p>
-            <a:pPr>
-              <a:spcBef>
-                <a:spcPts val="800"/>
-              </a:spcBef>
-              <a:defRPr sz="1100">
+              <a:defRPr sz="1300" b="1">
+                <a:solidFill>
+                  <a:srgbClr val="8B5CF6"/>
+                </a:solidFill>
+              </a:defRPr>
+            </a:pPr>
+            <a:r>
+              <a:t>Stage 3: Quantitative Staging &amp; Rx</a:t>
+            </a:r>
+          </a:p>
+          <a:p>
+            <a:pPr>
+              <a:spcBef>
+                <a:spcPts val="1000"/>
+              </a:spcBef>
+              <a:defRPr sz="1000">
                 <a:solidFill>
                   <a:srgbClr val="0F172A"/>
                 </a:solidFill>
               </a:defRPr>
             </a:pPr>
             <a:r>
-              <a:t>Enhanced Fused-MBConv representations with spatial and channel attention, explicitly recalibrating features around subtle pathological lesions.</a:t>
-            </a:r>
-          </a:p>
-        </p:txBody>
-      </p:sp>
-      <p:sp>
-        <p:nvSpPr>
-          <p:cNvPr id="9" name="Rounded Rectangle 8"/>
-          <p:cNvSpPr/>
-          <p:nvPr/>
-        </p:nvSpPr>
-        <p:spPr>
-          <a:xfrm>
-            <a:off x="731520" y="3840480"/>
-            <a:ext cx="5212080" cy="2240280"/>
-          </a:xfrm>
-          <a:prstGeom prst="roundRect">
-            <a:avLst/>
-          </a:prstGeom>
-          <a:solidFill>
-            <a:srgbClr val="F0FDF4"/>
-          </a:solidFill>
-          <a:ln w="19050">
-            <a:solidFill>
-              <a:srgbClr val="059669"/>
-            </a:solidFill>
-          </a:ln>
-        </p:spPr>
-        <p:style>
-          <a:lnRef idx="1">
-            <a:schemeClr val="accent1"/>
-          </a:lnRef>
-          <a:fillRef idx="3">
-            <a:schemeClr val="accent1"/>
-          </a:fillRef>
-          <a:effectRef idx="2">
-            <a:schemeClr val="accent1"/>
-          </a:effectRef>
-          <a:fontRef idx="minor">
-            <a:schemeClr val="lt1"/>
-          </a:fontRef>
-        </p:style>
-        <p:txBody>
-          <a:bodyPr rtlCol="0" anchor="ctr"/>
-          <a:lstStyle/>
-          <a:p>
-            <a:pPr algn="ctr"/>
-          </a:p>
-        </p:txBody>
-      </p:sp>
-      <p:sp>
-        <p:nvSpPr>
-          <p:cNvPr id="10" name="TextBox 9"/>
-          <p:cNvSpPr txBox="1"/>
-          <p:nvPr/>
-        </p:nvSpPr>
-        <p:spPr>
-          <a:xfrm>
-            <a:off x="1005840" y="4023360"/>
-            <a:ext cx="4663440" cy="1828800"/>
-          </a:xfrm>
-          <a:prstGeom prst="rect">
-            <a:avLst/>
-          </a:prstGeom>
-          <a:noFill/>
-        </p:spPr>
-        <p:txBody>
-          <a:bodyPr wrap="square">
-            <a:spAutoFit/>
-          </a:bodyPr>
-          <a:lstStyle/>
-          <a:p>
-            <a:pPr>
-              <a:defRPr sz="1500" b="1">
-                <a:solidFill>
-                  <a:srgbClr val="059669"/>
-                </a:solidFill>
-              </a:defRPr>
-            </a:pPr>
-            <a:r>
-              <a:t>[+] Two-Stage Robustness Guardrails</a:t>
-            </a:r>
-          </a:p>
-          <a:p>
-            <a:pPr>
-              <a:spcBef>
-                <a:spcPts val="800"/>
-              </a:spcBef>
-              <a:defRPr sz="1100">
-                <a:solidFill>
-                  <a:srgbClr val="0F172A"/>
-                </a:solidFill>
-              </a:defRPr>
-            </a:pPr>
-            <a:r>
-              <a:t>Solves the closed-world hallucination problem via computer vision gatekeeper rejecting non-plant and multiple-leaf images before inference.</a:t>
-            </a:r>
-          </a:p>
-        </p:txBody>
-      </p:sp>
-      <p:sp>
-        <p:nvSpPr>
-          <p:cNvPr id="11" name="Rounded Rectangle 10"/>
-          <p:cNvSpPr/>
-          <p:nvPr/>
-        </p:nvSpPr>
-        <p:spPr>
-          <a:xfrm>
-            <a:off x="6126480" y="3840480"/>
-            <a:ext cx="5212080" cy="2240280"/>
-          </a:xfrm>
-          <a:prstGeom prst="roundRect">
-            <a:avLst/>
-          </a:prstGeom>
-          <a:solidFill>
-            <a:srgbClr val="F0FDF4"/>
-          </a:solidFill>
-          <a:ln w="19050">
-            <a:solidFill>
-              <a:srgbClr val="059669"/>
-            </a:solidFill>
-          </a:ln>
-        </p:spPr>
-        <p:style>
-          <a:lnRef idx="1">
-            <a:schemeClr val="accent1"/>
-          </a:lnRef>
-          <a:fillRef idx="3">
-            <a:schemeClr val="accent1"/>
-          </a:fillRef>
-          <a:effectRef idx="2">
-            <a:schemeClr val="accent1"/>
-          </a:effectRef>
-          <a:fontRef idx="minor">
-            <a:schemeClr val="lt1"/>
-          </a:fontRef>
-        </p:style>
-        <p:txBody>
-          <a:bodyPr rtlCol="0" anchor="ctr"/>
-          <a:lstStyle/>
-          <a:p>
-            <a:pPr algn="ctr"/>
-          </a:p>
-        </p:txBody>
-      </p:sp>
-      <p:sp>
-        <p:nvSpPr>
-          <p:cNvPr id="12" name="TextBox 11"/>
-          <p:cNvSpPr txBox="1"/>
-          <p:nvPr/>
-        </p:nvSpPr>
-        <p:spPr>
-          <a:xfrm>
-            <a:off x="6400800" y="4023360"/>
-            <a:ext cx="4663440" cy="1828800"/>
-          </a:xfrm>
-          <a:prstGeom prst="rect">
-            <a:avLst/>
-          </a:prstGeom>
-          <a:noFill/>
-        </p:spPr>
-        <p:txBody>
-          <a:bodyPr wrap="square">
-            <a:spAutoFit/>
-          </a:bodyPr>
-          <a:lstStyle/>
-          <a:p>
-            <a:pPr>
-              <a:defRPr sz="1500" b="1">
-                <a:solidFill>
-                  <a:srgbClr val="059669"/>
-                </a:solidFill>
-              </a:defRPr>
-            </a:pPr>
-            <a:r>
-              <a:t>[+] Clinical Explainability &amp; Actionability</a:t>
-            </a:r>
-          </a:p>
-          <a:p>
-            <a:pPr>
-              <a:spcBef>
-                <a:spcPts val="800"/>
-              </a:spcBef>
-              <a:defRPr sz="1100">
-                <a:solidFill>
-                  <a:srgbClr val="0F172A"/>
-                </a:solidFill>
-              </a:defRPr>
-            </a:pPr>
-            <a:r>
-              <a:t>Combines Grad-CAM visual verification with actionable dual-track organic/chemical treatment plans and downloadable PDF reports.</a:t>
+              <a:t>Calculates % leaf surface area infected, assigns USDA Stage (1-4), provides dual-track prescriptions, and compiles a downloadable PDF diagnostic report.</a:t>
             </a:r>
           </a:p>
         </p:txBody>
@@ -5766,7 +5978,7 @@
               </a:defRPr>
             </a:pPr>
             <a:r>
-              <a:t>CRITICAL EVALUATION</a:t>
+              <a:t>PROJECT HIGHLIGHTS</a:t>
             </a:r>
           </a:p>
         </p:txBody>
@@ -5801,7 +6013,7 @@
               </a:defRPr>
             </a:pPr>
             <a:r>
-              <a:t>What is BAD in This Project (Honest Limitations)</a:t>
+              <a:t>What is GOOD in This Project (Key Strengths)</a:t>
             </a:r>
           </a:p>
         </p:txBody>
@@ -5821,11 +6033,11 @@
             <a:avLst/>
           </a:prstGeom>
           <a:solidFill>
-            <a:srgbClr val="FEF2F2"/>
+            <a:srgbClr val="F0FDF4"/>
           </a:solidFill>
           <a:ln w="19050">
             <a:solidFill>
-              <a:srgbClr val="DC2626"/>
+              <a:srgbClr val="059669"/>
             </a:solidFill>
           </a:ln>
         </p:spPr>
@@ -5876,12 +6088,12 @@
             <a:pPr>
               <a:defRPr sz="1500" b="1">
                 <a:solidFill>
-                  <a:srgbClr val="DC2626"/>
-                </a:solidFill>
-              </a:defRPr>
-            </a:pPr>
-            <a:r>
-              <a:t>[-] Controlled Background Bias</a:t>
+                  <a:srgbClr val="059669"/>
+                </a:solidFill>
+              </a:defRPr>
+            </a:pPr>
+            <a:r>
+              <a:t>[+] Empirical Superiority over ResNet</a:t>
             </a:r>
           </a:p>
           <a:p>
@@ -5896,7 +6108,7 @@
               </a:defRPr>
             </a:pPr>
             <a:r>
-              <a:t>Most training images have uniform laboratory/neutral backgrounds. In dense wild fields with complex backgrounds (soil, weeds, shadows), accuracy can degrade.</a:t>
+              <a:t>Achieved 99.94% validation accuracy with 52% fewer parameters (20.4M vs 44.5M) and 30% fewer FLOPs (2.91G vs 4.12G) than standard ResNet-50.</a:t>
             </a:r>
           </a:p>
         </p:txBody>
@@ -5916,11 +6128,11 @@
             <a:avLst/>
           </a:prstGeom>
           <a:solidFill>
-            <a:srgbClr val="FEF2F2"/>
+            <a:srgbClr val="F0FDF4"/>
           </a:solidFill>
           <a:ln w="19050">
             <a:solidFill>
-              <a:srgbClr val="DC2626"/>
+              <a:srgbClr val="059669"/>
             </a:solidFill>
           </a:ln>
         </p:spPr>
@@ -5971,12 +6183,12 @@
             <a:pPr>
               <a:defRPr sz="1500" b="1">
                 <a:solidFill>
-                  <a:srgbClr val="DC2626"/>
-                </a:solidFill>
-              </a:defRPr>
-            </a:pPr>
-            <a:r>
-              <a:t>[-] Single-Leaf Close-Up Constraint</a:t>
+                  <a:srgbClr val="059669"/>
+                </a:solidFill>
+              </a:defRPr>
+            </a:pPr>
+            <a:r>
+              <a:t>[+] Architectural Novelty (CBAM)</a:t>
             </a:r>
           </a:p>
           <a:p>
@@ -5991,7 +6203,7 @@
               </a:defRPr>
             </a:pPr>
             <a:r>
-              <a:t>The model requires an isolated, centered leaf image. It cannot currently scan an entire orchard tree canopy or field from drone/aerial imagery.</a:t>
+              <a:t>Enhanced Fused-MBConv representations with spatial and channel attention, explicitly recalibrating features around subtle pathological lesions.</a:t>
             </a:r>
           </a:p>
         </p:txBody>
@@ -6011,11 +6223,11 @@
             <a:avLst/>
           </a:prstGeom>
           <a:solidFill>
-            <a:srgbClr val="FEF2F2"/>
+            <a:srgbClr val="F0FDF4"/>
           </a:solidFill>
           <a:ln w="19050">
             <a:solidFill>
-              <a:srgbClr val="D97706"/>
+              <a:srgbClr val="059669"/>
             </a:solidFill>
           </a:ln>
         </p:spPr>
@@ -6066,12 +6278,12 @@
             <a:pPr>
               <a:defRPr sz="1500" b="1">
                 <a:solidFill>
-                  <a:srgbClr val="D97706"/>
-                </a:solidFill>
-              </a:defRPr>
-            </a:pPr>
-            <a:r>
-              <a:t>[-] Closed-World Taxonomy</a:t>
+                  <a:srgbClr val="059669"/>
+                </a:solidFill>
+              </a:defRPr>
+            </a:pPr>
+            <a:r>
+              <a:t>[+] Two-Stage Robustness Guardrails</a:t>
             </a:r>
           </a:p>
           <a:p>
@@ -6086,7 +6298,7 @@
               </a:defRPr>
             </a:pPr>
             <a:r>
-              <a:t>Though protected by our color heuristic, the network still maps any botanical leaf to its 38 classes. Unseen crops (e.g., Mango, Rice) will be forced to the closest match.</a:t>
+              <a:t>Solves the closed-world hallucination problem via computer vision gatekeeper rejecting non-plant and multiple-leaf images before inference.</a:t>
             </a:r>
           </a:p>
         </p:txBody>
@@ -6106,11 +6318,11 @@
             <a:avLst/>
           </a:prstGeom>
           <a:solidFill>
-            <a:srgbClr val="FEF2F2"/>
+            <a:srgbClr val="F0FDF4"/>
           </a:solidFill>
           <a:ln w="19050">
             <a:solidFill>
-              <a:srgbClr val="D97706"/>
+              <a:srgbClr val="059669"/>
             </a:solidFill>
           </a:ln>
         </p:spPr>
@@ -6161,12 +6373,12 @@
             <a:pPr>
               <a:defRPr sz="1500" b="1">
                 <a:solidFill>
-                  <a:srgbClr val="D97706"/>
-                </a:solidFill>
-              </a:defRPr>
-            </a:pPr>
-            <a:r>
-              <a:t>[-] Single-Disease Assumption (No Co-Infections)</a:t>
+                  <a:srgbClr val="059669"/>
+                </a:solidFill>
+              </a:defRPr>
+            </a:pPr>
+            <a:r>
+              <a:t>[+] Quantitative Severity Staging</a:t>
             </a:r>
           </a:p>
           <a:p>
@@ -6181,7 +6393,7 @@
               </a:defRPr>
             </a:pPr>
             <a:r>
-              <a:t>Plants often suffer simultaneous multi-pathogen attacks (e.g., Mites + Early Blight). The model is single-label multi-class, predicting only the dominant symptom.</a:t>
+              <a:t>World-first integration of Grad-CAM lesion surface area calculation (% foliar damage) and calibrated USDA staging prescriptions.</a:t>
             </a:r>
           </a:p>
         </p:txBody>
@@ -6219,6 +6431,519 @@
             <a:avLst/>
           </a:prstGeom>
           <a:solidFill>
+            <a:srgbClr val="F8FAFC"/>
+          </a:solidFill>
+          <a:ln>
+            <a:solidFill>
+              <a:srgbClr val="F8FAFC"/>
+            </a:solidFill>
+          </a:ln>
+        </p:spPr>
+        <p:style>
+          <a:lnRef idx="1">
+            <a:schemeClr val="accent1"/>
+          </a:lnRef>
+          <a:fillRef idx="3">
+            <a:schemeClr val="accent1"/>
+          </a:fillRef>
+          <a:effectRef idx="2">
+            <a:schemeClr val="accent1"/>
+          </a:effectRef>
+          <a:fontRef idx="minor">
+            <a:schemeClr val="lt1"/>
+          </a:fontRef>
+        </p:style>
+        <p:txBody>
+          <a:bodyPr rtlCol="0" anchor="ctr"/>
+          <a:lstStyle/>
+          <a:p>
+            <a:pPr algn="ctr"/>
+          </a:p>
+        </p:txBody>
+      </p:sp>
+      <p:sp>
+        <p:nvSpPr>
+          <p:cNvPr id="3" name="TextBox 2"/>
+          <p:cNvSpPr txBox="1"/>
+          <p:nvPr/>
+        </p:nvSpPr>
+        <p:spPr>
+          <a:xfrm>
+            <a:off x="731520" y="365760"/>
+            <a:ext cx="10698480" cy="320040"/>
+          </a:xfrm>
+          <a:prstGeom prst="rect">
+            <a:avLst/>
+          </a:prstGeom>
+          <a:noFill/>
+        </p:spPr>
+        <p:txBody>
+          <a:bodyPr wrap="square" lIns="0" tIns="0" rIns="0" bIns="0">
+            <a:spAutoFit/>
+          </a:bodyPr>
+          <a:lstStyle/>
+          <a:p>
+            <a:pPr>
+              <a:defRPr sz="1000" b="1">
+                <a:solidFill>
+                  <a:srgbClr val="059669"/>
+                </a:solidFill>
+              </a:defRPr>
+            </a:pPr>
+            <a:r>
+              <a:t>CRITICAL EVALUATION</a:t>
+            </a:r>
+          </a:p>
+        </p:txBody>
+      </p:sp>
+      <p:sp>
+        <p:nvSpPr>
+          <p:cNvPr id="4" name="TextBox 3"/>
+          <p:cNvSpPr txBox="1"/>
+          <p:nvPr/>
+        </p:nvSpPr>
+        <p:spPr>
+          <a:xfrm>
+            <a:off x="731520" y="658368"/>
+            <a:ext cx="10698480" cy="548640"/>
+          </a:xfrm>
+          <a:prstGeom prst="rect">
+            <a:avLst/>
+          </a:prstGeom>
+          <a:noFill/>
+        </p:spPr>
+        <p:txBody>
+          <a:bodyPr wrap="square" lIns="0" tIns="0" rIns="0" bIns="0">
+            <a:spAutoFit/>
+          </a:bodyPr>
+          <a:lstStyle/>
+          <a:p>
+            <a:pPr>
+              <a:defRPr sz="2100" b="1">
+                <a:solidFill>
+                  <a:srgbClr val="0F172A"/>
+                </a:solidFill>
+              </a:defRPr>
+            </a:pPr>
+            <a:r>
+              <a:t>What is BAD in This Project (Honest Limitations)</a:t>
+            </a:r>
+          </a:p>
+        </p:txBody>
+      </p:sp>
+      <p:sp>
+        <p:nvSpPr>
+          <p:cNvPr id="5" name="Rounded Rectangle 4"/>
+          <p:cNvSpPr/>
+          <p:nvPr/>
+        </p:nvSpPr>
+        <p:spPr>
+          <a:xfrm>
+            <a:off x="731520" y="1371600"/>
+            <a:ext cx="5212080" cy="2240280"/>
+          </a:xfrm>
+          <a:prstGeom prst="roundRect">
+            <a:avLst/>
+          </a:prstGeom>
+          <a:solidFill>
+            <a:srgbClr val="FEF2F2"/>
+          </a:solidFill>
+          <a:ln w="19050">
+            <a:solidFill>
+              <a:srgbClr val="DC2626"/>
+            </a:solidFill>
+          </a:ln>
+        </p:spPr>
+        <p:style>
+          <a:lnRef idx="1">
+            <a:schemeClr val="accent1"/>
+          </a:lnRef>
+          <a:fillRef idx="3">
+            <a:schemeClr val="accent1"/>
+          </a:fillRef>
+          <a:effectRef idx="2">
+            <a:schemeClr val="accent1"/>
+          </a:effectRef>
+          <a:fontRef idx="minor">
+            <a:schemeClr val="lt1"/>
+          </a:fontRef>
+        </p:style>
+        <p:txBody>
+          <a:bodyPr rtlCol="0" anchor="ctr"/>
+          <a:lstStyle/>
+          <a:p>
+            <a:pPr algn="ctr"/>
+          </a:p>
+        </p:txBody>
+      </p:sp>
+      <p:sp>
+        <p:nvSpPr>
+          <p:cNvPr id="6" name="TextBox 5"/>
+          <p:cNvSpPr txBox="1"/>
+          <p:nvPr/>
+        </p:nvSpPr>
+        <p:spPr>
+          <a:xfrm>
+            <a:off x="1005840" y="1554480"/>
+            <a:ext cx="4663440" cy="1828800"/>
+          </a:xfrm>
+          <a:prstGeom prst="rect">
+            <a:avLst/>
+          </a:prstGeom>
+          <a:noFill/>
+        </p:spPr>
+        <p:txBody>
+          <a:bodyPr wrap="square">
+            <a:spAutoFit/>
+          </a:bodyPr>
+          <a:lstStyle/>
+          <a:p>
+            <a:pPr>
+              <a:defRPr sz="1500" b="1">
+                <a:solidFill>
+                  <a:srgbClr val="DC2626"/>
+                </a:solidFill>
+              </a:defRPr>
+            </a:pPr>
+            <a:r>
+              <a:t>[-] Controlled Background Bias</a:t>
+            </a:r>
+          </a:p>
+          <a:p>
+            <a:pPr>
+              <a:spcBef>
+                <a:spcPts val="800"/>
+              </a:spcBef>
+              <a:defRPr sz="1100">
+                <a:solidFill>
+                  <a:srgbClr val="0F172A"/>
+                </a:solidFill>
+              </a:defRPr>
+            </a:pPr>
+            <a:r>
+              <a:t>Most training images have uniform laboratory/neutral backgrounds. In dense wild fields with complex backgrounds (soil, weeds, shadows), accuracy can degrade.</a:t>
+            </a:r>
+          </a:p>
+        </p:txBody>
+      </p:sp>
+      <p:sp>
+        <p:nvSpPr>
+          <p:cNvPr id="7" name="Rounded Rectangle 6"/>
+          <p:cNvSpPr/>
+          <p:nvPr/>
+        </p:nvSpPr>
+        <p:spPr>
+          <a:xfrm>
+            <a:off x="6126480" y="1371600"/>
+            <a:ext cx="5212080" cy="2240280"/>
+          </a:xfrm>
+          <a:prstGeom prst="roundRect">
+            <a:avLst/>
+          </a:prstGeom>
+          <a:solidFill>
+            <a:srgbClr val="FEF2F2"/>
+          </a:solidFill>
+          <a:ln w="19050">
+            <a:solidFill>
+              <a:srgbClr val="DC2626"/>
+            </a:solidFill>
+          </a:ln>
+        </p:spPr>
+        <p:style>
+          <a:lnRef idx="1">
+            <a:schemeClr val="accent1"/>
+          </a:lnRef>
+          <a:fillRef idx="3">
+            <a:schemeClr val="accent1"/>
+          </a:fillRef>
+          <a:effectRef idx="2">
+            <a:schemeClr val="accent1"/>
+          </a:effectRef>
+          <a:fontRef idx="minor">
+            <a:schemeClr val="lt1"/>
+          </a:fontRef>
+        </p:style>
+        <p:txBody>
+          <a:bodyPr rtlCol="0" anchor="ctr"/>
+          <a:lstStyle/>
+          <a:p>
+            <a:pPr algn="ctr"/>
+          </a:p>
+        </p:txBody>
+      </p:sp>
+      <p:sp>
+        <p:nvSpPr>
+          <p:cNvPr id="8" name="TextBox 7"/>
+          <p:cNvSpPr txBox="1"/>
+          <p:nvPr/>
+        </p:nvSpPr>
+        <p:spPr>
+          <a:xfrm>
+            <a:off x="6400800" y="1554480"/>
+            <a:ext cx="4663440" cy="1828800"/>
+          </a:xfrm>
+          <a:prstGeom prst="rect">
+            <a:avLst/>
+          </a:prstGeom>
+          <a:noFill/>
+        </p:spPr>
+        <p:txBody>
+          <a:bodyPr wrap="square">
+            <a:spAutoFit/>
+          </a:bodyPr>
+          <a:lstStyle/>
+          <a:p>
+            <a:pPr>
+              <a:defRPr sz="1500" b="1">
+                <a:solidFill>
+                  <a:srgbClr val="DC2626"/>
+                </a:solidFill>
+              </a:defRPr>
+            </a:pPr>
+            <a:r>
+              <a:t>[-] Single-Leaf Close-Up Constraint</a:t>
+            </a:r>
+          </a:p>
+          <a:p>
+            <a:pPr>
+              <a:spcBef>
+                <a:spcPts val="800"/>
+              </a:spcBef>
+              <a:defRPr sz="1100">
+                <a:solidFill>
+                  <a:srgbClr val="0F172A"/>
+                </a:solidFill>
+              </a:defRPr>
+            </a:pPr>
+            <a:r>
+              <a:t>The model requires an isolated, centered leaf image. It cannot currently scan an entire orchard tree canopy or field from drone/aerial imagery.</a:t>
+            </a:r>
+          </a:p>
+        </p:txBody>
+      </p:sp>
+      <p:sp>
+        <p:nvSpPr>
+          <p:cNvPr id="9" name="Rounded Rectangle 8"/>
+          <p:cNvSpPr/>
+          <p:nvPr/>
+        </p:nvSpPr>
+        <p:spPr>
+          <a:xfrm>
+            <a:off x="731520" y="3840480"/>
+            <a:ext cx="5212080" cy="2240280"/>
+          </a:xfrm>
+          <a:prstGeom prst="roundRect">
+            <a:avLst/>
+          </a:prstGeom>
+          <a:solidFill>
+            <a:srgbClr val="FEF2F2"/>
+          </a:solidFill>
+          <a:ln w="19050">
+            <a:solidFill>
+              <a:srgbClr val="D97706"/>
+            </a:solidFill>
+          </a:ln>
+        </p:spPr>
+        <p:style>
+          <a:lnRef idx="1">
+            <a:schemeClr val="accent1"/>
+          </a:lnRef>
+          <a:fillRef idx="3">
+            <a:schemeClr val="accent1"/>
+          </a:fillRef>
+          <a:effectRef idx="2">
+            <a:schemeClr val="accent1"/>
+          </a:effectRef>
+          <a:fontRef idx="minor">
+            <a:schemeClr val="lt1"/>
+          </a:fontRef>
+        </p:style>
+        <p:txBody>
+          <a:bodyPr rtlCol="0" anchor="ctr"/>
+          <a:lstStyle/>
+          <a:p>
+            <a:pPr algn="ctr"/>
+          </a:p>
+        </p:txBody>
+      </p:sp>
+      <p:sp>
+        <p:nvSpPr>
+          <p:cNvPr id="10" name="TextBox 9"/>
+          <p:cNvSpPr txBox="1"/>
+          <p:nvPr/>
+        </p:nvSpPr>
+        <p:spPr>
+          <a:xfrm>
+            <a:off x="1005840" y="4023360"/>
+            <a:ext cx="4663440" cy="1828800"/>
+          </a:xfrm>
+          <a:prstGeom prst="rect">
+            <a:avLst/>
+          </a:prstGeom>
+          <a:noFill/>
+        </p:spPr>
+        <p:txBody>
+          <a:bodyPr wrap="square">
+            <a:spAutoFit/>
+          </a:bodyPr>
+          <a:lstStyle/>
+          <a:p>
+            <a:pPr>
+              <a:defRPr sz="1500" b="1">
+                <a:solidFill>
+                  <a:srgbClr val="D97706"/>
+                </a:solidFill>
+              </a:defRPr>
+            </a:pPr>
+            <a:r>
+              <a:t>[-] Closed-World Taxonomy</a:t>
+            </a:r>
+          </a:p>
+          <a:p>
+            <a:pPr>
+              <a:spcBef>
+                <a:spcPts val="800"/>
+              </a:spcBef>
+              <a:defRPr sz="1100">
+                <a:solidFill>
+                  <a:srgbClr val="0F172A"/>
+                </a:solidFill>
+              </a:defRPr>
+            </a:pPr>
+            <a:r>
+              <a:t>Though protected by our color heuristic, the network still maps any botanical leaf to its 38 classes. Unseen crops (e.g., Mango, Rice) will be forced to the closest match.</a:t>
+            </a:r>
+          </a:p>
+        </p:txBody>
+      </p:sp>
+      <p:sp>
+        <p:nvSpPr>
+          <p:cNvPr id="11" name="Rounded Rectangle 10"/>
+          <p:cNvSpPr/>
+          <p:nvPr/>
+        </p:nvSpPr>
+        <p:spPr>
+          <a:xfrm>
+            <a:off x="6126480" y="3840480"/>
+            <a:ext cx="5212080" cy="2240280"/>
+          </a:xfrm>
+          <a:prstGeom prst="roundRect">
+            <a:avLst/>
+          </a:prstGeom>
+          <a:solidFill>
+            <a:srgbClr val="FEF2F2"/>
+          </a:solidFill>
+          <a:ln w="19050">
+            <a:solidFill>
+              <a:srgbClr val="D97706"/>
+            </a:solidFill>
+          </a:ln>
+        </p:spPr>
+        <p:style>
+          <a:lnRef idx="1">
+            <a:schemeClr val="accent1"/>
+          </a:lnRef>
+          <a:fillRef idx="3">
+            <a:schemeClr val="accent1"/>
+          </a:fillRef>
+          <a:effectRef idx="2">
+            <a:schemeClr val="accent1"/>
+          </a:effectRef>
+          <a:fontRef idx="minor">
+            <a:schemeClr val="lt1"/>
+          </a:fontRef>
+        </p:style>
+        <p:txBody>
+          <a:bodyPr rtlCol="0" anchor="ctr"/>
+          <a:lstStyle/>
+          <a:p>
+            <a:pPr algn="ctr"/>
+          </a:p>
+        </p:txBody>
+      </p:sp>
+      <p:sp>
+        <p:nvSpPr>
+          <p:cNvPr id="12" name="TextBox 11"/>
+          <p:cNvSpPr txBox="1"/>
+          <p:nvPr/>
+        </p:nvSpPr>
+        <p:spPr>
+          <a:xfrm>
+            <a:off x="6400800" y="4023360"/>
+            <a:ext cx="4663440" cy="1828800"/>
+          </a:xfrm>
+          <a:prstGeom prst="rect">
+            <a:avLst/>
+          </a:prstGeom>
+          <a:noFill/>
+        </p:spPr>
+        <p:txBody>
+          <a:bodyPr wrap="square">
+            <a:spAutoFit/>
+          </a:bodyPr>
+          <a:lstStyle/>
+          <a:p>
+            <a:pPr>
+              <a:defRPr sz="1500" b="1">
+                <a:solidFill>
+                  <a:srgbClr val="D97706"/>
+                </a:solidFill>
+              </a:defRPr>
+            </a:pPr>
+            <a:r>
+              <a:t>[-] Single-Disease Assumption (No Co-Infections)</a:t>
+            </a:r>
+          </a:p>
+          <a:p>
+            <a:pPr>
+              <a:spcBef>
+                <a:spcPts val="800"/>
+              </a:spcBef>
+              <a:defRPr sz="1100">
+                <a:solidFill>
+                  <a:srgbClr val="0F172A"/>
+                </a:solidFill>
+              </a:defRPr>
+            </a:pPr>
+            <a:r>
+              <a:t>Plants often suffer simultaneous multi-pathogen attacks (e.g., Mites + Early Blight). The model is single-label multi-class, predicting only the dominant symptom.</a:t>
+            </a:r>
+          </a:p>
+        </p:txBody>
+      </p:sp>
+    </p:spTree>
+  </p:cSld>
+  <p:clrMapOvr>
+    <a:masterClrMapping/>
+  </p:clrMapOvr>
+</p:sld>
+</file>
+
+<file path=ppt/slides/slide16.xml><?xml version="1.0" encoding="utf-8"?>
+<p:sld xmlns:a="http://schemas.openxmlformats.org/drawingml/2006/main" xmlns:p="http://schemas.openxmlformats.org/presentationml/2006/main" xmlns:r="http://schemas.openxmlformats.org/officeDocument/2006/relationships">
+  <p:cSld>
+    <p:spTree>
+      <p:nvGrpSpPr>
+        <p:cNvPr id="1" name=""/>
+        <p:cNvGrpSpPr/>
+        <p:nvPr/>
+      </p:nvGrpSpPr>
+      <p:grpSpPr/>
+      <p:sp>
+        <p:nvSpPr>
+          <p:cNvPr id="2" name="Rectangle 1"/>
+          <p:cNvSpPr/>
+          <p:nvPr/>
+        </p:nvSpPr>
+        <p:spPr>
+          <a:xfrm>
+            <a:off x="0" y="0"/>
+            <a:ext cx="12191695" cy="6858000"/>
+          </a:xfrm>
+          <a:prstGeom prst="rect">
+            <a:avLst/>
+          </a:prstGeom>
+          <a:solidFill>
             <a:srgbClr val="0F172A"/>
           </a:solidFill>
           <a:ln>
@@ -6400,7 +7125,7 @@
           <a:p>
             <a:pPr>
               <a:spcBef>
-                <a:spcPts val="900"/>
+                <a:spcPts val="800"/>
               </a:spcBef>
               <a:defRPr sz="1150">
                 <a:solidFill>
@@ -6415,7 +7140,7 @@
           <a:p>
             <a:pPr>
               <a:spcBef>
-                <a:spcPts val="900"/>
+                <a:spcPts val="800"/>
               </a:spcBef>
               <a:defRPr sz="1150">
                 <a:solidFill>
@@ -6424,13 +7149,43 @@
               </a:defRPr>
             </a:pPr>
             <a:r>
+              <a:t>- Quantitative Staging: Real-time % infected leaf surface area calculation (USDA Stages 1-4).</a:t>
+            </a:r>
+          </a:p>
+          <a:p>
+            <a:pPr>
+              <a:spcBef>
+                <a:spcPts val="800"/>
+              </a:spcBef>
+              <a:defRPr sz="1150">
+                <a:solidFill>
+                  <a:srgbClr val="E2E8F0"/>
+                </a:solidFill>
+              </a:defRPr>
+            </a:pPr>
+            <a:r>
+              <a:t>- Crisp Mathematical Formulations: Embedded LaTeX equations for attention and staging.</a:t>
+            </a:r>
+          </a:p>
+          <a:p>
+            <a:pPr>
+              <a:spcBef>
+                <a:spcPts val="800"/>
+              </a:spcBef>
+              <a:defRPr sz="1150">
+                <a:solidFill>
+                  <a:srgbClr val="E2E8F0"/>
+                </a:solidFill>
+              </a:defRPr>
+            </a:pPr>
+            <a:r>
               <a:t>- Empirical Baselines: Proven 30% FLOPs reduction and 52% parameter reduction vs ResNet-50.</a:t>
             </a:r>
           </a:p>
           <a:p>
             <a:pPr>
               <a:spcBef>
-                <a:spcPts val="900"/>
+                <a:spcPts val="800"/>
               </a:spcBef>
               <a:defRPr sz="1150">
                 <a:solidFill>
@@ -6445,7 +7200,7 @@
           <a:p>
             <a:pPr>
               <a:spcBef>
-                <a:spcPts val="900"/>
+                <a:spcPts val="800"/>
               </a:spcBef>
               <a:defRPr sz="1150">
                 <a:solidFill>
@@ -6455,21 +7210,6 @@
             </a:pPr>
             <a:r>
               <a:t>- Two-Stage Pipeline: Computer vision gatekeeper eliminating closed-world false positives.</a:t>
-            </a:r>
-          </a:p>
-          <a:p>
-            <a:pPr>
-              <a:spcBef>
-                <a:spcPts val="900"/>
-              </a:spcBef>
-              <a:defRPr sz="1150">
-                <a:solidFill>
-                  <a:srgbClr val="E2E8F0"/>
-                </a:solidFill>
-              </a:defRPr>
-            </a:pPr>
-            <a:r>
-              <a:t>- Full Practicality: Live camera capture, Grad-CAM XAI, and downloadable PDF prescriptions.</a:t>
             </a:r>
           </a:p>
         </p:txBody>
@@ -7093,7 +7833,7 @@
             </a:r>
             <a:br/>
             <a:r>
-              <a:t>(Prescription Engine)</a:t>
+              <a:t>(Quantitative Staging &amp; Rx)</a:t>
             </a:r>
           </a:p>
           <a:p>
@@ -7117,20 +7857,20 @@
             <a:br/>
             <a:br/>
             <a:r>
-              <a:t>• Dual-Track Prescriptions:</a:t>
+              <a:t>• Quantitative Disease Severity Staging:</a:t>
             </a:r>
             <a:br/>
             <a:r>
-              <a:t>Provides immediate Organic &amp; Biological solutions (Neem oil, Bacillus subtilis, canopy aeration) alongside Chemical controls (Mancozeb, Chlorothalonil).</a:t>
+              <a:t>Calculates % infected leaf surface area and maps to official USDA Stages (Mild, Moderate, Severe, Critical).</a:t>
             </a:r>
             <a:br/>
             <a:br/>
             <a:r>
-              <a:t>• One-Click Diagnostic PDF Reports:</a:t>
+              <a:t>• Dual-Track Prescriptions &amp; PDF Reports:</a:t>
             </a:r>
             <a:br/>
             <a:r>
-              <a:t>Automated print-ready field reports.</a:t>
+              <a:t>Immediate Organic &amp; Chemical recommendations with downloadable print-ready field reports.</a:t>
             </a:r>
           </a:p>
         </p:txBody>
@@ -9647,7 +10387,7 @@
               </a:defRPr>
             </a:pPr>
             <a:r>
-              <a:t>ARCHITECTURAL NOVELTY</a:t>
+              <a:t>ARCHITECTURAL INNOVATION</a:t>
             </a:r>
           </a:p>
         </p:txBody>
@@ -9682,7 +10422,7 @@
               </a:defRPr>
             </a:pPr>
             <a:r>
-              <a:t>Dual-Attention Hybrid: EfficientNetV2-CBAM Lesion Localization</a:t>
+              <a:t>Dual-Attention Equations: Mathematical Formulation of CBAM</a:t>
             </a:r>
           </a:p>
         </p:txBody>
@@ -9740,8 +10480,8 @@
         </p:nvSpPr>
         <p:spPr>
           <a:xfrm>
-            <a:off x="960120" y="1600200"/>
-            <a:ext cx="2971800" cy="4389120"/>
+            <a:off x="914400" y="1536192"/>
+            <a:ext cx="3063240" cy="548640"/>
           </a:xfrm>
           <a:prstGeom prst="rect">
             <a:avLst/>
@@ -9755,7 +10495,7 @@
           <a:lstStyle/>
           <a:p>
             <a:pPr>
-              <a:defRPr sz="1400" b="1">
+              <a:defRPr sz="1300" b="1">
                 <a:solidFill>
                   <a:srgbClr val="059669"/>
                 </a:solidFill>
@@ -9765,10 +10505,57 @@
               <a:t>1. Channel Attention: Mc(F)</a:t>
             </a:r>
           </a:p>
-          <a:p>
-            <a:pPr>
-              <a:spcBef>
-                <a:spcPts val="1200"/>
+        </p:txBody>
+      </p:sp>
+      <p:pic>
+        <p:nvPicPr>
+          <p:cNvPr id="7" name="Picture 6" descr="eq_channel_attention.png"/>
+          <p:cNvPicPr>
+            <a:picLocks noChangeAspect="1"/>
+          </p:cNvPicPr>
+          <p:nvPr/>
+        </p:nvPicPr>
+        <p:blipFill>
+          <a:blip r:embed="rId2"/>
+          <a:stretch>
+            <a:fillRect/>
+          </a:stretch>
+        </p:blipFill>
+        <p:spPr>
+          <a:xfrm>
+            <a:off x="868680" y="2148840"/>
+            <a:ext cx="3154680" cy="572457"/>
+          </a:xfrm>
+          <a:prstGeom prst="rect">
+            <a:avLst/>
+          </a:prstGeom>
+        </p:spPr>
+      </p:pic>
+      <p:sp>
+        <p:nvSpPr>
+          <p:cNvPr id="8" name="TextBox 7"/>
+          <p:cNvSpPr txBox="1"/>
+          <p:nvPr/>
+        </p:nvSpPr>
+        <p:spPr>
+          <a:xfrm>
+            <a:off x="914400" y="3108960"/>
+            <a:ext cx="3063240" cy="2926080"/>
+          </a:xfrm>
+          <a:prstGeom prst="rect">
+            <a:avLst/>
+          </a:prstGeom>
+          <a:noFill/>
+        </p:spPr>
+        <p:txBody>
+          <a:bodyPr wrap="square">
+            <a:spAutoFit/>
+          </a:bodyPr>
+          <a:lstStyle/>
+          <a:p>
+            <a:pPr>
+              <a:spcBef>
+                <a:spcPts val="400"/>
               </a:spcBef>
               <a:defRPr sz="1000">
                 <a:solidFill>
@@ -9777,27 +10564,14 @@
               </a:defRPr>
             </a:pPr>
             <a:r>
-              <a:t>Mathematical Formulation:</a:t>
-            </a:r>
-            <a:br/>
-            <a:r>
-              <a:t>Mc(F) = σ(MLP(AvgPool(F)) + MLP(MaxPool(F)))</a:t>
-            </a:r>
-            <a:br/>
-            <a:br/>
-            <a:r>
-              <a:t>Mechanism &amp; Purpose:</a:t>
-            </a:r>
-            <a:br/>
-            <a:r>
-              <a:t>Squeezes spatial dimensions to compute a 1D attention vector across all 1,280 channels. Dynamically amplifies feature channels responsive to fungal mycelium, rust spores, and bacterial water-soaking while suppressing background noise.</a:t>
-            </a:r>
-          </a:p>
-        </p:txBody>
-      </p:sp>
-      <p:sp>
-        <p:nvSpPr>
-          <p:cNvPr id="7" name="Rounded Rectangle 6"/>
+              <a:t>Squeezes spatial dimensions via both Average and Max pooling to generate a 1D channel attention vector. Dynamically amplifies feature channels responsive to fungal mycelium, rust spores, and bacterial water-soaking while suppressing background noise.</a:t>
+            </a:r>
+          </a:p>
+        </p:txBody>
+      </p:sp>
+      <p:sp>
+        <p:nvSpPr>
+          <p:cNvPr id="9" name="Rounded Rectangle 8"/>
           <p:cNvSpPr/>
           <p:nvPr/>
         </p:nvSpPr>
@@ -9842,14 +10616,14 @@
       </p:sp>
       <p:sp>
         <p:nvSpPr>
-          <p:cNvPr id="8" name="TextBox 7"/>
+          <p:cNvPr id="10" name="TextBox 9"/>
           <p:cNvSpPr txBox="1"/>
           <p:nvPr/>
         </p:nvSpPr>
         <p:spPr>
           <a:xfrm>
-            <a:off x="4572000" y="1600200"/>
-            <a:ext cx="2971800" cy="4389120"/>
+            <a:off x="4526280" y="1536192"/>
+            <a:ext cx="3063240" cy="548640"/>
           </a:xfrm>
           <a:prstGeom prst="rect">
             <a:avLst/>
@@ -9863,7 +10637,7 @@
           <a:lstStyle/>
           <a:p>
             <a:pPr>
-              <a:defRPr sz="1400" b="1">
+              <a:defRPr sz="1300" b="1">
                 <a:solidFill>
                   <a:srgbClr val="2563EB"/>
                 </a:solidFill>
@@ -9873,10 +10647,57 @@
               <a:t>2. Spatial Attention: Ms(F)</a:t>
             </a:r>
           </a:p>
-          <a:p>
-            <a:pPr>
-              <a:spcBef>
-                <a:spcPts val="1200"/>
+        </p:txBody>
+      </p:sp>
+      <p:pic>
+        <p:nvPicPr>
+          <p:cNvPr id="11" name="Picture 10" descr="eq_spatial_attention.png"/>
+          <p:cNvPicPr>
+            <a:picLocks noChangeAspect="1"/>
+          </p:cNvPicPr>
+          <p:nvPr/>
+        </p:nvPicPr>
+        <p:blipFill>
+          <a:blip r:embed="rId3"/>
+          <a:stretch>
+            <a:fillRect/>
+          </a:stretch>
+        </p:blipFill>
+        <p:spPr>
+          <a:xfrm>
+            <a:off x="4480560" y="2148840"/>
+            <a:ext cx="3154680" cy="595395"/>
+          </a:xfrm>
+          <a:prstGeom prst="rect">
+            <a:avLst/>
+          </a:prstGeom>
+        </p:spPr>
+      </p:pic>
+      <p:sp>
+        <p:nvSpPr>
+          <p:cNvPr id="12" name="TextBox 11"/>
+          <p:cNvSpPr txBox="1"/>
+          <p:nvPr/>
+        </p:nvSpPr>
+        <p:spPr>
+          <a:xfrm>
+            <a:off x="4526280" y="3108960"/>
+            <a:ext cx="3063240" cy="2926080"/>
+          </a:xfrm>
+          <a:prstGeom prst="rect">
+            <a:avLst/>
+          </a:prstGeom>
+          <a:noFill/>
+        </p:spPr>
+        <p:txBody>
+          <a:bodyPr wrap="square">
+            <a:spAutoFit/>
+          </a:bodyPr>
+          <a:lstStyle/>
+          <a:p>
+            <a:pPr>
+              <a:spcBef>
+                <a:spcPts val="400"/>
               </a:spcBef>
               <a:defRPr sz="1000">
                 <a:solidFill>
@@ -9885,19 +10706,6 @@
               </a:defRPr>
             </a:pPr>
             <a:r>
-              <a:t>Mathematical Formulation:</a:t>
-            </a:r>
-            <a:br/>
-            <a:r>
-              <a:t>Ms(F) = σ(f7x7([AvgPool(F); MaxPool(F)]))</a:t>
-            </a:r>
-            <a:br/>
-            <a:br/>
-            <a:r>
-              <a:t>Mechanism &amp; Purpose:</a:t>
-            </a:r>
-            <a:br/>
-            <a:r>
               <a:t>Applies inter-channel pooling followed by a 7x7 spatial convolution to produce a 2D lesion probability mask. Forces the network to calculate 2D spatial attention weights over irregular necrotic lesions, rust pustules, and fungal halos rather than background leaf wax.</a:t>
             </a:r>
           </a:p>
@@ -9905,7 +10713,7 @@
       </p:sp>
       <p:sp>
         <p:nvSpPr>
-          <p:cNvPr id="9" name="Rounded Rectangle 8"/>
+          <p:cNvPr id="13" name="Rounded Rectangle 12"/>
           <p:cNvSpPr/>
           <p:nvPr/>
         </p:nvSpPr>
@@ -9950,14 +10758,14 @@
       </p:sp>
       <p:sp>
         <p:nvSpPr>
-          <p:cNvPr id="10" name="TextBox 9"/>
+          <p:cNvPr id="14" name="TextBox 13"/>
           <p:cNvSpPr txBox="1"/>
           <p:nvPr/>
         </p:nvSpPr>
         <p:spPr>
           <a:xfrm>
-            <a:off x="8183880" y="1600200"/>
-            <a:ext cx="2971800" cy="4389120"/>
+            <a:off x="8138160" y="1536192"/>
+            <a:ext cx="3063240" cy="548640"/>
           </a:xfrm>
           <a:prstGeom prst="rect">
             <a:avLst/>
@@ -9971,20 +10779,67 @@
           <a:lstStyle/>
           <a:p>
             <a:pPr>
-              <a:defRPr sz="1400" b="1">
+              <a:defRPr sz="1300" b="1">
                 <a:solidFill>
                   <a:srgbClr val="8B5CF6"/>
                 </a:solidFill>
               </a:defRPr>
             </a:pPr>
             <a:r>
-              <a:t>3. Residual Integration: F'' + F</a:t>
-            </a:r>
-          </a:p>
-          <a:p>
-            <a:pPr>
-              <a:spcBef>
-                <a:spcPts val="1200"/>
+              <a:t>3. Residual Integration: Y = F + F''</a:t>
+            </a:r>
+          </a:p>
+        </p:txBody>
+      </p:sp>
+      <p:pic>
+        <p:nvPicPr>
+          <p:cNvPr id="15" name="Picture 14" descr="eq_cbam_fusion.png"/>
+          <p:cNvPicPr>
+            <a:picLocks noChangeAspect="1"/>
+          </p:cNvPicPr>
+          <p:nvPr/>
+        </p:nvPicPr>
+        <p:blipFill>
+          <a:blip r:embed="rId4"/>
+          <a:stretch>
+            <a:fillRect/>
+          </a:stretch>
+        </p:blipFill>
+        <p:spPr>
+          <a:xfrm>
+            <a:off x="8092440" y="2148840"/>
+            <a:ext cx="3154680" cy="506557"/>
+          </a:xfrm>
+          <a:prstGeom prst="rect">
+            <a:avLst/>
+          </a:prstGeom>
+        </p:spPr>
+      </p:pic>
+      <p:sp>
+        <p:nvSpPr>
+          <p:cNvPr id="16" name="TextBox 15"/>
+          <p:cNvSpPr txBox="1"/>
+          <p:nvPr/>
+        </p:nvSpPr>
+        <p:spPr>
+          <a:xfrm>
+            <a:off x="8138160" y="3108960"/>
+            <a:ext cx="3063240" cy="2926080"/>
+          </a:xfrm>
+          <a:prstGeom prst="rect">
+            <a:avLst/>
+          </a:prstGeom>
+          <a:noFill/>
+        </p:spPr>
+        <p:txBody>
+          <a:bodyPr wrap="square">
+            <a:spAutoFit/>
+          </a:bodyPr>
+          <a:lstStyle/>
+          <a:p>
+            <a:pPr>
+              <a:spcBef>
+                <a:spcPts val="400"/>
               </a:spcBef>
               <a:defRPr sz="1000">
                 <a:solidFill>
@@ -9993,24 +10848,7 @@
               </a:defRPr>
             </a:pPr>
             <a:r>
-              <a:t>End-to-End Synergy:</a:t>
-            </a:r>
-            <a:br/>
-            <a:r>
-              <a:t>F' = Mc(F) ⊗ F</a:t>
-            </a:r>
-            <a:br/>
-            <a:r>
-              <a:t>F'' = Ms(F') ⊗ F'</a:t>
-            </a:r>
-            <a:br/>
-            <a:r>
-              <a:t>Output = F + F''</a:t>
-            </a:r>
-            <a:br/>
-            <a:br/>
-            <a:r>
-              <a:t>By maintaining a residual connection, the network retains general botanical features while selectively boosting fine-grained pathological anomalies.</a:t>
+              <a:t>Sequentially applies Channel Attention then Spatial Attention with an identity residual bypass. Preserves global botanical structures while boosting fine-grained lesion boundaries with zero feature degradation.</a:t>
             </a:r>
           </a:p>
         </p:txBody>
@@ -11338,7 +12176,7 @@
         </p:nvSpPr>
         <p:spPr>
           <a:xfrm>
-            <a:off x="1005840" y="1554480"/>
+            <a:off x="1005840" y="1536192"/>
             <a:ext cx="4663440" cy="1828800"/>
           </a:xfrm>
           <a:prstGeom prst="rect">
@@ -11366,7 +12204,7 @@
           <a:p>
             <a:pPr>
               <a:spcBef>
-                <a:spcPts val="400"/>
+                <a:spcPts val="300"/>
               </a:spcBef>
               <a:defRPr sz="1000">
                 <a:solidFill>
@@ -11448,7 +12286,7 @@
         </p:nvSpPr>
         <p:spPr>
           <a:xfrm>
-            <a:off x="6400800" y="1554480"/>
+            <a:off x="6400800" y="1536192"/>
             <a:ext cx="4663440" cy="1828800"/>
           </a:xfrm>
           <a:prstGeom prst="rect">
@@ -11476,7 +12314,7 @@
           <a:p>
             <a:pPr>
               <a:spcBef>
-                <a:spcPts val="400"/>
+                <a:spcPts val="300"/>
               </a:spcBef>
               <a:defRPr sz="1000">
                 <a:solidFill>
@@ -11558,7 +12396,7 @@
         </p:nvSpPr>
         <p:spPr>
           <a:xfrm>
-            <a:off x="1005840" y="4023360"/>
+            <a:off x="1005840" y="4005072"/>
             <a:ext cx="4663440" cy="1828800"/>
           </a:xfrm>
           <a:prstGeom prst="rect">
@@ -11586,7 +12424,7 @@
           <a:p>
             <a:pPr>
               <a:spcBef>
-                <a:spcPts val="400"/>
+                <a:spcPts val="300"/>
               </a:spcBef>
               <a:defRPr sz="1000">
                 <a:solidFill>
@@ -11595,13 +12433,13 @@
               </a:defRPr>
             </a:pPr>
             <a:r>
-              <a:t>Softened hard ground-truth targets (1.0 -&gt; 0.9) with smoothing factor = 0.1.</a:t>
-            </a:r>
-          </a:p>
-          <a:p>
-            <a:pPr>
-              <a:spcBef>
-                <a:spcPts val="600"/>
+              <a:t>Softened hard ground-truth targets with smoothing factor ε = 0.1:</a:t>
+            </a:r>
+          </a:p>
+          <a:p>
+            <a:pPr>
+              <a:spcBef>
+                <a:spcPts val="2800"/>
               </a:spcBef>
               <a:defRPr sz="1000" b="1">
                 <a:solidFill>
@@ -11610,14 +12448,38 @@
               </a:defRPr>
             </a:pPr>
             <a:r>
-              <a:t>Impact: Directly prevents the network from becoming overconfident, dramatically boosting test generalization.</a:t>
-            </a:r>
-          </a:p>
-        </p:txBody>
-      </p:sp>
-      <p:sp>
-        <p:nvSpPr>
-          <p:cNvPr id="11" name="Rounded Rectangle 10"/>
+              <a:t>Impact: Directly prevents the network from becoming overconfident on clean studio backgrounds.</a:t>
+            </a:r>
+          </a:p>
+        </p:txBody>
+      </p:sp>
+      <p:pic>
+        <p:nvPicPr>
+          <p:cNvPr id="11" name="Picture 10" descr="eq_label_smoothing.png"/>
+          <p:cNvPicPr>
+            <a:picLocks noChangeAspect="1"/>
+          </p:cNvPicPr>
+          <p:nvPr/>
+        </p:nvPicPr>
+        <p:blipFill>
+          <a:blip r:embed="rId2"/>
+          <a:stretch>
+            <a:fillRect/>
+          </a:stretch>
+        </p:blipFill>
+        <p:spPr>
+          <a:xfrm>
+            <a:off x="1005840" y="4800600"/>
+            <a:ext cx="4114800" cy="741892"/>
+          </a:xfrm>
+          <a:prstGeom prst="rect">
+            <a:avLst/>
+          </a:prstGeom>
+        </p:spPr>
+      </p:pic>
+      <p:sp>
+        <p:nvSpPr>
+          <p:cNvPr id="12" name="Rounded Rectangle 11"/>
           <p:cNvSpPr/>
           <p:nvPr/>
         </p:nvSpPr>
@@ -11662,13 +12524,13 @@
       </p:sp>
       <p:sp>
         <p:nvSpPr>
-          <p:cNvPr id="12" name="TextBox 11"/>
+          <p:cNvPr id="13" name="TextBox 12"/>
           <p:cNvSpPr txBox="1"/>
           <p:nvPr/>
         </p:nvSpPr>
         <p:spPr>
           <a:xfrm>
-            <a:off x="6400800" y="4023360"/>
+            <a:off x="6400800" y="4005072"/>
             <a:ext cx="4663440" cy="1828800"/>
           </a:xfrm>
           <a:prstGeom prst="rect">
@@ -11696,7 +12558,7 @@
           <a:p>
             <a:pPr>
               <a:spcBef>
-                <a:spcPts val="400"/>
+                <a:spcPts val="300"/>
               </a:spcBef>
               <a:defRPr sz="1000">
                 <a:solidFill>

</xml_diff>